<commit_message>
26 session 1 prep
</commit_message>
<xml_diff>
--- a/Fall_2026/slides/CPBP8306_Session1_Thinking_Like_a_Coder.pptx
+++ b/Fall_2026/slides/CPBP8306_Session1_Thinking_Like_a_Coder.pptx
@@ -1225,36 +1225,34 @@
               <a:t>The activity has moved to homework because the installs took the block. Say that as a plan, not an apology.</a:t>
             </a:r>
           </a:p>
-          <a:p>
-            <a:endParaRPr/>
-          </a:p>
+          <a:p/>
           <a:p>
             <a:r>
               <a:t>Warn them explicitly: the tutor is DESIGNED to refuse to give code. Students who have not been told this get frustrated and rate it badly. Frame the refusal as respect: "it thinks you can get there."</a:t>
             </a:r>
           </a:p>
-          <a:p>
-            <a:endParaRPr/>
-          </a:p>
+          <a:p/>
           <a:p>
             <a:r>
               <a:t>Restate the participation rule: full credit for engaging with the questions, not for reaching a correct answer. Paste the transcript as-is, including anywhere they went in circles.</a:t>
             </a:r>
           </a:p>
-          <a:p>
-            <a:endParaRPr/>
-          </a:p>
+          <a:p/>
           <a:p>
             <a:r>
               <a:t>Tell them the deadline out loud: before Session 2, next Thursday.</a:t>
             </a:r>
           </a:p>
-          <a:p>
-            <a:endParaRPr/>
-          </a:p>
+          <a:p/>
           <a:p>
             <a:r>
               <a:t>Important for the students still broken: only the tutor's first problem needs a working laptop. Everything else is a conversation. They should do it regardless.</a:t>
+            </a:r>
+          </a:p>
+          <a:p/>
+          <a:p>
+            <a:r>
+              <a:t>The URL on the slide is the live tutor, but do not make anyone type it — send them to the Brightspace link. It is on the slide so that a student who photographs this slide has a way back to it.</a:t>
             </a:r>
           </a:p>
         </p:txBody>
@@ -12116,7 +12114,7 @@
         <p:spPr>
           <a:xfrm>
             <a:off x="566928" y="5815584"/>
-            <a:ext cx="11057839" cy="329184"/>
+            <a:ext cx="11057839" cy="566928"/>
           </a:xfrm>
           <a:prstGeom prst="rect">
             <a:avLst/>
@@ -12140,7 +12138,24 @@
                 <a:ea typeface="Calibri" pitchFamily="34" charset="-122"/>
                 <a:cs typeface="Calibri" pitchFamily="34" charset="-120"/>
               </a:rPr>
-              <a:t>Link on Brightspace. Start it once your install is finished — but if the install beats you, do the tutor anyway. Only its first problem needs a working laptop.</a:t>
+              <a:t>Link on Brightspace — or go straight there: chatgpt.com/g/g-6a8f87ff4fc88191beb3a40405c0f2e3-cpbp-8306-tutor-session-1-thinking-like-a-coder</a:t>
+            </a:r>
+            <a:endParaRPr lang="en-US" sz="1250" dirty="0"/>
+          </a:p>
+          <a:p>
+            <a:pPr marL="0" indent="0">
+              <a:buNone/>
+            </a:pPr>
+            <a:r>
+              <a:rPr lang="en-US" sz="1250" i="1" dirty="0">
+                <a:solidFill>
+                  <a:srgbClr val="7A7A7A"/>
+                </a:solidFill>
+                <a:latin typeface="Calibri" pitchFamily="34" charset="0"/>
+                <a:ea typeface="Calibri" pitchFamily="34" charset="-122"/>
+                <a:cs typeface="Calibri" pitchFamily="34" charset="-120"/>
+              </a:rPr>
+              <a:t>Do the tutor even if your install is not finished. Only its first problem needs a working laptop.</a:t>
             </a:r>
             <a:endParaRPr lang="en-US" sz="1250" dirty="0"/>
           </a:p>

</xml_diff>

<commit_message>
2026 session 2 content
</commit_message>
<xml_diff>
--- a/Fall_2026/slides/CPBP8306_Session1_Thinking_Like_a_Coder.pptx
+++ b/Fall_2026/slides/CPBP8306_Session1_Thinking_Like_a_Coder.pptx
@@ -9,6 +9,7 @@
   </p:notesMasterIdLst>
   <p:sldIdLst>
     <p:sldId id="256" r:id="rId2"/>
+    <p:sldId id="277" r:id="rId27"/>
     <p:sldId id="257" r:id="rId3"/>
     <p:sldId id="258" r:id="rId4"/>
     <p:sldId id="259" r:id="rId5"/>
@@ -1581,6 +1582,111 @@
         <p14:creationId xmlns:p14="http://schemas.microsoft.com/office/powerpoint/2010/main" val="1024086991"/>
       </p:ext>
     </p:extLst>
+  </p:cSld>
+  <p:clrMapOvr>
+    <a:masterClrMapping/>
+  </p:clrMapOvr>
+</p:notes>
+</file>
+
+<file path=ppt/notesSlides/notesSlide21.xml><?xml version="1.0" encoding="utf-8"?>
+<p:notes xmlns:a="http://schemas.openxmlformats.org/drawingml/2006/main" xmlns:p="http://schemas.openxmlformats.org/presentationml/2006/main" xmlns:r="http://schemas.openxmlformats.org/officeDocument/2006/relationships">
+  <p:cSld>
+    <p:spTree>
+      <p:nvGrpSpPr>
+        <p:cNvPr id="1" name=""/>
+        <p:cNvGrpSpPr/>
+        <p:nvPr/>
+      </p:nvGrpSpPr>
+      <p:grpSpPr>
+        <a:xfrm>
+          <a:off x="0" y="0"/>
+          <a:ext cx="0" cy="0"/>
+          <a:chOff x="0" y="0"/>
+          <a:chExt cx="0" cy="0"/>
+        </a:xfrm>
+      </p:grpSpPr>
+      <p:sp>
+        <p:nvSpPr>
+          <p:cNvPr id="2" name="Slide Image Placeholder 1"/>
+          <p:cNvSpPr>
+            <a:spLocks noGrp="1" noRot="1" noChangeAspect="1"/>
+          </p:cNvSpPr>
+          <p:nvPr>
+            <p:ph type="sldImg"/>
+          </p:nvPr>
+        </p:nvSpPr>
+        <p:spPr/>
+      </p:sp>
+      <p:sp>
+        <p:nvSpPr>
+          <p:cNvPr id="3" name="Notes Placeholder 2"/>
+          <p:cNvSpPr>
+            <a:spLocks noGrp="1"/>
+          </p:cNvSpPr>
+          <p:nvPr>
+            <p:ph type="body" idx="1"/>
+          </p:nvPr>
+        </p:nvSpPr>
+        <p:spPr/>
+        <p:txBody>
+          <a:bodyPr/>
+          <a:lstStyle/>
+          <a:p>
+            <a:r>
+              <a:t>Do this first, while people are still settling in and getting laptops open — it costs almost nothing if it overlaps with attendance.</a:t>
+            </a:r>
+          </a:p>
+          <a:p/>
+          <a:p>
+            <a:r>
+              <a:t>Say the three things that get people to actually submit it: two minutes, phone is fine, graded on completion. Then say the honest version — we are measuring whether the course works, and a low-confidence answer today is the most useful kind.</a:t>
+            </a:r>
+          </a:p>
+          <a:p/>
+          <a:p>
+            <a:r>
+              <a:t>Put the URL up and leave it up while you take attendance. Do not read it aloud character by character; it is also on Brightspace.</a:t>
+            </a:r>
+          </a:p>
+          <a:p/>
+          <a:p>
+            <a:r>
+              <a:t>Most students finish in under 90 seconds. If the room is done early, take the time back — it goes straight into the install block later, which is where you will want it.</a:t>
+            </a:r>
+          </a:p>
+          <a:p/>
+          <a:p>
+            <a:r>
+              <a:t>Anyone without a device can do it tonight. Do not stall the session for it.</a:t>
+            </a:r>
+          </a:p>
+        </p:txBody>
+      </p:sp>
+      <p:sp>
+        <p:nvSpPr>
+          <p:cNvPr id="4" name="Slide Number Placeholder 3"/>
+          <p:cNvSpPr>
+            <a:spLocks noGrp="1"/>
+          </p:cNvSpPr>
+          <p:nvPr>
+            <p:ph type="sldNum" sz="quarter" idx="10"/>
+          </p:nvPr>
+        </p:nvSpPr>
+        <p:spPr/>
+        <p:txBody>
+          <a:bodyPr/>
+          <a:lstStyle/>
+          <a:p>
+            <a:fld id="{F7021451-1387-4CA6-816F-3879F97B5CBC}" type="slidenum">
+              <a:rPr lang="en-US"/>
+              <a:t>2</a:t>
+            </a:fld>
+            <a:endParaRPr lang="en-US"/>
+          </a:p>
+        </p:txBody>
+      </p:sp>
+    </p:spTree>
   </p:cSld>
   <p:clrMapOvr>
     <a:masterClrMapping/>
@@ -3237,7 +3343,7 @@
                 <a:ea typeface="Arial" pitchFamily="34" charset="-122"/>
                 <a:cs typeface="Arial" pitchFamily="34" charset="-120"/>
               </a:rPr>
-              <a:t>23–27 MIN  ·  INSTALL 2 OF 4</a:t>
+              <a:t>19–24 MIN  ·  INSTALL 1 OF 4</a:t>
             </a:r>
             <a:endParaRPr lang="en-US" sz="1050" dirty="0"/>
           </a:p>
@@ -3276,7 +3382,7 @@
                 <a:ea typeface="Arial" pitchFamily="34" charset="-122"/>
                 <a:cs typeface="Arial" pitchFamily="34" charset="-120"/>
               </a:rPr>
-              <a:t>VS Code — where you type</a:t>
+              <a:t>Python — the engine</a:t>
             </a:r>
             <a:endParaRPr lang="en-US" sz="3300" dirty="0"/>
           </a:p>
@@ -3388,7 +3494,7 @@
                 <a:ea typeface="Arial" pitchFamily="34" charset="-122"/>
                 <a:cs typeface="Arial" pitchFamily="34" charset="-120"/>
               </a:rPr>
-              <a:t>INSTALL IT</a:t>
+              <a:t>WINDOWS</a:t>
             </a:r>
             <a:endParaRPr lang="en-US" sz="1000" dirty="0"/>
           </a:p>
@@ -3434,7 +3540,7 @@
                 <a:ea typeface="Calibri" pitchFamily="34" charset="-122"/>
                 <a:cs typeface="Calibri" pitchFamily="34" charset="-120"/>
               </a:rPr>
-              <a:t>Run the installer and accept the defaults.</a:t>
+              <a:t>Run the installer you downloaded.</a:t>
             </a:r>
             <a:endParaRPr lang="en-US" sz="1250" dirty="0"/>
           </a:p>
@@ -3458,7 +3564,7 @@
                 <a:ea typeface="Calibri" pitchFamily="34" charset="-122"/>
                 <a:cs typeface="Calibri" pitchFamily="34" charset="-120"/>
               </a:rPr>
-              <a:t>On Windows leave every checkbox ticked, especially “Add to PATH.”</a:t>
+              <a:t>STOP on the first screen. Tick “Add python.exe to PATH” at the bottom.</a:t>
             </a:r>
             <a:endParaRPr lang="en-US" sz="1250" dirty="0"/>
           </a:p>
@@ -3482,7 +3588,7 @@
                 <a:ea typeface="Calibri" pitchFamily="34" charset="-122"/>
                 <a:cs typeface="Calibri" pitchFamily="34" charset="-120"/>
               </a:rPr>
-              <a:t>Open it. You will get a Welcome tab. Ignore it.</a:t>
+              <a:t>That one checkbox is the most common reason Session 2 does not work.</a:t>
             </a:r>
             <a:endParaRPr lang="en-US" sz="1250" dirty="0"/>
           </a:p>
@@ -3506,7 +3612,31 @@
                 <a:ea typeface="Calibri" pitchFamily="34" charset="-122"/>
                 <a:cs typeface="Calibri" pitchFamily="34" charset="-120"/>
               </a:rPr>
-              <a:t>It is a text editor. Installing it does not install Python.</a:t>
+              <a:t>Then “Install Now.” Accept everything else.</a:t>
+            </a:r>
+            <a:endParaRPr lang="en-US" sz="1250" dirty="0"/>
+          </a:p>
+          <a:p>
+            <a:pPr marL="203200" indent="-203200">
+              <a:lnSpc>
+                <a:spcPts val="1800"/>
+              </a:lnSpc>
+              <a:spcAft>
+                <a:spcPts val="900"/>
+              </a:spcAft>
+              <a:buSzPct val="100000"/>
+              <a:buChar char="•"/>
+            </a:pPr>
+            <a:r>
+              <a:rPr lang="en-US" sz="1250" dirty="0">
+                <a:solidFill>
+                  <a:srgbClr val="3A3A3A"/>
+                </a:solidFill>
+                <a:latin typeface="Calibri" pitchFamily="34" charset="0"/>
+                <a:ea typeface="Calibri" pitchFamily="34" charset="-122"/>
+                <a:cs typeface="Calibri" pitchFamily="34" charset="-120"/>
+              </a:rPr>
+              <a:t>Check it: Command Prompt, type  python --version  — any 3.11 or newer is fine.</a:t>
             </a:r>
             <a:endParaRPr lang="en-US" sz="1250" dirty="0"/>
           </a:p>
@@ -3579,7 +3709,7 @@
                 <a:ea typeface="Arial" pitchFamily="34" charset="-122"/>
                 <a:cs typeface="Arial" pitchFamily="34" charset="-120"/>
               </a:rPr>
-              <a:t>THEN ADD TWO EXTENSIONS</a:t>
+              <a:t>MACOS</a:t>
             </a:r>
             <a:endParaRPr lang="en-US" sz="1000" dirty="0"/>
           </a:p>
@@ -3625,7 +3755,7 @@
                 <a:ea typeface="Calibri" pitchFamily="34" charset="-122"/>
                 <a:cs typeface="Calibri" pitchFamily="34" charset="-120"/>
               </a:rPr>
-              <a:t>Click the Extensions icon in the left bar — the four squares.</a:t>
+              <a:t>Open the .pkg you downloaded.</a:t>
             </a:r>
             <a:endParaRPr lang="en-US" sz="1250" dirty="0"/>
           </a:p>
@@ -3649,7 +3779,7 @@
                 <a:ea typeface="Calibri" pitchFamily="34" charset="-122"/>
                 <a:cs typeface="Calibri" pitchFamily="34" charset="-120"/>
               </a:rPr>
-              <a:t>Search Python. Install the one published by Microsoft.</a:t>
+              <a:t>Continue, Agree, Install. There are no choices to make.</a:t>
             </a:r>
             <a:endParaRPr lang="en-US" sz="1250" dirty="0"/>
           </a:p>
@@ -3673,7 +3803,7 @@
                 <a:ea typeface="Calibri" pitchFamily="34" charset="-122"/>
                 <a:cs typeface="Calibri" pitchFamily="34" charset="-120"/>
               </a:rPr>
-              <a:t>Search Jupyter. Install that one too, also by Microsoft.</a:t>
+              <a:t>Enter your Mac password when it asks.</a:t>
             </a:r>
             <a:endParaRPr lang="en-US" sz="1250" dirty="0"/>
           </a:p>
@@ -3697,7 +3827,31 @@
                 <a:ea typeface="Calibri" pitchFamily="34" charset="-122"/>
                 <a:cs typeface="Calibri" pitchFamily="34" charset="-120"/>
               </a:rPr>
-              <a:t>Nothing else today. Extensions are a rabbit hole.</a:t>
+              <a:t>Check it: open Terminal and type  python3 --version</a:t>
+            </a:r>
+            <a:endParaRPr lang="en-US" sz="1250" dirty="0"/>
+          </a:p>
+          <a:p>
+            <a:pPr marL="203200" indent="-203200">
+              <a:lnSpc>
+                <a:spcPts val="1800"/>
+              </a:lnSpc>
+              <a:spcAft>
+                <a:spcPts val="900"/>
+              </a:spcAft>
+              <a:buSzPct val="100000"/>
+              <a:buChar char="•"/>
+            </a:pPr>
+            <a:r>
+              <a:rPr lang="en-US" sz="1250" dirty="0">
+                <a:solidFill>
+                  <a:srgbClr val="3A3A3A"/>
+                </a:solidFill>
+                <a:latin typeface="Calibri" pitchFamily="34" charset="0"/>
+                <a:ea typeface="Calibri" pitchFamily="34" charset="-122"/>
+                <a:cs typeface="Calibri" pitchFamily="34" charset="-120"/>
+              </a:rPr>
+              <a:t>On a Mac it is python3, not python. Both are normal.</a:t>
             </a:r>
             <a:endParaRPr lang="en-US" sz="1250" dirty="0"/>
           </a:p>
@@ -3736,7 +3890,7 @@
                 <a:ea typeface="Arial" pitchFamily="34" charset="-122"/>
                 <a:cs typeface="Arial" pitchFamily="34" charset="-120"/>
               </a:rPr>
-              <a:t>WATCH OUT FOR</a:t>
+              <a:t>WHEN IT GOES WRONG — AND WHAT IT MEANS</a:t>
             </a:r>
             <a:endParaRPr lang="en-US" sz="1000" dirty="0"/>
           </a:p>
@@ -3814,7 +3968,7 @@
                 <a:ea typeface="Calibri" pitchFamily="34" charset="-122"/>
                 <a:cs typeface="Calibri" pitchFamily="34" charset="-120"/>
               </a:rPr>
-              <a:t>A Python extension that is not Microsoft’s — check the publisher line.</a:t>
+              <a:t>“python is not recognized” — the PATH box was missed. Re-run the installer and tick it.</a:t>
             </a:r>
             <a:endParaRPr lang="en-US" sz="1250" dirty="0"/>
           </a:p>
@@ -3892,7 +4046,7 @@
                 <a:ea typeface="Calibri" pitchFamily="34" charset="-122"/>
                 <a:cs typeface="Calibri" pitchFamily="34" charset="-120"/>
               </a:rPr>
-              <a:t>A “Select Interpreter” prompt — pick the 3.1x you just installed.</a:t>
+              <a:t>The Microsoft Store opens instead — same cause, same fix.</a:t>
             </a:r>
             <a:endParaRPr lang="en-US" sz="1250" dirty="0"/>
           </a:p>
@@ -3970,7 +4124,7 @@
                 <a:ea typeface="Calibri" pitchFamily="34" charset="-122"/>
                 <a:cs typeface="Calibri" pitchFamily="34" charset="-120"/>
               </a:rPr>
-              <a:t>Do not install Copilot yet. It needs a GitHub account — that is homework.</a:t>
+              <a:t>“command not found” on a Mac — you typed python. Try python3.</a:t>
             </a:r>
             <a:endParaRPr lang="en-US" sz="1250" dirty="0"/>
           </a:p>
@@ -4048,7 +4202,7 @@
                 <a:ea typeface="Calibri" pitchFamily="34" charset="-122"/>
                 <a:cs typeface="Calibri" pitchFamily="34" charset="-120"/>
               </a:rPr>
-              <a:t>Installing the wrong search result — Microsoft’s has millions of downloads.</a:t>
+              <a:t>Python 2.7 prints on an older Mac — that is the built-in one, not yours. Use python3.</a:t>
             </a:r>
             <a:endParaRPr lang="en-US" sz="1250" dirty="0"/>
           </a:p>
@@ -4087,7 +4241,7 @@
                 <a:ea typeface="Calibri" pitchFamily="34" charset="-122"/>
                 <a:cs typeface="Calibri" pitchFamily="34" charset="-120"/>
               </a:rPr>
-              <a:t>VS Code is the smallest of the four. If yours is done early, help the person next to you — genuinely, that is the fastest way through this.</a:t>
+              <a:t>Hand up the moment your screen differs from this. Do not go quiet and fall behind — that is how people leave today without a working laptop.</a:t>
             </a:r>
             <a:endParaRPr lang="en-US" sz="1250" dirty="0"/>
           </a:p>
@@ -4151,7 +4305,7 @@
         <p:spPr>
           <a:xfrm>
             <a:off x="566928" y="329184"/>
-            <a:ext cx="3008372" cy="310896"/>
+            <a:ext cx="2838294" cy="310896"/>
           </a:xfrm>
           <a:prstGeom prst="roundRect">
             <a:avLst>
@@ -4185,7 +4339,7 @@
         <p:spPr>
           <a:xfrm>
             <a:off x="566928" y="329184"/>
-            <a:ext cx="3008372" cy="310896"/>
+            <a:ext cx="2838294" cy="310896"/>
           </a:xfrm>
           <a:prstGeom prst="rect">
             <a:avLst/>
@@ -4209,7 +4363,7 @@
                 <a:ea typeface="Arial" pitchFamily="34" charset="-122"/>
                 <a:cs typeface="Arial" pitchFamily="34" charset="-120"/>
               </a:rPr>
-              <a:t>27–34 MIN  ·  INSTALLS 3 AND 4</a:t>
+              <a:t>24–28 MIN  ·  INSTALL 2 OF 4</a:t>
             </a:r>
             <a:endParaRPr lang="en-US" sz="1050" dirty="0"/>
           </a:p>
@@ -4248,7 +4402,7 @@
                 <a:ea typeface="Arial" pitchFamily="34" charset="-122"/>
                 <a:cs typeface="Arial" pitchFamily="34" charset="-120"/>
               </a:rPr>
-              <a:t>R, then RStudio — in that order</a:t>
+              <a:t>VS Code — where you type</a:t>
             </a:r>
             <a:endParaRPr lang="en-US" sz="3300" dirty="0"/>
           </a:p>
@@ -4360,7 +4514,7 @@
                 <a:ea typeface="Arial" pitchFamily="34" charset="-122"/>
                 <a:cs typeface="Arial" pitchFamily="34" charset="-120"/>
               </a:rPr>
-              <a:t>FIRST: R</a:t>
+              <a:t>INSTALL IT</a:t>
             </a:r>
             <a:endParaRPr lang="en-US" sz="1000" dirty="0"/>
           </a:p>
@@ -4406,7 +4560,7 @@
                 <a:ea typeface="Calibri" pitchFamily="34" charset="-122"/>
                 <a:cs typeface="Calibri" pitchFamily="34" charset="-120"/>
               </a:rPr>
-              <a:t>Windows: run the .exe and accept every default.</a:t>
+              <a:t>Run the installer and accept the defaults.</a:t>
             </a:r>
             <a:endParaRPr lang="en-US" sz="1250" dirty="0"/>
           </a:p>
@@ -4430,7 +4584,7 @@
                 <a:ea typeface="Calibri" pitchFamily="34" charset="-122"/>
                 <a:cs typeface="Calibri" pitchFamily="34" charset="-120"/>
               </a:rPr>
-              <a:t>macOS: open the .pkg and click through.</a:t>
+              <a:t>On Windows leave every checkbox ticked, especially “Add to PATH.”</a:t>
             </a:r>
             <a:endParaRPr lang="en-US" sz="1250" dirty="0"/>
           </a:p>
@@ -4454,7 +4608,7 @@
                 <a:ea typeface="Calibri" pitchFamily="34" charset="-122"/>
                 <a:cs typeface="Calibri" pitchFamily="34" charset="-120"/>
               </a:rPr>
-              <a:t>R is the engine. Its own window is plain and ugly. That is correct.</a:t>
+              <a:t>Open it. You will get a Welcome tab. Ignore it.</a:t>
             </a:r>
             <a:endParaRPr lang="en-US" sz="1250" dirty="0"/>
           </a:p>
@@ -4478,7 +4632,7 @@
                 <a:ea typeface="Calibri" pitchFamily="34" charset="-122"/>
                 <a:cs typeface="Calibri" pitchFamily="34" charset="-120"/>
               </a:rPr>
-              <a:t>Nothing to configure. Do not bother opening it.</a:t>
+              <a:t>It is a text editor. Installing it does not install Python.</a:t>
             </a:r>
             <a:endParaRPr lang="en-US" sz="1250" dirty="0"/>
           </a:p>
@@ -4551,7 +4705,7 @@
                 <a:ea typeface="Arial" pitchFamily="34" charset="-122"/>
                 <a:cs typeface="Arial" pitchFamily="34" charset="-120"/>
               </a:rPr>
-              <a:t>SECOND: RSTUDIO</a:t>
+              <a:t>THEN ADD TWO EXTENSIONS</a:t>
             </a:r>
             <a:endParaRPr lang="en-US" sz="1000" dirty="0"/>
           </a:p>
@@ -4597,7 +4751,7 @@
                 <a:ea typeface="Calibri" pitchFamily="34" charset="-122"/>
                 <a:cs typeface="Calibri" pitchFamily="34" charset="-120"/>
               </a:rPr>
-              <a:t>Only once R has finished installing.</a:t>
+              <a:t>Click the Extensions icon in the left bar — the four squares.</a:t>
             </a:r>
             <a:endParaRPr lang="en-US" sz="1250" dirty="0"/>
           </a:p>
@@ -4621,7 +4775,7 @@
                 <a:ea typeface="Calibri" pitchFamily="34" charset="-122"/>
                 <a:cs typeface="Calibri" pitchFamily="34" charset="-120"/>
               </a:rPr>
-              <a:t>Run the installer, accept the defaults, then open RStudio.</a:t>
+              <a:t>Search Python. Install the one published by Microsoft.</a:t>
             </a:r>
             <a:endParaRPr lang="en-US" sz="1250" dirty="0"/>
           </a:p>
@@ -4645,7 +4799,7 @@
                 <a:ea typeface="Calibri" pitchFamily="34" charset="-122"/>
                 <a:cs typeface="Calibri" pitchFamily="34" charset="-120"/>
               </a:rPr>
-              <a:t>It finds R by itself. You will see four panes.</a:t>
+              <a:t>Search Jupyter. Install that one too, also by Microsoft.</a:t>
             </a:r>
             <a:endParaRPr lang="en-US" sz="1250" dirty="0"/>
           </a:p>
@@ -4669,7 +4823,7 @@
                 <a:ea typeface="Calibri" pitchFamily="34" charset="-122"/>
                 <a:cs typeface="Calibri" pitchFamily="34" charset="-120"/>
               </a:rPr>
-              <a:t>Bottom-left pane is the console. That is where code runs.</a:t>
+              <a:t>Nothing else today. Extensions are a rabbit hole.</a:t>
             </a:r>
             <a:endParaRPr lang="en-US" sz="1250" dirty="0"/>
           </a:p>
@@ -4708,7 +4862,7 @@
                 <a:ea typeface="Arial" pitchFamily="34" charset="-122"/>
                 <a:cs typeface="Arial" pitchFamily="34" charset="-120"/>
               </a:rPr>
-              <a:t>THE ORDER MATTERS</a:t>
+              <a:t>WATCH OUT FOR</a:t>
             </a:r>
             <a:endParaRPr lang="en-US" sz="1000" dirty="0"/>
           </a:p>
@@ -4786,7 +4940,7 @@
                 <a:ea typeface="Calibri" pitchFamily="34" charset="-122"/>
                 <a:cs typeface="Calibri" pitchFamily="34" charset="-120"/>
               </a:rPr>
-              <a:t>RStudio opens and reports it cannot find R — you installed it first. Install R, then restart.</a:t>
+              <a:t>A Python extension that is not Microsoft’s — check the publisher line.</a:t>
             </a:r>
             <a:endParaRPr lang="en-US" sz="1250" dirty="0"/>
           </a:p>
@@ -4864,7 +5018,7 @@
                 <a:ea typeface="Calibri" pitchFamily="34" charset="-122"/>
                 <a:cs typeface="Calibri" pitchFamily="34" charset="-120"/>
               </a:rPr>
-              <a:t>R installed while RStudio is already open — restart RStudio or it will not see it.</a:t>
+              <a:t>A “Select Interpreter” prompt — pick the 3.1x you just installed.</a:t>
             </a:r>
             <a:endParaRPr lang="en-US" sz="1250" dirty="0"/>
           </a:p>
@@ -4942,7 +5096,7 @@
                 <a:ea typeface="Calibri" pitchFamily="34" charset="-122"/>
                 <a:cs typeface="Calibri" pitchFamily="34" charset="-120"/>
               </a:rPr>
-              <a:t>RStudio is not R — it is a dashboard bolted onto the R engine.</a:t>
+              <a:t>Do not install Copilot yet. It needs a GitHub account — that is homework.</a:t>
             </a:r>
             <a:endParaRPr lang="en-US" sz="1250" dirty="0"/>
           </a:p>
@@ -5020,7 +5174,7 @@
                 <a:ea typeface="Calibri" pitchFamily="34" charset="-122"/>
                 <a:cs typeface="Calibri" pitchFamily="34" charset="-120"/>
               </a:rPr>
-              <a:t>Still waiting on the 250 MB download at minute 34 — leave it running, finish tonight.</a:t>
+              <a:t>Installing the wrong search result — Microsoft’s has millions of downloads.</a:t>
             </a:r>
             <a:endParaRPr lang="en-US" sz="1250" dirty="0"/>
           </a:p>
@@ -5059,7 +5213,7 @@
                 <a:ea typeface="Calibri" pitchFamily="34" charset="-122"/>
                 <a:cs typeface="Calibri" pitchFamily="34" charset="-120"/>
               </a:rPr>
-              <a:t>The slowest step, and the one most likely to run past the clock. If yours is still going at minute 34, leave it running and come with us — finish it tonight.</a:t>
+              <a:t>VS Code is the smallest of the four. If yours is done early, help the person next to you — genuinely, that is the fastest way through this.</a:t>
             </a:r>
             <a:endParaRPr lang="en-US" sz="1250" dirty="0"/>
           </a:p>
@@ -5074,6 +5228,978 @@
 </file>
 
 <file path=ppt/slides/slide12.xml><?xml version="1.0" encoding="utf-8"?>
+<p:sld xmlns:a="http://schemas.openxmlformats.org/drawingml/2006/main" xmlns:r="http://schemas.openxmlformats.org/officeDocument/2006/relationships" xmlns:p="http://schemas.openxmlformats.org/presentationml/2006/main">
+  <p:cSld>
+    <p:spTree>
+      <p:nvGrpSpPr>
+        <p:cNvPr id="1" name=""/>
+        <p:cNvGrpSpPr/>
+        <p:nvPr/>
+      </p:nvGrpSpPr>
+      <p:grpSpPr>
+        <a:xfrm>
+          <a:off x="0" y="0"/>
+          <a:ext cx="0" cy="0"/>
+          <a:chOff x="0" y="0"/>
+          <a:chExt cx="0" cy="0"/>
+        </a:xfrm>
+      </p:grpSpPr>
+      <p:pic>
+        <p:nvPicPr>
+          <p:cNvPr id="2" name="Image 0" descr="vu_mark_gold.png"/>
+          <p:cNvPicPr>
+            <a:picLocks noChangeAspect="1"/>
+          </p:cNvPicPr>
+          <p:nvPr/>
+        </p:nvPicPr>
+        <p:blipFill>
+          <a:blip r:embed="rId3"/>
+          <a:stretch>
+            <a:fillRect/>
+          </a:stretch>
+        </p:blipFill>
+        <p:spPr>
+          <a:xfrm>
+            <a:off x="11356848" y="310896"/>
+            <a:ext cx="384048" cy="274320"/>
+          </a:xfrm>
+          <a:prstGeom prst="rect">
+            <a:avLst/>
+          </a:prstGeom>
+        </p:spPr>
+      </p:pic>
+      <p:sp>
+        <p:nvSpPr>
+          <p:cNvPr id="3" name="Shape 0"/>
+          <p:cNvSpPr/>
+          <p:nvPr/>
+        </p:nvSpPr>
+        <p:spPr>
+          <a:xfrm>
+            <a:off x="566928" y="329184"/>
+            <a:ext cx="3008372" cy="310896"/>
+          </a:xfrm>
+          <a:prstGeom prst="roundRect">
+            <a:avLst>
+              <a:gd name="adj" fmla="val 50000"/>
+            </a:avLst>
+          </a:prstGeom>
+          <a:solidFill>
+            <a:srgbClr val="F2C879"/>
+          </a:solidFill>
+          <a:ln w="12700">
+            <a:solidFill>
+              <a:srgbClr val="F2C879"/>
+            </a:solidFill>
+            <a:prstDash val="solid"/>
+          </a:ln>
+        </p:spPr>
+        <p:txBody>
+          <a:bodyPr/>
+          <a:lstStyle/>
+          <a:p>
+            <a:endParaRPr lang="en-US"/>
+          </a:p>
+        </p:txBody>
+      </p:sp>
+      <p:sp>
+        <p:nvSpPr>
+          <p:cNvPr id="4" name="Text 1"/>
+          <p:cNvSpPr txBox="1"/>
+          <p:nvPr/>
+        </p:nvSpPr>
+        <p:spPr>
+          <a:xfrm>
+            <a:off x="566928" y="329184"/>
+            <a:ext cx="3008372" cy="310896"/>
+          </a:xfrm>
+          <a:prstGeom prst="rect">
+            <a:avLst/>
+          </a:prstGeom>
+          <a:noFill/>
+          <a:ln/>
+        </p:spPr>
+        <p:txBody>
+          <a:bodyPr wrap="square" lIns="0" tIns="0" rIns="0" bIns="0" rtlCol="0" anchor="ctr"/>
+          <a:lstStyle/>
+          <a:p>
+            <a:pPr marL="0" indent="0" algn="ctr">
+              <a:buNone/>
+            </a:pPr>
+            <a:r>
+              <a:rPr lang="en-US" sz="1050" b="1" kern="0" spc="110" dirty="0">
+                <a:solidFill>
+                  <a:srgbClr val="5A4415"/>
+                </a:solidFill>
+                <a:latin typeface="Arial" pitchFamily="34" charset="0"/>
+                <a:ea typeface="Arial" pitchFamily="34" charset="-122"/>
+                <a:cs typeface="Arial" pitchFamily="34" charset="-120"/>
+              </a:rPr>
+              <a:t>28–34 MIN  ·  INSTALLS 3 AND 4</a:t>
+            </a:r>
+            <a:endParaRPr lang="en-US" sz="1050" dirty="0"/>
+          </a:p>
+        </p:txBody>
+      </p:sp>
+      <p:sp>
+        <p:nvSpPr>
+          <p:cNvPr id="5" name="Text 2"/>
+          <p:cNvSpPr txBox="1"/>
+          <p:nvPr/>
+        </p:nvSpPr>
+        <p:spPr>
+          <a:xfrm>
+            <a:off x="566928" y="749808"/>
+            <a:ext cx="10692079" cy="658368"/>
+          </a:xfrm>
+          <a:prstGeom prst="rect">
+            <a:avLst/>
+          </a:prstGeom>
+          <a:noFill/>
+          <a:ln/>
+        </p:spPr>
+        <p:txBody>
+          <a:bodyPr wrap="square" lIns="0" tIns="0" rIns="0" bIns="0" rtlCol="0" anchor="ctr"/>
+          <a:lstStyle/>
+          <a:p>
+            <a:pPr marL="0" indent="0">
+              <a:buNone/>
+            </a:pPr>
+            <a:r>
+              <a:rPr lang="en-US" sz="3300" b="1" dirty="0">
+                <a:solidFill>
+                  <a:srgbClr val="1C1C1C"/>
+                </a:solidFill>
+                <a:latin typeface="Arial" pitchFamily="34" charset="0"/>
+                <a:ea typeface="Arial" pitchFamily="34" charset="-122"/>
+                <a:cs typeface="Arial" pitchFamily="34" charset="-120"/>
+              </a:rPr>
+              <a:t>R, then RStudio — in that order</a:t>
+            </a:r>
+            <a:endParaRPr lang="en-US" sz="3300" dirty="0"/>
+          </a:p>
+        </p:txBody>
+      </p:sp>
+      <p:sp>
+        <p:nvSpPr>
+          <p:cNvPr id="6" name="Text 3"/>
+          <p:cNvSpPr txBox="1"/>
+          <p:nvPr/>
+        </p:nvSpPr>
+        <p:spPr>
+          <a:xfrm>
+            <a:off x="11430000" y="6419088"/>
+            <a:ext cx="320040" cy="228600"/>
+          </a:xfrm>
+          <a:prstGeom prst="rect">
+            <a:avLst/>
+          </a:prstGeom>
+          <a:noFill/>
+          <a:ln/>
+        </p:spPr>
+        <p:txBody>
+          <a:bodyPr wrap="square" lIns="0" tIns="0" rIns="0" bIns="0" rtlCol="0" anchor="ctr"/>
+          <a:lstStyle/>
+          <a:p>
+            <a:pPr marL="0" indent="0" algn="r">
+              <a:buNone/>
+            </a:pPr>
+            <a:r>
+              <a:rPr lang="en-US" sz="1000" dirty="0">
+                <a:solidFill>
+                  <a:srgbClr val="B5B5B5"/>
+                </a:solidFill>
+                <a:latin typeface="Calibri" pitchFamily="34" charset="0"/>
+                <a:ea typeface="Calibri" pitchFamily="34" charset="-122"/>
+                <a:cs typeface="Calibri" pitchFamily="34" charset="-120"/>
+              </a:rPr>
+              <a:t>12</a:t>
+            </a:r>
+            <a:endParaRPr lang="en-US" sz="1000" dirty="0"/>
+          </a:p>
+        </p:txBody>
+      </p:sp>
+      <p:sp>
+        <p:nvSpPr>
+          <p:cNvPr id="7" name="Shape 4"/>
+          <p:cNvSpPr/>
+          <p:nvPr/>
+        </p:nvSpPr>
+        <p:spPr>
+          <a:xfrm>
+            <a:off x="566928" y="1517904"/>
+            <a:ext cx="5760720" cy="2633472"/>
+          </a:xfrm>
+          <a:prstGeom prst="roundRect">
+            <a:avLst>
+              <a:gd name="adj" fmla="val 3125"/>
+            </a:avLst>
+          </a:prstGeom>
+          <a:solidFill>
+            <a:srgbClr val="FBF7EF"/>
+          </a:solidFill>
+          <a:ln w="12700">
+            <a:solidFill>
+              <a:srgbClr val="E6E6E6"/>
+            </a:solidFill>
+            <a:prstDash val="solid"/>
+          </a:ln>
+        </p:spPr>
+        <p:txBody>
+          <a:bodyPr/>
+          <a:lstStyle/>
+          <a:p>
+            <a:endParaRPr lang="en-US"/>
+          </a:p>
+        </p:txBody>
+      </p:sp>
+      <p:sp>
+        <p:nvSpPr>
+          <p:cNvPr id="8" name="Text 5"/>
+          <p:cNvSpPr txBox="1"/>
+          <p:nvPr/>
+        </p:nvSpPr>
+        <p:spPr>
+          <a:xfrm>
+            <a:off x="822960" y="1719072"/>
+            <a:ext cx="5120640" cy="237744"/>
+          </a:xfrm>
+          <a:prstGeom prst="rect">
+            <a:avLst/>
+          </a:prstGeom>
+          <a:noFill/>
+          <a:ln/>
+        </p:spPr>
+        <p:txBody>
+          <a:bodyPr wrap="square" lIns="0" tIns="0" rIns="0" bIns="0" rtlCol="0" anchor="ctr"/>
+          <a:lstStyle/>
+          <a:p>
+            <a:pPr marL="0" indent="0">
+              <a:buNone/>
+            </a:pPr>
+            <a:r>
+              <a:rPr lang="en-US" sz="1000" b="1" kern="0" spc="150" dirty="0">
+                <a:solidFill>
+                  <a:srgbClr val="8A6D3B"/>
+                </a:solidFill>
+                <a:latin typeface="Arial" pitchFamily="34" charset="0"/>
+                <a:ea typeface="Arial" pitchFamily="34" charset="-122"/>
+                <a:cs typeface="Arial" pitchFamily="34" charset="-120"/>
+              </a:rPr>
+              <a:t>FIRST: R</a:t>
+            </a:r>
+            <a:endParaRPr lang="en-US" sz="1000" dirty="0"/>
+          </a:p>
+        </p:txBody>
+      </p:sp>
+      <p:sp>
+        <p:nvSpPr>
+          <p:cNvPr id="9" name="Text 6"/>
+          <p:cNvSpPr txBox="1"/>
+          <p:nvPr/>
+        </p:nvSpPr>
+        <p:spPr>
+          <a:xfrm>
+            <a:off x="841248" y="2029968"/>
+            <a:ext cx="5257800" cy="2103120"/>
+          </a:xfrm>
+          <a:prstGeom prst="rect">
+            <a:avLst/>
+          </a:prstGeom>
+          <a:noFill/>
+          <a:ln/>
+        </p:spPr>
+        <p:txBody>
+          <a:bodyPr wrap="square" lIns="0" tIns="0" rIns="0" bIns="0" rtlCol="0" anchor="t"/>
+          <a:lstStyle/>
+          <a:p>
+            <a:pPr marL="203200" indent="-203200">
+              <a:lnSpc>
+                <a:spcPts val="1800"/>
+              </a:lnSpc>
+              <a:spcAft>
+                <a:spcPts val="900"/>
+              </a:spcAft>
+              <a:buSzPct val="100000"/>
+              <a:buChar char="•"/>
+            </a:pPr>
+            <a:r>
+              <a:rPr lang="en-US" sz="1250" dirty="0">
+                <a:solidFill>
+                  <a:srgbClr val="3A3A3A"/>
+                </a:solidFill>
+                <a:latin typeface="Calibri" pitchFamily="34" charset="0"/>
+                <a:ea typeface="Calibri" pitchFamily="34" charset="-122"/>
+                <a:cs typeface="Calibri" pitchFamily="34" charset="-120"/>
+              </a:rPr>
+              <a:t>Windows: run the .exe and accept every default.</a:t>
+            </a:r>
+            <a:endParaRPr lang="en-US" sz="1250" dirty="0"/>
+          </a:p>
+          <a:p>
+            <a:pPr marL="203200" indent="-203200">
+              <a:lnSpc>
+                <a:spcPts val="1800"/>
+              </a:lnSpc>
+              <a:spcAft>
+                <a:spcPts val="900"/>
+              </a:spcAft>
+              <a:buSzPct val="100000"/>
+              <a:buChar char="•"/>
+            </a:pPr>
+            <a:r>
+              <a:rPr lang="en-US" sz="1250" dirty="0">
+                <a:solidFill>
+                  <a:srgbClr val="3A3A3A"/>
+                </a:solidFill>
+                <a:latin typeface="Calibri" pitchFamily="34" charset="0"/>
+                <a:ea typeface="Calibri" pitchFamily="34" charset="-122"/>
+                <a:cs typeface="Calibri" pitchFamily="34" charset="-120"/>
+              </a:rPr>
+              <a:t>macOS: open the .pkg and click through.</a:t>
+            </a:r>
+            <a:endParaRPr lang="en-US" sz="1250" dirty="0"/>
+          </a:p>
+          <a:p>
+            <a:pPr marL="203200" indent="-203200">
+              <a:lnSpc>
+                <a:spcPts val="1800"/>
+              </a:lnSpc>
+              <a:spcAft>
+                <a:spcPts val="900"/>
+              </a:spcAft>
+              <a:buSzPct val="100000"/>
+              <a:buChar char="•"/>
+            </a:pPr>
+            <a:r>
+              <a:rPr lang="en-US" sz="1250" dirty="0">
+                <a:solidFill>
+                  <a:srgbClr val="3A3A3A"/>
+                </a:solidFill>
+                <a:latin typeface="Calibri" pitchFamily="34" charset="0"/>
+                <a:ea typeface="Calibri" pitchFamily="34" charset="-122"/>
+                <a:cs typeface="Calibri" pitchFamily="34" charset="-120"/>
+              </a:rPr>
+              <a:t>R is the engine. Its own window is plain and ugly. That is correct.</a:t>
+            </a:r>
+            <a:endParaRPr lang="en-US" sz="1250" dirty="0"/>
+          </a:p>
+          <a:p>
+            <a:pPr marL="203200" indent="-203200">
+              <a:lnSpc>
+                <a:spcPts val="1800"/>
+              </a:lnSpc>
+              <a:spcAft>
+                <a:spcPts val="900"/>
+              </a:spcAft>
+              <a:buSzPct val="100000"/>
+              <a:buChar char="•"/>
+            </a:pPr>
+            <a:r>
+              <a:rPr lang="en-US" sz="1250" dirty="0">
+                <a:solidFill>
+                  <a:srgbClr val="3A3A3A"/>
+                </a:solidFill>
+                <a:latin typeface="Calibri" pitchFamily="34" charset="0"/>
+                <a:ea typeface="Calibri" pitchFamily="34" charset="-122"/>
+                <a:cs typeface="Calibri" pitchFamily="34" charset="-120"/>
+              </a:rPr>
+              <a:t>Nothing to configure. Do not bother opening it.</a:t>
+            </a:r>
+            <a:endParaRPr lang="en-US" sz="1250" dirty="0"/>
+          </a:p>
+        </p:txBody>
+      </p:sp>
+      <p:sp>
+        <p:nvSpPr>
+          <p:cNvPr id="10" name="Shape 7"/>
+          <p:cNvSpPr/>
+          <p:nvPr/>
+        </p:nvSpPr>
+        <p:spPr>
+          <a:xfrm>
+            <a:off x="6583680" y="1517904"/>
+            <a:ext cx="5029200" cy="2633472"/>
+          </a:xfrm>
+          <a:prstGeom prst="roundRect">
+            <a:avLst>
+              <a:gd name="adj" fmla="val 3125"/>
+            </a:avLst>
+          </a:prstGeom>
+          <a:solidFill>
+            <a:srgbClr val="FFFFFF"/>
+          </a:solidFill>
+          <a:ln w="12700">
+            <a:solidFill>
+              <a:srgbClr val="E6E6E6"/>
+            </a:solidFill>
+            <a:prstDash val="solid"/>
+          </a:ln>
+        </p:spPr>
+        <p:txBody>
+          <a:bodyPr/>
+          <a:lstStyle/>
+          <a:p>
+            <a:endParaRPr lang="en-US"/>
+          </a:p>
+        </p:txBody>
+      </p:sp>
+      <p:sp>
+        <p:nvSpPr>
+          <p:cNvPr id="11" name="Text 8"/>
+          <p:cNvSpPr txBox="1"/>
+          <p:nvPr/>
+        </p:nvSpPr>
+        <p:spPr>
+          <a:xfrm>
+            <a:off x="6839712" y="1719072"/>
+            <a:ext cx="4480560" cy="237744"/>
+          </a:xfrm>
+          <a:prstGeom prst="rect">
+            <a:avLst/>
+          </a:prstGeom>
+          <a:noFill/>
+          <a:ln/>
+        </p:spPr>
+        <p:txBody>
+          <a:bodyPr wrap="square" lIns="0" tIns="0" rIns="0" bIns="0" rtlCol="0" anchor="ctr"/>
+          <a:lstStyle/>
+          <a:p>
+            <a:pPr marL="0" indent="0">
+              <a:buNone/>
+            </a:pPr>
+            <a:r>
+              <a:rPr lang="en-US" sz="1000" b="1" kern="0" spc="150" dirty="0">
+                <a:solidFill>
+                  <a:srgbClr val="8A6D3B"/>
+                </a:solidFill>
+                <a:latin typeface="Arial" pitchFamily="34" charset="0"/>
+                <a:ea typeface="Arial" pitchFamily="34" charset="-122"/>
+                <a:cs typeface="Arial" pitchFamily="34" charset="-120"/>
+              </a:rPr>
+              <a:t>SECOND: RSTUDIO</a:t>
+            </a:r>
+            <a:endParaRPr lang="en-US" sz="1000" dirty="0"/>
+          </a:p>
+        </p:txBody>
+      </p:sp>
+      <p:sp>
+        <p:nvSpPr>
+          <p:cNvPr id="12" name="Text 9"/>
+          <p:cNvSpPr txBox="1"/>
+          <p:nvPr/>
+        </p:nvSpPr>
+        <p:spPr>
+          <a:xfrm>
+            <a:off x="6858000" y="2029968"/>
+            <a:ext cx="4526280" cy="2103120"/>
+          </a:xfrm>
+          <a:prstGeom prst="rect">
+            <a:avLst/>
+          </a:prstGeom>
+          <a:noFill/>
+          <a:ln/>
+        </p:spPr>
+        <p:txBody>
+          <a:bodyPr wrap="square" lIns="0" tIns="0" rIns="0" bIns="0" rtlCol="0" anchor="t"/>
+          <a:lstStyle/>
+          <a:p>
+            <a:pPr marL="203200" indent="-203200">
+              <a:lnSpc>
+                <a:spcPts val="1800"/>
+              </a:lnSpc>
+              <a:spcAft>
+                <a:spcPts val="900"/>
+              </a:spcAft>
+              <a:buSzPct val="100000"/>
+              <a:buChar char="•"/>
+            </a:pPr>
+            <a:r>
+              <a:rPr lang="en-US" sz="1250" dirty="0">
+                <a:solidFill>
+                  <a:srgbClr val="3A3A3A"/>
+                </a:solidFill>
+                <a:latin typeface="Calibri" pitchFamily="34" charset="0"/>
+                <a:ea typeface="Calibri" pitchFamily="34" charset="-122"/>
+                <a:cs typeface="Calibri" pitchFamily="34" charset="-120"/>
+              </a:rPr>
+              <a:t>Only once R has finished installing.</a:t>
+            </a:r>
+            <a:endParaRPr lang="en-US" sz="1250" dirty="0"/>
+          </a:p>
+          <a:p>
+            <a:pPr marL="203200" indent="-203200">
+              <a:lnSpc>
+                <a:spcPts val="1800"/>
+              </a:lnSpc>
+              <a:spcAft>
+                <a:spcPts val="900"/>
+              </a:spcAft>
+              <a:buSzPct val="100000"/>
+              <a:buChar char="•"/>
+            </a:pPr>
+            <a:r>
+              <a:rPr lang="en-US" sz="1250" dirty="0">
+                <a:solidFill>
+                  <a:srgbClr val="3A3A3A"/>
+                </a:solidFill>
+                <a:latin typeface="Calibri" pitchFamily="34" charset="0"/>
+                <a:ea typeface="Calibri" pitchFamily="34" charset="-122"/>
+                <a:cs typeface="Calibri" pitchFamily="34" charset="-120"/>
+              </a:rPr>
+              <a:t>Run the installer, accept the defaults, then open RStudio.</a:t>
+            </a:r>
+            <a:endParaRPr lang="en-US" sz="1250" dirty="0"/>
+          </a:p>
+          <a:p>
+            <a:pPr marL="203200" indent="-203200">
+              <a:lnSpc>
+                <a:spcPts val="1800"/>
+              </a:lnSpc>
+              <a:spcAft>
+                <a:spcPts val="900"/>
+              </a:spcAft>
+              <a:buSzPct val="100000"/>
+              <a:buChar char="•"/>
+            </a:pPr>
+            <a:r>
+              <a:rPr lang="en-US" sz="1250" dirty="0">
+                <a:solidFill>
+                  <a:srgbClr val="3A3A3A"/>
+                </a:solidFill>
+                <a:latin typeface="Calibri" pitchFamily="34" charset="0"/>
+                <a:ea typeface="Calibri" pitchFamily="34" charset="-122"/>
+                <a:cs typeface="Calibri" pitchFamily="34" charset="-120"/>
+              </a:rPr>
+              <a:t>It finds R by itself. You will see four panes.</a:t>
+            </a:r>
+            <a:endParaRPr lang="en-US" sz="1250" dirty="0"/>
+          </a:p>
+          <a:p>
+            <a:pPr marL="203200" indent="-203200">
+              <a:lnSpc>
+                <a:spcPts val="1800"/>
+              </a:lnSpc>
+              <a:spcAft>
+                <a:spcPts val="900"/>
+              </a:spcAft>
+              <a:buSzPct val="100000"/>
+              <a:buChar char="•"/>
+            </a:pPr>
+            <a:r>
+              <a:rPr lang="en-US" sz="1250" dirty="0">
+                <a:solidFill>
+                  <a:srgbClr val="3A3A3A"/>
+                </a:solidFill>
+                <a:latin typeface="Calibri" pitchFamily="34" charset="0"/>
+                <a:ea typeface="Calibri" pitchFamily="34" charset="-122"/>
+                <a:cs typeface="Calibri" pitchFamily="34" charset="-120"/>
+              </a:rPr>
+              <a:t>Bottom-left pane is the console. That is where code runs.</a:t>
+            </a:r>
+            <a:endParaRPr lang="en-US" sz="1250" dirty="0"/>
+          </a:p>
+        </p:txBody>
+      </p:sp>
+      <p:sp>
+        <p:nvSpPr>
+          <p:cNvPr id="13" name="Text 10"/>
+          <p:cNvSpPr txBox="1"/>
+          <p:nvPr/>
+        </p:nvSpPr>
+        <p:spPr>
+          <a:xfrm>
+            <a:off x="566928" y="4443984"/>
+            <a:ext cx="7315200" cy="256032"/>
+          </a:xfrm>
+          <a:prstGeom prst="rect">
+            <a:avLst/>
+          </a:prstGeom>
+          <a:noFill/>
+          <a:ln/>
+        </p:spPr>
+        <p:txBody>
+          <a:bodyPr wrap="square" lIns="0" tIns="0" rIns="0" bIns="0" rtlCol="0" anchor="ctr"/>
+          <a:lstStyle/>
+          <a:p>
+            <a:pPr marL="0" indent="0">
+              <a:buNone/>
+            </a:pPr>
+            <a:r>
+              <a:rPr lang="en-US" sz="1000" b="1" kern="0" spc="150" dirty="0">
+                <a:solidFill>
+                  <a:srgbClr val="A83A2C"/>
+                </a:solidFill>
+                <a:latin typeface="Arial" pitchFamily="34" charset="0"/>
+                <a:ea typeface="Arial" pitchFamily="34" charset="-122"/>
+                <a:cs typeface="Arial" pitchFamily="34" charset="-120"/>
+              </a:rPr>
+              <a:t>THE ORDER MATTERS</a:t>
+            </a:r>
+            <a:endParaRPr lang="en-US" sz="1000" dirty="0"/>
+          </a:p>
+        </p:txBody>
+      </p:sp>
+      <p:sp>
+        <p:nvSpPr>
+          <p:cNvPr id="14" name="Text 11"/>
+          <p:cNvSpPr txBox="1"/>
+          <p:nvPr/>
+        </p:nvSpPr>
+        <p:spPr>
+          <a:xfrm>
+            <a:off x="566928" y="4754880"/>
+            <a:ext cx="219456" cy="310896"/>
+          </a:xfrm>
+          <a:prstGeom prst="rect">
+            <a:avLst/>
+          </a:prstGeom>
+          <a:noFill/>
+          <a:ln/>
+        </p:spPr>
+        <p:txBody>
+          <a:bodyPr wrap="square" lIns="0" tIns="0" rIns="0" bIns="0" rtlCol="0" anchor="ctr"/>
+          <a:lstStyle/>
+          <a:p>
+            <a:pPr marL="0" indent="0">
+              <a:buNone/>
+            </a:pPr>
+            <a:r>
+              <a:rPr lang="en-US" sz="1100" b="1" dirty="0">
+                <a:solidFill>
+                  <a:srgbClr val="A83A2C"/>
+                </a:solidFill>
+                <a:latin typeface="Arial" pitchFamily="34" charset="0"/>
+                <a:ea typeface="Arial" pitchFamily="34" charset="-122"/>
+                <a:cs typeface="Arial" pitchFamily="34" charset="-120"/>
+              </a:rPr>
+              <a:t>✕</a:t>
+            </a:r>
+            <a:endParaRPr lang="en-US" sz="1100" dirty="0"/>
+          </a:p>
+        </p:txBody>
+      </p:sp>
+      <p:sp>
+        <p:nvSpPr>
+          <p:cNvPr id="15" name="Text 12"/>
+          <p:cNvSpPr txBox="1"/>
+          <p:nvPr/>
+        </p:nvSpPr>
+        <p:spPr>
+          <a:xfrm>
+            <a:off x="804672" y="4754880"/>
+            <a:ext cx="5120640" cy="310896"/>
+          </a:xfrm>
+          <a:prstGeom prst="rect">
+            <a:avLst/>
+          </a:prstGeom>
+          <a:noFill/>
+          <a:ln/>
+        </p:spPr>
+        <p:txBody>
+          <a:bodyPr wrap="square" lIns="0" tIns="0" rIns="0" bIns="0" rtlCol="0" anchor="ctr"/>
+          <a:lstStyle/>
+          <a:p>
+            <a:pPr marL="0" indent="0">
+              <a:buNone/>
+            </a:pPr>
+            <a:r>
+              <a:rPr lang="en-US" sz="1250" dirty="0">
+                <a:solidFill>
+                  <a:srgbClr val="3A3A3A"/>
+                </a:solidFill>
+                <a:latin typeface="Calibri" pitchFamily="34" charset="0"/>
+                <a:ea typeface="Calibri" pitchFamily="34" charset="-122"/>
+                <a:cs typeface="Calibri" pitchFamily="34" charset="-120"/>
+              </a:rPr>
+              <a:t>RStudio opens and reports it cannot find R — you installed it first. Install R, then restart.</a:t>
+            </a:r>
+            <a:endParaRPr lang="en-US" sz="1250" dirty="0"/>
+          </a:p>
+        </p:txBody>
+      </p:sp>
+      <p:sp>
+        <p:nvSpPr>
+          <p:cNvPr id="16" name="Text 13"/>
+          <p:cNvSpPr txBox="1"/>
+          <p:nvPr/>
+        </p:nvSpPr>
+        <p:spPr>
+          <a:xfrm>
+            <a:off x="6108192" y="4754880"/>
+            <a:ext cx="219456" cy="310896"/>
+          </a:xfrm>
+          <a:prstGeom prst="rect">
+            <a:avLst/>
+          </a:prstGeom>
+          <a:noFill/>
+          <a:ln/>
+        </p:spPr>
+        <p:txBody>
+          <a:bodyPr wrap="square" lIns="0" tIns="0" rIns="0" bIns="0" rtlCol="0" anchor="ctr"/>
+          <a:lstStyle/>
+          <a:p>
+            <a:pPr marL="0" indent="0">
+              <a:buNone/>
+            </a:pPr>
+            <a:r>
+              <a:rPr lang="en-US" sz="1100" b="1" dirty="0">
+                <a:solidFill>
+                  <a:srgbClr val="A83A2C"/>
+                </a:solidFill>
+                <a:latin typeface="Arial" pitchFamily="34" charset="0"/>
+                <a:ea typeface="Arial" pitchFamily="34" charset="-122"/>
+                <a:cs typeface="Arial" pitchFamily="34" charset="-120"/>
+              </a:rPr>
+              <a:t>✕</a:t>
+            </a:r>
+            <a:endParaRPr lang="en-US" sz="1100" dirty="0"/>
+          </a:p>
+        </p:txBody>
+      </p:sp>
+      <p:sp>
+        <p:nvSpPr>
+          <p:cNvPr id="17" name="Text 14"/>
+          <p:cNvSpPr txBox="1"/>
+          <p:nvPr/>
+        </p:nvSpPr>
+        <p:spPr>
+          <a:xfrm>
+            <a:off x="6345936" y="4754880"/>
+            <a:ext cx="5120640" cy="310896"/>
+          </a:xfrm>
+          <a:prstGeom prst="rect">
+            <a:avLst/>
+          </a:prstGeom>
+          <a:noFill/>
+          <a:ln/>
+        </p:spPr>
+        <p:txBody>
+          <a:bodyPr wrap="square" lIns="0" tIns="0" rIns="0" bIns="0" rtlCol="0" anchor="ctr"/>
+          <a:lstStyle/>
+          <a:p>
+            <a:pPr marL="0" indent="0">
+              <a:buNone/>
+            </a:pPr>
+            <a:r>
+              <a:rPr lang="en-US" sz="1250" dirty="0">
+                <a:solidFill>
+                  <a:srgbClr val="3A3A3A"/>
+                </a:solidFill>
+                <a:latin typeface="Calibri" pitchFamily="34" charset="0"/>
+                <a:ea typeface="Calibri" pitchFamily="34" charset="-122"/>
+                <a:cs typeface="Calibri" pitchFamily="34" charset="-120"/>
+              </a:rPr>
+              <a:t>R installed while RStudio is already open — restart RStudio or it will not see it.</a:t>
+            </a:r>
+            <a:endParaRPr lang="en-US" sz="1250" dirty="0"/>
+          </a:p>
+        </p:txBody>
+      </p:sp>
+      <p:sp>
+        <p:nvSpPr>
+          <p:cNvPr id="18" name="Text 15"/>
+          <p:cNvSpPr txBox="1"/>
+          <p:nvPr/>
+        </p:nvSpPr>
+        <p:spPr>
+          <a:xfrm>
+            <a:off x="566928" y="5175504"/>
+            <a:ext cx="219456" cy="310896"/>
+          </a:xfrm>
+          <a:prstGeom prst="rect">
+            <a:avLst/>
+          </a:prstGeom>
+          <a:noFill/>
+          <a:ln/>
+        </p:spPr>
+        <p:txBody>
+          <a:bodyPr wrap="square" lIns="0" tIns="0" rIns="0" bIns="0" rtlCol="0" anchor="ctr"/>
+          <a:lstStyle/>
+          <a:p>
+            <a:pPr marL="0" indent="0">
+              <a:buNone/>
+            </a:pPr>
+            <a:r>
+              <a:rPr lang="en-US" sz="1100" b="1" dirty="0">
+                <a:solidFill>
+                  <a:srgbClr val="A83A2C"/>
+                </a:solidFill>
+                <a:latin typeface="Arial" pitchFamily="34" charset="0"/>
+                <a:ea typeface="Arial" pitchFamily="34" charset="-122"/>
+                <a:cs typeface="Arial" pitchFamily="34" charset="-120"/>
+              </a:rPr>
+              <a:t>✕</a:t>
+            </a:r>
+            <a:endParaRPr lang="en-US" sz="1100" dirty="0"/>
+          </a:p>
+        </p:txBody>
+      </p:sp>
+      <p:sp>
+        <p:nvSpPr>
+          <p:cNvPr id="19" name="Text 16"/>
+          <p:cNvSpPr txBox="1"/>
+          <p:nvPr/>
+        </p:nvSpPr>
+        <p:spPr>
+          <a:xfrm>
+            <a:off x="804672" y="5175504"/>
+            <a:ext cx="5120640" cy="310896"/>
+          </a:xfrm>
+          <a:prstGeom prst="rect">
+            <a:avLst/>
+          </a:prstGeom>
+          <a:noFill/>
+          <a:ln/>
+        </p:spPr>
+        <p:txBody>
+          <a:bodyPr wrap="square" lIns="0" tIns="0" rIns="0" bIns="0" rtlCol="0" anchor="ctr"/>
+          <a:lstStyle/>
+          <a:p>
+            <a:pPr marL="0" indent="0">
+              <a:buNone/>
+            </a:pPr>
+            <a:r>
+              <a:rPr lang="en-US" sz="1250" dirty="0">
+                <a:solidFill>
+                  <a:srgbClr val="3A3A3A"/>
+                </a:solidFill>
+                <a:latin typeface="Calibri" pitchFamily="34" charset="0"/>
+                <a:ea typeface="Calibri" pitchFamily="34" charset="-122"/>
+                <a:cs typeface="Calibri" pitchFamily="34" charset="-120"/>
+              </a:rPr>
+              <a:t>RStudio is not R — it is a dashboard bolted onto the R engine.</a:t>
+            </a:r>
+            <a:endParaRPr lang="en-US" sz="1250" dirty="0"/>
+          </a:p>
+        </p:txBody>
+      </p:sp>
+      <p:sp>
+        <p:nvSpPr>
+          <p:cNvPr id="20" name="Text 17"/>
+          <p:cNvSpPr txBox="1"/>
+          <p:nvPr/>
+        </p:nvSpPr>
+        <p:spPr>
+          <a:xfrm>
+            <a:off x="6108192" y="5175504"/>
+            <a:ext cx="219456" cy="310896"/>
+          </a:xfrm>
+          <a:prstGeom prst="rect">
+            <a:avLst/>
+          </a:prstGeom>
+          <a:noFill/>
+          <a:ln/>
+        </p:spPr>
+        <p:txBody>
+          <a:bodyPr wrap="square" lIns="0" tIns="0" rIns="0" bIns="0" rtlCol="0" anchor="ctr"/>
+          <a:lstStyle/>
+          <a:p>
+            <a:pPr marL="0" indent="0">
+              <a:buNone/>
+            </a:pPr>
+            <a:r>
+              <a:rPr lang="en-US" sz="1100" b="1" dirty="0">
+                <a:solidFill>
+                  <a:srgbClr val="A83A2C"/>
+                </a:solidFill>
+                <a:latin typeface="Arial" pitchFamily="34" charset="0"/>
+                <a:ea typeface="Arial" pitchFamily="34" charset="-122"/>
+                <a:cs typeface="Arial" pitchFamily="34" charset="-120"/>
+              </a:rPr>
+              <a:t>✕</a:t>
+            </a:r>
+            <a:endParaRPr lang="en-US" sz="1100" dirty="0"/>
+          </a:p>
+        </p:txBody>
+      </p:sp>
+      <p:sp>
+        <p:nvSpPr>
+          <p:cNvPr id="21" name="Text 18"/>
+          <p:cNvSpPr txBox="1"/>
+          <p:nvPr/>
+        </p:nvSpPr>
+        <p:spPr>
+          <a:xfrm>
+            <a:off x="6345936" y="5175504"/>
+            <a:ext cx="5120640" cy="310896"/>
+          </a:xfrm>
+          <a:prstGeom prst="rect">
+            <a:avLst/>
+          </a:prstGeom>
+          <a:noFill/>
+          <a:ln/>
+        </p:spPr>
+        <p:txBody>
+          <a:bodyPr wrap="square" lIns="0" tIns="0" rIns="0" bIns="0" rtlCol="0" anchor="ctr"/>
+          <a:lstStyle/>
+          <a:p>
+            <a:pPr marL="0" indent="0">
+              <a:buNone/>
+            </a:pPr>
+            <a:r>
+              <a:rPr lang="en-US" sz="1250" dirty="0">
+                <a:solidFill>
+                  <a:srgbClr val="3A3A3A"/>
+                </a:solidFill>
+                <a:latin typeface="Calibri" pitchFamily="34" charset="0"/>
+                <a:ea typeface="Calibri" pitchFamily="34" charset="-122"/>
+                <a:cs typeface="Calibri" pitchFamily="34" charset="-120"/>
+              </a:rPr>
+              <a:t>Still waiting on the 250 MB download at minute 34 — leave it running, finish tonight.</a:t>
+            </a:r>
+            <a:endParaRPr lang="en-US" sz="1250" dirty="0"/>
+          </a:p>
+        </p:txBody>
+      </p:sp>
+      <p:sp>
+        <p:nvSpPr>
+          <p:cNvPr id="22" name="Text 19"/>
+          <p:cNvSpPr txBox="1"/>
+          <p:nvPr/>
+        </p:nvSpPr>
+        <p:spPr>
+          <a:xfrm>
+            <a:off x="566928" y="5815584"/>
+            <a:ext cx="11057839" cy="329184"/>
+          </a:xfrm>
+          <a:prstGeom prst="rect">
+            <a:avLst/>
+          </a:prstGeom>
+          <a:noFill/>
+          <a:ln/>
+        </p:spPr>
+        <p:txBody>
+          <a:bodyPr wrap="square" lIns="0" tIns="0" rIns="0" bIns="0" rtlCol="0" anchor="ctr"/>
+          <a:lstStyle/>
+          <a:p>
+            <a:pPr marL="0" indent="0">
+              <a:buNone/>
+            </a:pPr>
+            <a:r>
+              <a:rPr lang="en-US" sz="1250" i="1" dirty="0">
+                <a:solidFill>
+                  <a:srgbClr val="7A7A7A"/>
+                </a:solidFill>
+                <a:latin typeface="Calibri" pitchFamily="34" charset="0"/>
+                <a:ea typeface="Calibri" pitchFamily="34" charset="-122"/>
+                <a:cs typeface="Calibri" pitchFamily="34" charset="-120"/>
+              </a:rPr>
+              <a:t>The slowest step, and the one most likely to run past the clock. If yours is still going at minute 34, leave it running and come with us — finish it tonight.</a:t>
+            </a:r>
+            <a:endParaRPr lang="en-US" sz="1250" dirty="0"/>
+          </a:p>
+        </p:txBody>
+      </p:sp>
+    </p:spTree>
+  </p:cSld>
+  <p:clrMapOvr>
+    <a:masterClrMapping/>
+  </p:clrMapOvr>
+</p:sld>
+</file>
+
+<file path=ppt/slides/slide13.xml><?xml version="1.0" encoding="utf-8"?>
 <p:sld xmlns:a="http://schemas.openxmlformats.org/drawingml/2006/main" xmlns:r="http://schemas.openxmlformats.org/officeDocument/2006/relationships" xmlns:p="http://schemas.openxmlformats.org/presentationml/2006/main">
   <p:cSld name="Slide 8">
     <p:bg>
@@ -5267,7 +6393,7 @@
                 <a:ea typeface="Calibri" pitchFamily="34" charset="-122"/>
                 <a:cs typeface="Calibri" pitchFamily="34" charset="-120"/>
               </a:rPr>
-              <a:t>12</a:t>
+              <a:t>13</a:t>
             </a:r>
             <a:endParaRPr lang="en-US" sz="1000" dirty="0"/>
           </a:p>
@@ -6093,7 +7219,7 @@
 </p:sld>
 </file>
 
-<file path=ppt/slides/slide13.xml><?xml version="1.0" encoding="utf-8"?>
+<file path=ppt/slides/slide14.xml><?xml version="1.0" encoding="utf-8"?>
 <p:sld xmlns:a="http://schemas.openxmlformats.org/drawingml/2006/main" xmlns:r="http://schemas.openxmlformats.org/officeDocument/2006/relationships" xmlns:p="http://schemas.openxmlformats.org/presentationml/2006/main">
   <p:cSld>
     <p:spTree>
@@ -6279,7 +7405,7 @@
                 <a:ea typeface="Calibri" pitchFamily="34" charset="-122"/>
                 <a:cs typeface="Calibri" pitchFamily="34" charset="-120"/>
               </a:rPr>
-              <a:t>13</a:t>
+              <a:t>14</a:t>
             </a:r>
             <a:endParaRPr lang="en-US" sz="1000" dirty="0"/>
           </a:p>
@@ -6786,7 +7912,7 @@
 </p:sld>
 </file>
 
-<file path=ppt/slides/slide14.xml><?xml version="1.0" encoding="utf-8"?>
+<file path=ppt/slides/slide15.xml><?xml version="1.0" encoding="utf-8"?>
 <p:sld xmlns:a="http://schemas.openxmlformats.org/drawingml/2006/main" xmlns:r="http://schemas.openxmlformats.org/officeDocument/2006/relationships" xmlns:p="http://schemas.openxmlformats.org/presentationml/2006/main">
   <p:cSld name="Slide 9">
     <p:bg>
@@ -7126,7 +8252,7 @@
 </p:sld>
 </file>
 
-<file path=ppt/slides/slide15.xml><?xml version="1.0" encoding="utf-8"?>
+<file path=ppt/slides/slide16.xml><?xml version="1.0" encoding="utf-8"?>
 <p:sld xmlns:a="http://schemas.openxmlformats.org/drawingml/2006/main" xmlns:r="http://schemas.openxmlformats.org/officeDocument/2006/relationships" xmlns:p="http://schemas.openxmlformats.org/presentationml/2006/main">
   <p:cSld name="Slide 10">
     <p:bg>
@@ -7320,7 +8446,7 @@
                 <a:ea typeface="Calibri" pitchFamily="34" charset="-122"/>
                 <a:cs typeface="Calibri" pitchFamily="34" charset="-120"/>
               </a:rPr>
-              <a:t>15</a:t>
+              <a:t>16</a:t>
             </a:r>
             <a:endParaRPr lang="en-US" sz="1000" dirty="0"/>
           </a:p>
@@ -8975,7 +10101,7 @@
 </p:sld>
 </file>
 
-<file path=ppt/slides/slide16.xml><?xml version="1.0" encoding="utf-8"?>
+<file path=ppt/slides/slide17.xml><?xml version="1.0" encoding="utf-8"?>
 <p:sld xmlns:a="http://schemas.openxmlformats.org/drawingml/2006/main" xmlns:r="http://schemas.openxmlformats.org/officeDocument/2006/relationships" xmlns:p="http://schemas.openxmlformats.org/presentationml/2006/main">
   <p:cSld name="Slide 12">
     <p:bg>
@@ -9169,7 +10295,7 @@
                 <a:ea typeface="Calibri" pitchFamily="34" charset="-122"/>
                 <a:cs typeface="Calibri" pitchFamily="34" charset="-120"/>
               </a:rPr>
-              <a:t>16</a:t>
+              <a:t>17</a:t>
             </a:r>
             <a:endParaRPr lang="en-US" sz="1000" dirty="0"/>
           </a:p>
@@ -9890,7 +11016,7 @@
 </p:sld>
 </file>
 
-<file path=ppt/slides/slide17.xml><?xml version="1.0" encoding="utf-8"?>
+<file path=ppt/slides/slide18.xml><?xml version="1.0" encoding="utf-8"?>
 <p:sld xmlns:a="http://schemas.openxmlformats.org/drawingml/2006/main" xmlns:r="http://schemas.openxmlformats.org/officeDocument/2006/relationships" xmlns:p="http://schemas.openxmlformats.org/presentationml/2006/main">
   <p:cSld name="Slide 13">
     <p:bg>
@@ -10084,7 +11210,7 @@
                 <a:ea typeface="Calibri" pitchFamily="34" charset="-122"/>
                 <a:cs typeface="Calibri" pitchFamily="34" charset="-120"/>
               </a:rPr>
-              <a:t>17</a:t>
+              <a:t>18</a:t>
             </a:r>
             <a:endParaRPr lang="en-US" sz="1000" dirty="0"/>
           </a:p>
@@ -11124,7 +12250,7 @@
 </p:sld>
 </file>
 
-<file path=ppt/slides/slide18.xml><?xml version="1.0" encoding="utf-8"?>
+<file path=ppt/slides/slide19.xml><?xml version="1.0" encoding="utf-8"?>
 <p:sld xmlns:a="http://schemas.openxmlformats.org/drawingml/2006/main" xmlns:r="http://schemas.openxmlformats.org/officeDocument/2006/relationships" xmlns:p="http://schemas.openxmlformats.org/presentationml/2006/main">
   <p:cSld name="Slide 14">
     <p:bg>
@@ -11318,7 +12444,7 @@
                 <a:ea typeface="Calibri" pitchFamily="34" charset="-122"/>
                 <a:cs typeface="Calibri" pitchFamily="34" charset="-120"/>
               </a:rPr>
-              <a:t>18</a:t>
+              <a:t>19</a:t>
             </a:r>
             <a:endParaRPr lang="en-US" sz="1000" dirty="0"/>
           </a:p>
@@ -12169,7 +13295,673 @@
 </p:sld>
 </file>
 
-<file path=ppt/slides/slide19.xml><?xml version="1.0" encoding="utf-8"?>
+<file path=ppt/slides/slide2.xml><?xml version="1.0" encoding="utf-8"?>
+<p:sld xmlns:a="http://schemas.openxmlformats.org/drawingml/2006/main" xmlns:p="http://schemas.openxmlformats.org/presentationml/2006/main" xmlns:r="http://schemas.openxmlformats.org/officeDocument/2006/relationships">
+  <p:cSld>
+    <p:spTree>
+      <p:nvGrpSpPr>
+        <p:cNvPr id="1" name=""/>
+        <p:cNvGrpSpPr/>
+        <p:nvPr/>
+      </p:nvGrpSpPr>
+      <p:grpSpPr/>
+      <p:pic>
+        <p:nvPicPr>
+          <p:cNvPr id="2" name="Image 0" descr="vu_mark_gold.png"/>
+          <p:cNvPicPr>
+            <a:picLocks noChangeAspect="1"/>
+          </p:cNvPicPr>
+          <p:nvPr/>
+        </p:nvPicPr>
+        <p:blipFill>
+          <a:blip r:embed="rId2"/>
+          <a:stretch>
+            <a:fillRect/>
+          </a:stretch>
+        </p:blipFill>
+        <p:spPr>
+          <a:xfrm>
+            <a:off x="11356848" y="310896"/>
+            <a:ext cx="384048" cy="274320"/>
+          </a:xfrm>
+          <a:prstGeom prst="rect">
+            <a:avLst/>
+          </a:prstGeom>
+        </p:spPr>
+      </p:pic>
+      <p:sp>
+        <p:nvSpPr>
+          <p:cNvPr id="3" name="Shape 0"/>
+          <p:cNvSpPr/>
+          <p:nvPr/>
+        </p:nvSpPr>
+        <p:spPr>
+          <a:xfrm>
+            <a:off x="566928" y="329184"/>
+            <a:ext cx="2413099" cy="310896"/>
+          </a:xfrm>
+          <a:prstGeom prst="roundRect">
+            <a:avLst>
+              <a:gd name="adj" fmla="val 50000"/>
+            </a:avLst>
+          </a:prstGeom>
+          <a:solidFill>
+            <a:srgbClr val="F2C879"/>
+          </a:solidFill>
+          <a:ln w="12700">
+            <a:solidFill>
+              <a:srgbClr val="F2C879"/>
+            </a:solidFill>
+            <a:prstDash val="solid"/>
+          </a:ln>
+        </p:spPr>
+        <p:txBody>
+          <a:bodyPr/>
+          <a:lstStyle/>
+          <a:p>
+            <a:endParaRPr lang="en-US"/>
+          </a:p>
+        </p:txBody>
+      </p:sp>
+      <p:sp>
+        <p:nvSpPr>
+          <p:cNvPr id="4" name="Text 1"/>
+          <p:cNvSpPr txBox="1"/>
+          <p:nvPr/>
+        </p:nvSpPr>
+        <p:spPr>
+          <a:xfrm>
+            <a:off x="566928" y="329184"/>
+            <a:ext cx="2413099" cy="310896"/>
+          </a:xfrm>
+          <a:prstGeom prst="rect">
+            <a:avLst/>
+          </a:prstGeom>
+          <a:noFill/>
+          <a:ln/>
+        </p:spPr>
+        <p:txBody>
+          <a:bodyPr wrap="square" lIns="0" tIns="0" rIns="0" bIns="0" rtlCol="0" anchor="ctr"/>
+          <a:lstStyle/>
+          <a:p>
+            <a:pPr marL="0" indent="0" algn="ctr">
+              <a:buNone/>
+            </a:pPr>
+            <a:r>
+              <a:rPr lang="en-US" sz="1050" b="1" kern="0" spc="110" dirty="0">
+                <a:solidFill>
+                  <a:srgbClr val="5A4415"/>
+                </a:solidFill>
+                <a:latin typeface="Arial" pitchFamily="34" charset="0"/>
+                <a:ea typeface="Arial" pitchFamily="34" charset="-122"/>
+                <a:cs typeface="Arial" pitchFamily="34" charset="-120"/>
+              </a:rPr>
+              <a:t>0–3 MIN  ·  FIRST THING</a:t>
+            </a:r>
+            <a:endParaRPr lang="en-US" sz="1050" dirty="0"/>
+          </a:p>
+        </p:txBody>
+      </p:sp>
+      <p:sp>
+        <p:nvSpPr>
+          <p:cNvPr id="5" name="Text 2"/>
+          <p:cNvSpPr txBox="1"/>
+          <p:nvPr/>
+        </p:nvSpPr>
+        <p:spPr>
+          <a:xfrm>
+            <a:off x="566928" y="749808"/>
+            <a:ext cx="10692079" cy="658368"/>
+          </a:xfrm>
+          <a:prstGeom prst="rect">
+            <a:avLst/>
+          </a:prstGeom>
+          <a:noFill/>
+          <a:ln/>
+        </p:spPr>
+        <p:txBody>
+          <a:bodyPr wrap="square" lIns="0" tIns="0" rIns="0" bIns="0" rtlCol="0" anchor="ctr"/>
+          <a:lstStyle/>
+          <a:p>
+            <a:pPr marL="0" indent="0">
+              <a:buNone/>
+            </a:pPr>
+            <a:r>
+              <a:rPr lang="en-US" sz="3300" b="1" dirty="0">
+                <a:solidFill>
+                  <a:srgbClr val="1C1C1C"/>
+                </a:solidFill>
+                <a:latin typeface="Arial" pitchFamily="34" charset="0"/>
+                <a:ea typeface="Arial" pitchFamily="34" charset="-122"/>
+                <a:cs typeface="Arial" pitchFamily="34" charset="-120"/>
+              </a:rPr>
+              <a:t>Before anything else — the pre-test</a:t>
+            </a:r>
+            <a:endParaRPr lang="en-US" sz="3300" dirty="0"/>
+          </a:p>
+        </p:txBody>
+      </p:sp>
+      <p:sp>
+        <p:nvSpPr>
+          <p:cNvPr id="6" name="Text 3"/>
+          <p:cNvSpPr txBox="1"/>
+          <p:nvPr/>
+        </p:nvSpPr>
+        <p:spPr>
+          <a:xfrm>
+            <a:off x="11430000" y="6419088"/>
+            <a:ext cx="320040" cy="228600"/>
+          </a:xfrm>
+          <a:prstGeom prst="rect">
+            <a:avLst/>
+          </a:prstGeom>
+          <a:noFill/>
+          <a:ln/>
+        </p:spPr>
+        <p:txBody>
+          <a:bodyPr wrap="square" lIns="0" tIns="0" rIns="0" bIns="0" rtlCol="0" anchor="ctr"/>
+          <a:lstStyle/>
+          <a:p>
+            <a:pPr marL="0" indent="0" algn="r">
+              <a:buNone/>
+            </a:pPr>
+            <a:r>
+              <a:rPr lang="en-US" sz="1000" dirty="0">
+                <a:solidFill>
+                  <a:srgbClr val="B5B5B5"/>
+                </a:solidFill>
+                <a:latin typeface="Calibri" pitchFamily="34" charset="0"/>
+                <a:ea typeface="Calibri" pitchFamily="34" charset="-122"/>
+                <a:cs typeface="Calibri" pitchFamily="34" charset="-120"/>
+              </a:rPr>
+              <a:t>2</a:t>
+            </a:r>
+            <a:endParaRPr lang="en-US" sz="1000" dirty="0"/>
+          </a:p>
+        </p:txBody>
+      </p:sp>
+      <p:sp>
+        <p:nvSpPr>
+          <p:cNvPr id="7" name="Shape 4"/>
+          <p:cNvSpPr/>
+          <p:nvPr/>
+        </p:nvSpPr>
+        <p:spPr>
+          <a:xfrm>
+            <a:off x="566928" y="1572768"/>
+            <a:ext cx="5532120" cy="2834640"/>
+          </a:xfrm>
+          <a:prstGeom prst="roundRect">
+            <a:avLst>
+              <a:gd name="adj" fmla="val 2903"/>
+            </a:avLst>
+          </a:prstGeom>
+          <a:solidFill>
+            <a:srgbClr val="FBF7EF"/>
+          </a:solidFill>
+          <a:ln w="12700">
+            <a:solidFill>
+              <a:srgbClr val="E6E6E6"/>
+            </a:solidFill>
+            <a:prstDash val="solid"/>
+          </a:ln>
+        </p:spPr>
+        <p:txBody>
+          <a:bodyPr/>
+          <a:lstStyle/>
+          <a:p>
+            <a:endParaRPr lang="en-US"/>
+          </a:p>
+        </p:txBody>
+      </p:sp>
+      <p:sp>
+        <p:nvSpPr>
+          <p:cNvPr id="8" name="Text 5"/>
+          <p:cNvSpPr txBox="1"/>
+          <p:nvPr/>
+        </p:nvSpPr>
+        <p:spPr>
+          <a:xfrm>
+            <a:off x="822960" y="1773936"/>
+            <a:ext cx="4937760" cy="237744"/>
+          </a:xfrm>
+          <a:prstGeom prst="rect">
+            <a:avLst/>
+          </a:prstGeom>
+          <a:noFill/>
+          <a:ln/>
+        </p:spPr>
+        <p:txBody>
+          <a:bodyPr wrap="square" lIns="0" tIns="0" rIns="0" bIns="0" rtlCol="0" anchor="ctr"/>
+          <a:lstStyle/>
+          <a:p>
+            <a:pPr marL="0" indent="0">
+              <a:buNone/>
+            </a:pPr>
+            <a:r>
+              <a:rPr lang="en-US" sz="1000" b="1" kern="0" spc="150" dirty="0">
+                <a:solidFill>
+                  <a:srgbClr val="8A6D3B"/>
+                </a:solidFill>
+                <a:latin typeface="Arial" pitchFamily="34" charset="0"/>
+                <a:ea typeface="Arial" pitchFamily="34" charset="-122"/>
+                <a:cs typeface="Arial" pitchFamily="34" charset="-120"/>
+              </a:rPr>
+              <a:t>WHAT IT IS</a:t>
+            </a:r>
+            <a:endParaRPr lang="en-US" sz="1000" dirty="0"/>
+          </a:p>
+        </p:txBody>
+      </p:sp>
+      <p:sp>
+        <p:nvSpPr>
+          <p:cNvPr id="9" name="Text 6"/>
+          <p:cNvSpPr txBox="1"/>
+          <p:nvPr/>
+        </p:nvSpPr>
+        <p:spPr>
+          <a:xfrm>
+            <a:off x="841248" y="2103120"/>
+            <a:ext cx="5029200" cy="2377440"/>
+          </a:xfrm>
+          <a:prstGeom prst="rect">
+            <a:avLst/>
+          </a:prstGeom>
+          <a:noFill/>
+          <a:ln/>
+        </p:spPr>
+        <p:txBody>
+          <a:bodyPr wrap="square" lIns="0" tIns="0" rIns="0" bIns="0" rtlCol="0" anchor="t"/>
+          <a:lstStyle/>
+          <a:p>
+            <a:pPr marL="203200" indent="-203200">
+              <a:lnSpc>
+                <a:spcPts val="1800"/>
+              </a:lnSpc>
+              <a:spcAft>
+                <a:spcPts val="1300"/>
+              </a:spcAft>
+              <a:buSzPct val="100000"/>
+              <a:buChar char="•"/>
+            </a:pPr>
+            <a:r>
+              <a:rPr lang="en-US" sz="1400" dirty="0">
+                <a:solidFill>
+                  <a:srgbClr val="3A3A3A"/>
+                </a:solidFill>
+                <a:latin typeface="Calibri" pitchFamily="34" charset="0"/>
+                <a:ea typeface="Calibri" pitchFamily="34" charset="-122"/>
+                <a:cs typeface="Calibri" pitchFamily="34" charset="-120"/>
+              </a:rPr>
+              <a:t>A few quick questions about how confident you feel about coding, plus one short written answer.</a:t>
+            </a:r>
+            <a:endParaRPr lang="en-US" sz="1400" dirty="0"/>
+          </a:p>
+          <a:p>
+            <a:pPr marL="203200" indent="-203200">
+              <a:lnSpc>
+                <a:spcPts val="1800"/>
+              </a:lnSpc>
+              <a:spcAft>
+                <a:spcPts val="1300"/>
+              </a:spcAft>
+              <a:buSzPct val="100000"/>
+              <a:buChar char="•"/>
+            </a:pPr>
+            <a:r>
+              <a:rPr lang="en-US" sz="1400" dirty="0">
+                <a:solidFill>
+                  <a:srgbClr val="3A3A3A"/>
+                </a:solidFill>
+                <a:latin typeface="Calibri" pitchFamily="34" charset="0"/>
+                <a:ea typeface="Calibri" pitchFamily="34" charset="-122"/>
+                <a:cs typeface="Calibri" pitchFamily="34" charset="-120"/>
+              </a:rPr>
+              <a:t>Two minutes. Your phone is fine.</a:t>
+            </a:r>
+            <a:endParaRPr lang="en-US" sz="1400" dirty="0"/>
+          </a:p>
+          <a:p>
+            <a:pPr marL="203200" indent="-203200">
+              <a:lnSpc>
+                <a:spcPts val="1800"/>
+              </a:lnSpc>
+              <a:spcAft>
+                <a:spcPts val="1300"/>
+              </a:spcAft>
+              <a:buSzPct val="100000"/>
+              <a:buChar char="•"/>
+            </a:pPr>
+            <a:r>
+              <a:rPr lang="en-US" sz="1400" dirty="0">
+                <a:solidFill>
+                  <a:srgbClr val="3A3A3A"/>
+                </a:solidFill>
+                <a:latin typeface="Calibri" pitchFamily="34" charset="0"/>
+                <a:ea typeface="Calibri" pitchFamily="34" charset="-122"/>
+                <a:cs typeface="Calibri" pitchFamily="34" charset="-120"/>
+              </a:rPr>
+              <a:t>It is not a test of knowledge. There is nothing to study and nothing to get wrong.</a:t>
+            </a:r>
+            <a:endParaRPr lang="en-US" sz="1400" dirty="0"/>
+          </a:p>
+        </p:txBody>
+      </p:sp>
+      <p:sp>
+        <p:nvSpPr>
+          <p:cNvPr id="10" name="Shape 7"/>
+          <p:cNvSpPr/>
+          <p:nvPr/>
+        </p:nvSpPr>
+        <p:spPr>
+          <a:xfrm>
+            <a:off x="6382512" y="1572768"/>
+            <a:ext cx="5230368" cy="2834640"/>
+          </a:xfrm>
+          <a:prstGeom prst="roundRect">
+            <a:avLst>
+              <a:gd name="adj" fmla="val 2903"/>
+            </a:avLst>
+          </a:prstGeom>
+          <a:solidFill>
+            <a:srgbClr val="FFFFFF"/>
+          </a:solidFill>
+          <a:ln w="12700">
+            <a:solidFill>
+              <a:srgbClr val="E6E6E6"/>
+            </a:solidFill>
+            <a:prstDash val="solid"/>
+          </a:ln>
+        </p:spPr>
+        <p:txBody>
+          <a:bodyPr/>
+          <a:lstStyle/>
+          <a:p>
+            <a:endParaRPr lang="en-US"/>
+          </a:p>
+        </p:txBody>
+      </p:sp>
+      <p:sp>
+        <p:nvSpPr>
+          <p:cNvPr id="11" name="Text 8"/>
+          <p:cNvSpPr txBox="1"/>
+          <p:nvPr/>
+        </p:nvSpPr>
+        <p:spPr>
+          <a:xfrm>
+            <a:off x="6638544" y="1773936"/>
+            <a:ext cx="4754880" cy="237744"/>
+          </a:xfrm>
+          <a:prstGeom prst="rect">
+            <a:avLst/>
+          </a:prstGeom>
+          <a:noFill/>
+          <a:ln/>
+        </p:spPr>
+        <p:txBody>
+          <a:bodyPr wrap="square" lIns="0" tIns="0" rIns="0" bIns="0" rtlCol="0" anchor="ctr"/>
+          <a:lstStyle/>
+          <a:p>
+            <a:pPr marL="0" indent="0">
+              <a:buNone/>
+            </a:pPr>
+            <a:r>
+              <a:rPr lang="en-US" sz="1000" b="1" kern="0" spc="150" dirty="0">
+                <a:solidFill>
+                  <a:srgbClr val="6B7A88"/>
+                </a:solidFill>
+                <a:latin typeface="Arial" pitchFamily="34" charset="0"/>
+                <a:ea typeface="Arial" pitchFamily="34" charset="-122"/>
+                <a:cs typeface="Arial" pitchFamily="34" charset="-120"/>
+              </a:rPr>
+              <a:t>WHY WE ASK</a:t>
+            </a:r>
+            <a:endParaRPr lang="en-US" sz="1000" dirty="0"/>
+          </a:p>
+        </p:txBody>
+      </p:sp>
+      <p:sp>
+        <p:nvSpPr>
+          <p:cNvPr id="12" name="Text 9"/>
+          <p:cNvSpPr txBox="1"/>
+          <p:nvPr/>
+        </p:nvSpPr>
+        <p:spPr>
+          <a:xfrm>
+            <a:off x="6656832" y="2103120"/>
+            <a:ext cx="4754880" cy="2377440"/>
+          </a:xfrm>
+          <a:prstGeom prst="rect">
+            <a:avLst/>
+          </a:prstGeom>
+          <a:noFill/>
+          <a:ln/>
+        </p:spPr>
+        <p:txBody>
+          <a:bodyPr wrap="square" lIns="0" tIns="0" rIns="0" bIns="0" rtlCol="0" anchor="t"/>
+          <a:lstStyle/>
+          <a:p>
+            <a:pPr marL="203200" indent="-203200">
+              <a:lnSpc>
+                <a:spcPts val="1800"/>
+              </a:lnSpc>
+              <a:spcAft>
+                <a:spcPts val="1300"/>
+              </a:spcAft>
+              <a:buSzPct val="100000"/>
+              <a:buChar char="•"/>
+            </a:pPr>
+            <a:r>
+              <a:rPr lang="en-US" sz="1400" dirty="0">
+                <a:solidFill>
+                  <a:srgbClr val="3A3A3A"/>
+                </a:solidFill>
+                <a:latin typeface="Calibri" pitchFamily="34" charset="0"/>
+                <a:ea typeface="Calibri" pitchFamily="34" charset="-122"/>
+                <a:cs typeface="Calibri" pitchFamily="34" charset="-120"/>
+              </a:rPr>
+              <a:t>Graded on completion, not correctness — submitting it is full marks.</a:t>
+            </a:r>
+            <a:endParaRPr lang="en-US" sz="1400" dirty="0"/>
+          </a:p>
+          <a:p>
+            <a:pPr marL="203200" indent="-203200">
+              <a:lnSpc>
+                <a:spcPts val="1800"/>
+              </a:lnSpc>
+              <a:spcAft>
+                <a:spcPts val="1300"/>
+              </a:spcAft>
+              <a:buSzPct val="100000"/>
+              <a:buChar char="•"/>
+            </a:pPr>
+            <a:r>
+              <a:rPr lang="en-US" sz="1400" dirty="0">
+                <a:solidFill>
+                  <a:srgbClr val="3A3A3A"/>
+                </a:solidFill>
+                <a:latin typeface="Calibri" pitchFamily="34" charset="0"/>
+                <a:ea typeface="Calibri" pitchFamily="34" charset="-122"/>
+                <a:cs typeface="Calibri" pitchFamily="34" charset="-120"/>
+              </a:rPr>
+              <a:t>We run the same survey again at the end of the semester.</a:t>
+            </a:r>
+            <a:endParaRPr lang="en-US" sz="1400" dirty="0"/>
+          </a:p>
+          <a:p>
+            <a:pPr marL="203200" indent="-203200">
+              <a:lnSpc>
+                <a:spcPts val="1800"/>
+              </a:lnSpc>
+              <a:spcAft>
+                <a:spcPts val="1300"/>
+              </a:spcAft>
+              <a:buSzPct val="100000"/>
+              <a:buChar char="•"/>
+            </a:pPr>
+            <a:r>
+              <a:rPr lang="en-US" sz="1400" dirty="0">
+                <a:solidFill>
+                  <a:srgbClr val="3A3A3A"/>
+                </a:solidFill>
+                <a:latin typeface="Calibri" pitchFamily="34" charset="0"/>
+                <a:ea typeface="Calibri" pitchFamily="34" charset="-122"/>
+                <a:cs typeface="Calibri" pitchFamily="34" charset="-120"/>
+              </a:rPr>
+              <a:t>Comparing the two is how we find out whether this course actually worked.</a:t>
+            </a:r>
+            <a:endParaRPr lang="en-US" sz="1400" dirty="0"/>
+          </a:p>
+          <a:p>
+            <a:pPr marL="203200" indent="-203200">
+              <a:lnSpc>
+                <a:spcPts val="1800"/>
+              </a:lnSpc>
+              <a:spcAft>
+                <a:spcPts val="1300"/>
+              </a:spcAft>
+              <a:buSzPct val="100000"/>
+              <a:buChar char="•"/>
+            </a:pPr>
+            <a:r>
+              <a:rPr lang="en-US" sz="1400" dirty="0">
+                <a:solidFill>
+                  <a:srgbClr val="3A3A3A"/>
+                </a:solidFill>
+                <a:latin typeface="Calibri" pitchFamily="34" charset="0"/>
+                <a:ea typeface="Calibri" pitchFamily="34" charset="-122"/>
+                <a:cs typeface="Calibri" pitchFamily="34" charset="-120"/>
+              </a:rPr>
+              <a:t>So answer honestly. “Not confident at all” is a genuinely useful answer.</a:t>
+            </a:r>
+            <a:endParaRPr lang="en-US" sz="1400" dirty="0"/>
+          </a:p>
+        </p:txBody>
+      </p:sp>
+      <p:sp>
+        <p:nvSpPr>
+          <p:cNvPr id="13" name="Shape 10"/>
+          <p:cNvSpPr/>
+          <p:nvPr/>
+        </p:nvSpPr>
+        <p:spPr>
+          <a:xfrm>
+            <a:off x="566928" y="4754880"/>
+            <a:ext cx="11057839" cy="1207008"/>
+          </a:xfrm>
+          <a:prstGeom prst="roundRect">
+            <a:avLst>
+              <a:gd name="adj" fmla="val 6818"/>
+            </a:avLst>
+          </a:prstGeom>
+          <a:solidFill>
+            <a:srgbClr val="1C1C1C"/>
+          </a:solidFill>
+          <a:ln w="12700">
+            <a:solidFill>
+              <a:srgbClr val="1C1C1C"/>
+            </a:solidFill>
+            <a:prstDash val="solid"/>
+          </a:ln>
+        </p:spPr>
+        <p:txBody>
+          <a:bodyPr/>
+          <a:lstStyle/>
+          <a:p>
+            <a:endParaRPr lang="en-US"/>
+          </a:p>
+        </p:txBody>
+      </p:sp>
+      <p:sp>
+        <p:nvSpPr>
+          <p:cNvPr id="14" name="Text 11"/>
+          <p:cNvSpPr txBox="1"/>
+          <p:nvPr/>
+        </p:nvSpPr>
+        <p:spPr>
+          <a:xfrm>
+            <a:off x="886968" y="4956048"/>
+            <a:ext cx="5486400" cy="237744"/>
+          </a:xfrm>
+          <a:prstGeom prst="rect">
+            <a:avLst/>
+          </a:prstGeom>
+          <a:noFill/>
+          <a:ln/>
+        </p:spPr>
+        <p:txBody>
+          <a:bodyPr wrap="square" lIns="0" tIns="0" rIns="0" bIns="0" rtlCol="0" anchor="ctr"/>
+          <a:lstStyle/>
+          <a:p>
+            <a:pPr marL="0" indent="0">
+              <a:buNone/>
+            </a:pPr>
+            <a:r>
+              <a:rPr lang="en-US" sz="950" b="1" kern="0" spc="160" dirty="0">
+                <a:solidFill>
+                  <a:srgbClr val="D9A441"/>
+                </a:solidFill>
+                <a:latin typeface="Arial" pitchFamily="34" charset="0"/>
+                <a:ea typeface="Arial" pitchFamily="34" charset="-122"/>
+                <a:cs typeface="Arial" pitchFamily="34" charset="-120"/>
+              </a:rPr>
+              <a:t>TAKE IT NOW  ·  ALSO LINKED ON BRIGHTSPACE</a:t>
+            </a:r>
+            <a:endParaRPr lang="en-US" sz="950" dirty="0"/>
+          </a:p>
+        </p:txBody>
+      </p:sp>
+      <p:sp>
+        <p:nvSpPr>
+          <p:cNvPr id="15" name="Text 12"/>
+          <p:cNvSpPr txBox="1"/>
+          <p:nvPr/>
+        </p:nvSpPr>
+        <p:spPr>
+          <a:xfrm>
+            <a:off x="886968" y="5230368"/>
+            <a:ext cx="10424160" cy="713232"/>
+          </a:xfrm>
+          <a:prstGeom prst="rect">
+            <a:avLst/>
+          </a:prstGeom>
+          <a:noFill/>
+          <a:ln/>
+        </p:spPr>
+        <p:txBody>
+          <a:bodyPr wrap="square" lIns="0" tIns="0" rIns="0" bIns="0" rtlCol="0" anchor="t"/>
+          <a:lstStyle/>
+          <a:p>
+            <a:pPr marL="0" indent="0">
+              <a:lnSpc>
+                <a:spcPts val="2400"/>
+              </a:lnSpc>
+              <a:buNone/>
+            </a:pPr>
+            <a:r>
+              <a:rPr lang="en-US" sz="3000" b="1" dirty="0">
+                <a:solidFill>
+                  <a:srgbClr val="FFFFFF"/>
+                </a:solidFill>
+                <a:latin typeface="Arial" pitchFamily="34" charset="0"/>
+                <a:ea typeface="Arial" pitchFamily="34" charset="-122"/>
+                <a:cs typeface="Arial" pitchFamily="34" charset="-120"/>
+              </a:rPr>
+              <a:t>forms.cloud.microsoft/r/ee6cN6cpkz</a:t>
+            </a:r>
+            <a:endParaRPr lang="en-US" sz="1800" dirty="0"/>
+          </a:p>
+        </p:txBody>
+      </p:sp>
+    </p:spTree>
+  </p:cSld>
+  <p:clrMapOvr>
+    <a:masterClrMapping/>
+  </p:clrMapOvr>
+</p:sld>
+</file>
+
+<file path=ppt/slides/slide20.xml><?xml version="1.0" encoding="utf-8"?>
 <p:sld xmlns:a="http://schemas.openxmlformats.org/drawingml/2006/main" xmlns:r="http://schemas.openxmlformats.org/officeDocument/2006/relationships" xmlns:p="http://schemas.openxmlformats.org/presentationml/2006/main">
   <p:cSld name="Slide 15">
     <p:bg>
@@ -12363,7 +14155,7 @@
                 <a:ea typeface="Calibri" pitchFamily="34" charset="-122"/>
                 <a:cs typeface="Calibri" pitchFamily="34" charset="-120"/>
               </a:rPr>
-              <a:t>19</a:t>
+              <a:t>20</a:t>
             </a:r>
             <a:endParaRPr lang="en-US" sz="1000" dirty="0"/>
           </a:p>
@@ -13106,7 +14898,724 @@
 </p:sld>
 </file>
 
-<file path=ppt/slides/slide2.xml><?xml version="1.0" encoding="utf-8"?>
+<file path=ppt/slides/slide21.xml><?xml version="1.0" encoding="utf-8"?>
+<p:sld xmlns:a="http://schemas.openxmlformats.org/drawingml/2006/main" xmlns:r="http://schemas.openxmlformats.org/officeDocument/2006/relationships" xmlns:p="http://schemas.openxmlformats.org/presentationml/2006/main">
+  <p:cSld name="Slide 16">
+    <p:bg>
+      <p:bgPr>
+        <a:solidFill>
+          <a:srgbClr val="FFFFFF"/>
+        </a:solidFill>
+        <a:effectLst/>
+      </p:bgPr>
+    </p:bg>
+    <p:spTree>
+      <p:nvGrpSpPr>
+        <p:cNvPr id="1" name=""/>
+        <p:cNvGrpSpPr/>
+        <p:nvPr/>
+      </p:nvGrpSpPr>
+      <p:grpSpPr>
+        <a:xfrm>
+          <a:off x="0" y="0"/>
+          <a:ext cx="0" cy="0"/>
+          <a:chOff x="0" y="0"/>
+          <a:chExt cx="0" cy="0"/>
+        </a:xfrm>
+      </p:grpSpPr>
+      <p:pic>
+        <p:nvPicPr>
+          <p:cNvPr id="2" name="Image 0" descr="vu_mark_gold.png"/>
+          <p:cNvPicPr>
+            <a:picLocks noChangeAspect="1"/>
+          </p:cNvPicPr>
+          <p:nvPr/>
+        </p:nvPicPr>
+        <p:blipFill>
+          <a:blip r:embed="rId3"/>
+          <a:stretch>
+            <a:fillRect/>
+          </a:stretch>
+        </p:blipFill>
+        <p:spPr>
+          <a:xfrm>
+            <a:off x="11356848" y="310896"/>
+            <a:ext cx="384048" cy="274320"/>
+          </a:xfrm>
+          <a:prstGeom prst="rect">
+            <a:avLst/>
+          </a:prstGeom>
+        </p:spPr>
+      </p:pic>
+      <p:sp>
+        <p:nvSpPr>
+          <p:cNvPr id="3" name="Shape 0"/>
+          <p:cNvSpPr/>
+          <p:nvPr/>
+        </p:nvSpPr>
+        <p:spPr>
+          <a:xfrm>
+            <a:off x="566928" y="329184"/>
+            <a:ext cx="1562710" cy="310896"/>
+          </a:xfrm>
+          <a:prstGeom prst="roundRect">
+            <a:avLst>
+              <a:gd name="adj" fmla="val 50000"/>
+            </a:avLst>
+          </a:prstGeom>
+          <a:solidFill>
+            <a:srgbClr val="F2C879"/>
+          </a:solidFill>
+          <a:ln w="12700">
+            <a:solidFill>
+              <a:srgbClr val="F2C879"/>
+            </a:solidFill>
+            <a:prstDash val="solid"/>
+          </a:ln>
+        </p:spPr>
+        <p:txBody>
+          <a:bodyPr/>
+          <a:lstStyle/>
+          <a:p>
+            <a:endParaRPr lang="en-US"/>
+          </a:p>
+        </p:txBody>
+      </p:sp>
+      <p:sp>
+        <p:nvSpPr>
+          <p:cNvPr id="4" name="Text 1"/>
+          <p:cNvSpPr txBox="1"/>
+          <p:nvPr/>
+        </p:nvSpPr>
+        <p:spPr>
+          <a:xfrm>
+            <a:off x="566928" y="329184"/>
+            <a:ext cx="1562710" cy="310896"/>
+          </a:xfrm>
+          <a:prstGeom prst="rect">
+            <a:avLst/>
+          </a:prstGeom>
+          <a:noFill/>
+          <a:ln/>
+        </p:spPr>
+        <p:txBody>
+          <a:bodyPr wrap="square" lIns="0" tIns="0" rIns="0" bIns="0" rtlCol="0" anchor="ctr"/>
+          <a:lstStyle/>
+          <a:p>
+            <a:pPr marL="0" indent="0" algn="ctr">
+              <a:buNone/>
+            </a:pPr>
+            <a:r>
+              <a:rPr lang="en-US" sz="1050" b="1" kern="0" spc="110" dirty="0">
+                <a:solidFill>
+                  <a:srgbClr val="5A4415"/>
+                </a:solidFill>
+                <a:latin typeface="Arial" pitchFamily="34" charset="0"/>
+                <a:ea typeface="Arial" pitchFamily="34" charset="-122"/>
+                <a:cs typeface="Arial" pitchFamily="34" charset="-120"/>
+              </a:rPr>
+              <a:t>BEFORE YOU GO</a:t>
+            </a:r>
+            <a:endParaRPr lang="en-US" sz="1050" dirty="0"/>
+          </a:p>
+        </p:txBody>
+      </p:sp>
+      <p:sp>
+        <p:nvSpPr>
+          <p:cNvPr id="5" name="Text 2"/>
+          <p:cNvSpPr txBox="1"/>
+          <p:nvPr/>
+        </p:nvSpPr>
+        <p:spPr>
+          <a:xfrm>
+            <a:off x="566928" y="749808"/>
+            <a:ext cx="10692079" cy="658368"/>
+          </a:xfrm>
+          <a:prstGeom prst="rect">
+            <a:avLst/>
+          </a:prstGeom>
+          <a:noFill/>
+          <a:ln/>
+        </p:spPr>
+        <p:txBody>
+          <a:bodyPr wrap="square" lIns="0" tIns="0" rIns="0" bIns="0" rtlCol="0" anchor="ctr"/>
+          <a:lstStyle/>
+          <a:p>
+            <a:pPr marL="0" indent="0">
+              <a:buNone/>
+            </a:pPr>
+            <a:r>
+              <a:rPr lang="en-US" sz="3300" b="1" dirty="0">
+                <a:solidFill>
+                  <a:srgbClr val="1C1C1C"/>
+                </a:solidFill>
+                <a:latin typeface="Arial" pitchFamily="34" charset="0"/>
+                <a:ea typeface="Arial" pitchFamily="34" charset="-122"/>
+                <a:cs typeface="Arial" pitchFamily="34" charset="-120"/>
+              </a:rPr>
+              <a:t>Before next week</a:t>
+            </a:r>
+            <a:endParaRPr lang="en-US" sz="3300" dirty="0"/>
+          </a:p>
+        </p:txBody>
+      </p:sp>
+      <p:sp>
+        <p:nvSpPr>
+          <p:cNvPr id="6" name="Text 3"/>
+          <p:cNvSpPr txBox="1"/>
+          <p:nvPr/>
+        </p:nvSpPr>
+        <p:spPr>
+          <a:xfrm>
+            <a:off x="11430000" y="6419088"/>
+            <a:ext cx="320040" cy="228600"/>
+          </a:xfrm>
+          <a:prstGeom prst="rect">
+            <a:avLst/>
+          </a:prstGeom>
+          <a:noFill/>
+          <a:ln/>
+        </p:spPr>
+        <p:txBody>
+          <a:bodyPr wrap="square" lIns="0" tIns="0" rIns="0" bIns="0" rtlCol="0" anchor="ctr"/>
+          <a:lstStyle/>
+          <a:p>
+            <a:pPr marL="0" indent="0" algn="r">
+              <a:buNone/>
+            </a:pPr>
+            <a:r>
+              <a:rPr lang="en-US" sz="1000" dirty="0">
+                <a:solidFill>
+                  <a:srgbClr val="B5B5B5"/>
+                </a:solidFill>
+                <a:latin typeface="Calibri" pitchFamily="34" charset="0"/>
+                <a:ea typeface="Calibri" pitchFamily="34" charset="-122"/>
+                <a:cs typeface="Calibri" pitchFamily="34" charset="-120"/>
+              </a:rPr>
+              <a:t>21</a:t>
+            </a:r>
+            <a:endParaRPr lang="en-US" sz="1000" dirty="0"/>
+          </a:p>
+        </p:txBody>
+      </p:sp>
+      <p:sp>
+        <p:nvSpPr>
+          <p:cNvPr id="7" name="Shape 4"/>
+          <p:cNvSpPr/>
+          <p:nvPr/>
+        </p:nvSpPr>
+        <p:spPr>
+          <a:xfrm>
+            <a:off x="566928" y="1572768"/>
+            <a:ext cx="5532120" cy="2834640"/>
+          </a:xfrm>
+          <a:prstGeom prst="roundRect">
+            <a:avLst>
+              <a:gd name="adj" fmla="val 2903"/>
+            </a:avLst>
+          </a:prstGeom>
+          <a:solidFill>
+            <a:srgbClr val="FBF7EF"/>
+          </a:solidFill>
+          <a:ln w="12700">
+            <a:solidFill>
+              <a:srgbClr val="E6E6E6"/>
+            </a:solidFill>
+            <a:prstDash val="solid"/>
+          </a:ln>
+        </p:spPr>
+        <p:txBody>
+          <a:bodyPr/>
+          <a:lstStyle/>
+          <a:p>
+            <a:endParaRPr lang="en-US"/>
+          </a:p>
+        </p:txBody>
+      </p:sp>
+      <p:sp>
+        <p:nvSpPr>
+          <p:cNvPr id="8" name="Text 5"/>
+          <p:cNvSpPr txBox="1"/>
+          <p:nvPr/>
+        </p:nvSpPr>
+        <p:spPr>
+          <a:xfrm>
+            <a:off x="822960" y="1773936"/>
+            <a:ext cx="4937760" cy="237744"/>
+          </a:xfrm>
+          <a:prstGeom prst="rect">
+            <a:avLst/>
+          </a:prstGeom>
+          <a:noFill/>
+          <a:ln/>
+        </p:spPr>
+        <p:txBody>
+          <a:bodyPr wrap="square" lIns="0" tIns="0" rIns="0" bIns="0" rtlCol="0" anchor="ctr"/>
+          <a:lstStyle/>
+          <a:p>
+            <a:pPr marL="0" indent="0">
+              <a:buNone/>
+            </a:pPr>
+            <a:r>
+              <a:rPr lang="en-US" sz="1000" b="1" kern="0" spc="150" dirty="0">
+                <a:solidFill>
+                  <a:srgbClr val="8A6D3B"/>
+                </a:solidFill>
+                <a:latin typeface="Arial" pitchFamily="34" charset="0"/>
+                <a:ea typeface="Arial" pitchFamily="34" charset="-122"/>
+                <a:cs typeface="Arial" pitchFamily="34" charset="-120"/>
+              </a:rPr>
+              <a:t>REQUIRED</a:t>
+            </a:r>
+            <a:endParaRPr lang="en-US" sz="1000" dirty="0"/>
+          </a:p>
+        </p:txBody>
+      </p:sp>
+      <p:sp>
+        <p:nvSpPr>
+          <p:cNvPr id="9" name="Text 6"/>
+          <p:cNvSpPr txBox="1"/>
+          <p:nvPr/>
+        </p:nvSpPr>
+        <p:spPr>
+          <a:xfrm>
+            <a:off x="841248" y="2103120"/>
+            <a:ext cx="5029200" cy="2377440"/>
+          </a:xfrm>
+          <a:prstGeom prst="rect">
+            <a:avLst/>
+          </a:prstGeom>
+          <a:noFill/>
+          <a:ln/>
+        </p:spPr>
+        <p:txBody>
+          <a:bodyPr wrap="square" lIns="0" tIns="0" rIns="0" bIns="0" rtlCol="0" anchor="t"/>
+          <a:lstStyle/>
+          <a:p>
+            <a:pPr marL="203200" indent="-203200">
+              <a:lnSpc>
+                <a:spcPts val="1800"/>
+              </a:lnSpc>
+              <a:spcAft>
+                <a:spcPts val="1300"/>
+              </a:spcAft>
+              <a:buSzPct val="100000"/>
+              <a:buChar char="•"/>
+            </a:pPr>
+            <a:r>
+              <a:rPr lang="en-US" sz="1400" dirty="0">
+                <a:solidFill>
+                  <a:srgbClr val="3A3A3A"/>
+                </a:solidFill>
+                <a:latin typeface="Calibri" pitchFamily="34" charset="0"/>
+                <a:ea typeface="Calibri" pitchFamily="34" charset="-122"/>
+                <a:cs typeface="Calibri" pitchFamily="34" charset="-120"/>
+              </a:rPr>
+              <a:t>Finish your installs — the written guide is on Brightspace.</a:t>
+            </a:r>
+            <a:endParaRPr lang="en-US" sz="1400" dirty="0"/>
+          </a:p>
+          <a:p>
+            <a:pPr marL="203200" indent="-203200">
+              <a:lnSpc>
+                <a:spcPts val="1800"/>
+              </a:lnSpc>
+              <a:spcAft>
+                <a:spcPts val="1300"/>
+              </a:spcAft>
+              <a:buSzPct val="100000"/>
+              <a:buChar char="•"/>
+            </a:pPr>
+            <a:r>
+              <a:rPr lang="en-US" sz="1400" dirty="0">
+                <a:solidFill>
+                  <a:srgbClr val="3A3A3A"/>
+                </a:solidFill>
+                <a:latin typeface="Calibri" pitchFamily="34" charset="0"/>
+                <a:ea typeface="Calibri" pitchFamily="34" charset="-122"/>
+                <a:cs typeface="Calibri" pitchFamily="34" charset="-120"/>
+              </a:rPr>
+              <a:t>Run the check script and fix whatever it names.</a:t>
+            </a:r>
+            <a:endParaRPr lang="en-US" sz="1400" dirty="0"/>
+          </a:p>
+          <a:p>
+            <a:pPr marL="203200" indent="-203200">
+              <a:lnSpc>
+                <a:spcPts val="1800"/>
+              </a:lnSpc>
+              <a:spcAft>
+                <a:spcPts val="1300"/>
+              </a:spcAft>
+              <a:buSzPct val="100000"/>
+              <a:buChar char="•"/>
+            </a:pPr>
+            <a:r>
+              <a:rPr lang="en-US" sz="1400" dirty="0">
+                <a:solidFill>
+                  <a:srgbClr val="3A3A3A"/>
+                </a:solidFill>
+                <a:latin typeface="Calibri" pitchFamily="34" charset="0"/>
+                <a:ea typeface="Calibri" pitchFamily="34" charset="-122"/>
+                <a:cs typeface="Calibri" pitchFamily="34" charset="-120"/>
+              </a:rPr>
+              <a:t>Do the Session 1 tutor activity and post the transcript — this is your participation grade.</a:t>
+            </a:r>
+            <a:endParaRPr lang="en-US" sz="1400" dirty="0"/>
+          </a:p>
+          <a:p>
+            <a:pPr marL="203200" indent="-203200">
+              <a:lnSpc>
+                <a:spcPts val="1800"/>
+              </a:lnSpc>
+              <a:spcAft>
+                <a:spcPts val="1300"/>
+              </a:spcAft>
+              <a:buSzPct val="100000"/>
+              <a:buChar char="•"/>
+            </a:pPr>
+            <a:r>
+              <a:rPr lang="en-US" sz="1400" dirty="0">
+                <a:solidFill>
+                  <a:srgbClr val="3A3A3A"/>
+                </a:solidFill>
+                <a:latin typeface="Calibri" pitchFamily="34" charset="0"/>
+                <a:ea typeface="Calibri" pitchFamily="34" charset="-122"/>
+                <a:cs typeface="Calibri" pitchFamily="34" charset="-120"/>
+              </a:rPr>
+              <a:t>Set up Copilot: make a GitHub account, apply for student access, then add the extension.</a:t>
+            </a:r>
+            <a:endParaRPr lang="en-US" sz="1400" dirty="0"/>
+          </a:p>
+          <a:p>
+            <a:pPr marL="203200" indent="-203200">
+              <a:lnSpc>
+                <a:spcPts val="1800"/>
+              </a:lnSpc>
+              <a:spcAft>
+                <a:spcPts val="1300"/>
+              </a:spcAft>
+              <a:buSzPct val="100000"/>
+              <a:buChar char="•"/>
+            </a:pPr>
+            <a:r>
+              <a:rPr lang="en-US" sz="1400" dirty="0">
+                <a:solidFill>
+                  <a:srgbClr val="3A3A3A"/>
+                </a:solidFill>
+                <a:latin typeface="Calibri" pitchFamily="34" charset="0"/>
+                <a:ea typeface="Calibri" pitchFamily="34" charset="-122"/>
+                <a:cs typeface="Calibri" pitchFamily="34" charset="-120"/>
+              </a:rPr>
+              <a:t>Missed the pre-test? forms.cloud.microsoft/r/ee6cN6cpkz</a:t>
+            </a:r>
+            <a:endParaRPr lang="en-US" sz="1400" dirty="0"/>
+          </a:p>
+        </p:txBody>
+      </p:sp>
+      <p:sp>
+        <p:nvSpPr>
+          <p:cNvPr id="10" name="Shape 7"/>
+          <p:cNvSpPr/>
+          <p:nvPr/>
+        </p:nvSpPr>
+        <p:spPr>
+          <a:xfrm>
+            <a:off x="6382512" y="1572768"/>
+            <a:ext cx="5230368" cy="2834640"/>
+          </a:xfrm>
+          <a:prstGeom prst="roundRect">
+            <a:avLst>
+              <a:gd name="adj" fmla="val 2903"/>
+            </a:avLst>
+          </a:prstGeom>
+          <a:solidFill>
+            <a:srgbClr val="FFFFFF"/>
+          </a:solidFill>
+          <a:ln w="12700">
+            <a:solidFill>
+              <a:srgbClr val="E6E6E6"/>
+            </a:solidFill>
+            <a:prstDash val="solid"/>
+          </a:ln>
+        </p:spPr>
+        <p:txBody>
+          <a:bodyPr/>
+          <a:lstStyle/>
+          <a:p>
+            <a:endParaRPr lang="en-US"/>
+          </a:p>
+        </p:txBody>
+      </p:sp>
+      <p:sp>
+        <p:nvSpPr>
+          <p:cNvPr id="11" name="Text 8"/>
+          <p:cNvSpPr txBox="1"/>
+          <p:nvPr/>
+        </p:nvSpPr>
+        <p:spPr>
+          <a:xfrm>
+            <a:off x="6638544" y="1773936"/>
+            <a:ext cx="4754880" cy="237744"/>
+          </a:xfrm>
+          <a:prstGeom prst="rect">
+            <a:avLst/>
+          </a:prstGeom>
+          <a:noFill/>
+          <a:ln/>
+        </p:spPr>
+        <p:txBody>
+          <a:bodyPr wrap="square" lIns="0" tIns="0" rIns="0" bIns="0" rtlCol="0" anchor="ctr"/>
+          <a:lstStyle/>
+          <a:p>
+            <a:pPr marL="0" indent="0">
+              <a:buNone/>
+            </a:pPr>
+            <a:r>
+              <a:rPr lang="en-US" sz="1000" b="1" kern="0" spc="150" dirty="0">
+                <a:solidFill>
+                  <a:srgbClr val="6B7A88"/>
+                </a:solidFill>
+                <a:latin typeface="Arial" pitchFamily="34" charset="0"/>
+                <a:ea typeface="Arial" pitchFamily="34" charset="-122"/>
+                <a:cs typeface="Arial" pitchFamily="34" charset="-120"/>
+              </a:rPr>
+              <a:t>START THINKING ABOUT</a:t>
+            </a:r>
+            <a:endParaRPr lang="en-US" sz="1000" dirty="0"/>
+          </a:p>
+        </p:txBody>
+      </p:sp>
+      <p:sp>
+        <p:nvSpPr>
+          <p:cNvPr id="12" name="Text 9"/>
+          <p:cNvSpPr txBox="1"/>
+          <p:nvPr/>
+        </p:nvSpPr>
+        <p:spPr>
+          <a:xfrm>
+            <a:off x="6656832" y="2103120"/>
+            <a:ext cx="4754880" cy="2377440"/>
+          </a:xfrm>
+          <a:prstGeom prst="rect">
+            <a:avLst/>
+          </a:prstGeom>
+          <a:noFill/>
+          <a:ln/>
+        </p:spPr>
+        <p:txBody>
+          <a:bodyPr wrap="square" lIns="0" tIns="0" rIns="0" bIns="0" rtlCol="0" anchor="t"/>
+          <a:lstStyle/>
+          <a:p>
+            <a:pPr marL="203200" indent="-203200">
+              <a:lnSpc>
+                <a:spcPts val="1800"/>
+              </a:lnSpc>
+              <a:spcAft>
+                <a:spcPts val="1300"/>
+              </a:spcAft>
+              <a:buSzPct val="100000"/>
+              <a:buChar char="•"/>
+            </a:pPr>
+            <a:r>
+              <a:rPr lang="en-US" sz="1400" dirty="0">
+                <a:solidFill>
+                  <a:srgbClr val="3A3A3A"/>
+                </a:solidFill>
+                <a:latin typeface="Calibri" pitchFamily="34" charset="0"/>
+                <a:ea typeface="Calibri" pitchFamily="34" charset="-122"/>
+                <a:cs typeface="Calibri" pitchFamily="34" charset="-120"/>
+              </a:rPr>
+              <a:t>Your project dataset. Choose by Session 4, register by Session 6.</a:t>
+            </a:r>
+            <a:endParaRPr lang="en-US" sz="1400" dirty="0"/>
+          </a:p>
+          <a:p>
+            <a:pPr marL="203200" indent="-203200">
+              <a:lnSpc>
+                <a:spcPts val="1800"/>
+              </a:lnSpc>
+              <a:spcAft>
+                <a:spcPts val="1300"/>
+              </a:spcAft>
+              <a:buSzPct val="100000"/>
+              <a:buChar char="•"/>
+            </a:pPr>
+            <a:r>
+              <a:rPr lang="en-US" sz="1400" dirty="0">
+                <a:solidFill>
+                  <a:srgbClr val="3A3A3A"/>
+                </a:solidFill>
+                <a:latin typeface="Calibri" pitchFamily="34" charset="0"/>
+                <a:ea typeface="Calibri" pitchFamily="34" charset="-122"/>
+                <a:cs typeface="Calibri" pitchFamily="34" charset="-120"/>
+              </a:rPr>
+              <a:t>Browse the dataset list on the course research guide.</a:t>
+            </a:r>
+            <a:endParaRPr lang="en-US" sz="1400" dirty="0"/>
+          </a:p>
+          <a:p>
+            <a:pPr marL="203200" indent="-203200">
+              <a:lnSpc>
+                <a:spcPts val="1800"/>
+              </a:lnSpc>
+              <a:spcAft>
+                <a:spcPts val="1300"/>
+              </a:spcAft>
+              <a:buSzPct val="100000"/>
+              <a:buChar char="•"/>
+            </a:pPr>
+            <a:r>
+              <a:rPr lang="en-US" sz="1400" dirty="0">
+                <a:solidFill>
+                  <a:srgbClr val="3A3A3A"/>
+                </a:solidFill>
+                <a:latin typeface="Calibri" pitchFamily="34" charset="0"/>
+                <a:ea typeface="Calibri" pitchFamily="34" charset="-122"/>
+                <a:cs typeface="Calibri" pitchFamily="34" charset="-120"/>
+              </a:rPr>
+              <a:t>Best option by far: data you already have, or already want.</a:t>
+            </a:r>
+            <a:endParaRPr lang="en-US" sz="1400" dirty="0"/>
+          </a:p>
+        </p:txBody>
+      </p:sp>
+      <p:sp>
+        <p:nvSpPr>
+          <p:cNvPr id="13" name="Shape 10"/>
+          <p:cNvSpPr/>
+          <p:nvPr/>
+        </p:nvSpPr>
+        <p:spPr>
+          <a:xfrm>
+            <a:off x="566928" y="4754880"/>
+            <a:ext cx="11057839" cy="1207008"/>
+          </a:xfrm>
+          <a:prstGeom prst="roundRect">
+            <a:avLst>
+              <a:gd name="adj" fmla="val 6818"/>
+            </a:avLst>
+          </a:prstGeom>
+          <a:solidFill>
+            <a:srgbClr val="1C1C1C"/>
+          </a:solidFill>
+          <a:ln w="12700">
+            <a:solidFill>
+              <a:srgbClr val="1C1C1C"/>
+            </a:solidFill>
+            <a:prstDash val="solid"/>
+          </a:ln>
+        </p:spPr>
+        <p:txBody>
+          <a:bodyPr/>
+          <a:lstStyle/>
+          <a:p>
+            <a:endParaRPr lang="en-US"/>
+          </a:p>
+        </p:txBody>
+      </p:sp>
+      <p:sp>
+        <p:nvSpPr>
+          <p:cNvPr id="14" name="Text 11"/>
+          <p:cNvSpPr txBox="1"/>
+          <p:nvPr/>
+        </p:nvSpPr>
+        <p:spPr>
+          <a:xfrm>
+            <a:off x="886968" y="4956048"/>
+            <a:ext cx="5486400" cy="237744"/>
+          </a:xfrm>
+          <a:prstGeom prst="rect">
+            <a:avLst/>
+          </a:prstGeom>
+          <a:noFill/>
+          <a:ln/>
+        </p:spPr>
+        <p:txBody>
+          <a:bodyPr wrap="square" lIns="0" tIns="0" rIns="0" bIns="0" rtlCol="0" anchor="ctr"/>
+          <a:lstStyle/>
+          <a:p>
+            <a:pPr marL="0" indent="0">
+              <a:buNone/>
+            </a:pPr>
+            <a:r>
+              <a:rPr lang="en-US" sz="950" b="1" kern="0" spc="160" dirty="0">
+                <a:solidFill>
+                  <a:srgbClr val="D9A441"/>
+                </a:solidFill>
+                <a:latin typeface="Arial" pitchFamily="34" charset="0"/>
+                <a:ea typeface="Arial" pitchFamily="34" charset="-122"/>
+                <a:cs typeface="Arial" pitchFamily="34" charset="-120"/>
+              </a:rPr>
+              <a:t>NEXT WEEK  ·  SESSION 2</a:t>
+            </a:r>
+            <a:endParaRPr lang="en-US" sz="950" dirty="0"/>
+          </a:p>
+        </p:txBody>
+      </p:sp>
+      <p:sp>
+        <p:nvSpPr>
+          <p:cNvPr id="15" name="Text 12"/>
+          <p:cNvSpPr txBox="1"/>
+          <p:nvPr/>
+        </p:nvSpPr>
+        <p:spPr>
+          <a:xfrm>
+            <a:off x="886968" y="5230368"/>
+            <a:ext cx="10424160" cy="713232"/>
+          </a:xfrm>
+          <a:prstGeom prst="rect">
+            <a:avLst/>
+          </a:prstGeom>
+          <a:noFill/>
+          <a:ln/>
+        </p:spPr>
+        <p:txBody>
+          <a:bodyPr wrap="square" lIns="0" tIns="0" rIns="0" bIns="0" rtlCol="0" anchor="t"/>
+          <a:lstStyle/>
+          <a:p>
+            <a:pPr marL="0" indent="0">
+              <a:lnSpc>
+                <a:spcPts val="2400"/>
+              </a:lnSpc>
+              <a:buNone/>
+            </a:pPr>
+            <a:r>
+              <a:rPr lang="en-US" sz="1800" b="1" dirty="0">
+                <a:solidFill>
+                  <a:srgbClr val="FFFFFF"/>
+                </a:solidFill>
+                <a:latin typeface="Arial" pitchFamily="34" charset="0"/>
+                <a:ea typeface="Arial" pitchFamily="34" charset="-122"/>
+                <a:cs typeface="Arial" pitchFamily="34" charset="-120"/>
+              </a:rPr>
+              <a:t>Variables and types — where most of your bugs will come from.
+</a:t>
+            </a:r>
+            <a:r>
+              <a:rPr lang="en-US" sz="1350" dirty="0">
+                <a:solidFill>
+                  <a:srgbClr val="C6C6C6"/>
+                </a:solidFill>
+                <a:latin typeface="Arial" pitchFamily="34" charset="0"/>
+                <a:ea typeface="Arial" pitchFamily="34" charset="-122"/>
+                <a:cs typeface="Arial" pitchFamily="34" charset="-120"/>
+              </a:rPr>
+              <a:t>Including how to read a TypeError traceback without panicking.</a:t>
+            </a:r>
+            <a:endParaRPr lang="en-US" sz="1800" dirty="0"/>
+          </a:p>
+        </p:txBody>
+      </p:sp>
+    </p:spTree>
+  </p:cSld>
+  <p:clrMapOvr>
+    <a:masterClrMapping/>
+  </p:clrMapOvr>
+</p:sld>
+</file>
+
+<file path=ppt/slides/slide3.xml><?xml version="1.0" encoding="utf-8"?>
 <p:sld xmlns:a="http://schemas.openxmlformats.org/drawingml/2006/main" xmlns:r="http://schemas.openxmlformats.org/officeDocument/2006/relationships" xmlns:p="http://schemas.openxmlformats.org/presentationml/2006/main">
   <p:cSld name="Slide 2">
     <p:bg>
@@ -13190,7 +15699,7 @@
                 <a:ea typeface="Arial" pitchFamily="34" charset="-122"/>
                 <a:cs typeface="Arial" pitchFamily="34" charset="-120"/>
               </a:rPr>
-              <a:t>0–3 MIN  ·  THE HONEST CONVERSATION</a:t>
+              <a:t>3–5 MIN  ·  THE HONEST CONVERSATION</a:t>
             </a:r>
             <a:endParaRPr lang="en-US" sz="1200" dirty="0"/>
           </a:p>
@@ -13411,676 +15920,7 @@
 </p:sld>
 </file>
 
-<file path=ppt/slides/slide20.xml><?xml version="1.0" encoding="utf-8"?>
-<p:sld xmlns:a="http://schemas.openxmlformats.org/drawingml/2006/main" xmlns:r="http://schemas.openxmlformats.org/officeDocument/2006/relationships" xmlns:p="http://schemas.openxmlformats.org/presentationml/2006/main">
-  <p:cSld name="Slide 16">
-    <p:bg>
-      <p:bgPr>
-        <a:solidFill>
-          <a:srgbClr val="FFFFFF"/>
-        </a:solidFill>
-        <a:effectLst/>
-      </p:bgPr>
-    </p:bg>
-    <p:spTree>
-      <p:nvGrpSpPr>
-        <p:cNvPr id="1" name=""/>
-        <p:cNvGrpSpPr/>
-        <p:nvPr/>
-      </p:nvGrpSpPr>
-      <p:grpSpPr>
-        <a:xfrm>
-          <a:off x="0" y="0"/>
-          <a:ext cx="0" cy="0"/>
-          <a:chOff x="0" y="0"/>
-          <a:chExt cx="0" cy="0"/>
-        </a:xfrm>
-      </p:grpSpPr>
-      <p:pic>
-        <p:nvPicPr>
-          <p:cNvPr id="2" name="Image 0" descr="vu_mark_gold.png"/>
-          <p:cNvPicPr>
-            <a:picLocks noChangeAspect="1"/>
-          </p:cNvPicPr>
-          <p:nvPr/>
-        </p:nvPicPr>
-        <p:blipFill>
-          <a:blip r:embed="rId3"/>
-          <a:stretch>
-            <a:fillRect/>
-          </a:stretch>
-        </p:blipFill>
-        <p:spPr>
-          <a:xfrm>
-            <a:off x="11356848" y="310896"/>
-            <a:ext cx="384048" cy="274320"/>
-          </a:xfrm>
-          <a:prstGeom prst="rect">
-            <a:avLst/>
-          </a:prstGeom>
-        </p:spPr>
-      </p:pic>
-      <p:sp>
-        <p:nvSpPr>
-          <p:cNvPr id="3" name="Shape 0"/>
-          <p:cNvSpPr/>
-          <p:nvPr/>
-        </p:nvSpPr>
-        <p:spPr>
-          <a:xfrm>
-            <a:off x="566928" y="329184"/>
-            <a:ext cx="1562710" cy="310896"/>
-          </a:xfrm>
-          <a:prstGeom prst="roundRect">
-            <a:avLst>
-              <a:gd name="adj" fmla="val 50000"/>
-            </a:avLst>
-          </a:prstGeom>
-          <a:solidFill>
-            <a:srgbClr val="F2C879"/>
-          </a:solidFill>
-          <a:ln w="12700">
-            <a:solidFill>
-              <a:srgbClr val="F2C879"/>
-            </a:solidFill>
-            <a:prstDash val="solid"/>
-          </a:ln>
-        </p:spPr>
-        <p:txBody>
-          <a:bodyPr/>
-          <a:lstStyle/>
-          <a:p>
-            <a:endParaRPr lang="en-US"/>
-          </a:p>
-        </p:txBody>
-      </p:sp>
-      <p:sp>
-        <p:nvSpPr>
-          <p:cNvPr id="4" name="Text 1"/>
-          <p:cNvSpPr txBox="1"/>
-          <p:nvPr/>
-        </p:nvSpPr>
-        <p:spPr>
-          <a:xfrm>
-            <a:off x="566928" y="329184"/>
-            <a:ext cx="1562710" cy="310896"/>
-          </a:xfrm>
-          <a:prstGeom prst="rect">
-            <a:avLst/>
-          </a:prstGeom>
-          <a:noFill/>
-          <a:ln/>
-        </p:spPr>
-        <p:txBody>
-          <a:bodyPr wrap="square" lIns="0" tIns="0" rIns="0" bIns="0" rtlCol="0" anchor="ctr"/>
-          <a:lstStyle/>
-          <a:p>
-            <a:pPr marL="0" indent="0" algn="ctr">
-              <a:buNone/>
-            </a:pPr>
-            <a:r>
-              <a:rPr lang="en-US" sz="1050" b="1" kern="0" spc="110" dirty="0">
-                <a:solidFill>
-                  <a:srgbClr val="5A4415"/>
-                </a:solidFill>
-                <a:latin typeface="Arial" pitchFamily="34" charset="0"/>
-                <a:ea typeface="Arial" pitchFamily="34" charset="-122"/>
-                <a:cs typeface="Arial" pitchFamily="34" charset="-120"/>
-              </a:rPr>
-              <a:t>BEFORE YOU GO</a:t>
-            </a:r>
-            <a:endParaRPr lang="en-US" sz="1050" dirty="0"/>
-          </a:p>
-        </p:txBody>
-      </p:sp>
-      <p:sp>
-        <p:nvSpPr>
-          <p:cNvPr id="5" name="Text 2"/>
-          <p:cNvSpPr txBox="1"/>
-          <p:nvPr/>
-        </p:nvSpPr>
-        <p:spPr>
-          <a:xfrm>
-            <a:off x="566928" y="749808"/>
-            <a:ext cx="10692079" cy="658368"/>
-          </a:xfrm>
-          <a:prstGeom prst="rect">
-            <a:avLst/>
-          </a:prstGeom>
-          <a:noFill/>
-          <a:ln/>
-        </p:spPr>
-        <p:txBody>
-          <a:bodyPr wrap="square" lIns="0" tIns="0" rIns="0" bIns="0" rtlCol="0" anchor="ctr"/>
-          <a:lstStyle/>
-          <a:p>
-            <a:pPr marL="0" indent="0">
-              <a:buNone/>
-            </a:pPr>
-            <a:r>
-              <a:rPr lang="en-US" sz="3300" b="1" dirty="0">
-                <a:solidFill>
-                  <a:srgbClr val="1C1C1C"/>
-                </a:solidFill>
-                <a:latin typeface="Arial" pitchFamily="34" charset="0"/>
-                <a:ea typeface="Arial" pitchFamily="34" charset="-122"/>
-                <a:cs typeface="Arial" pitchFamily="34" charset="-120"/>
-              </a:rPr>
-              <a:t>Before next week</a:t>
-            </a:r>
-            <a:endParaRPr lang="en-US" sz="3300" dirty="0"/>
-          </a:p>
-        </p:txBody>
-      </p:sp>
-      <p:sp>
-        <p:nvSpPr>
-          <p:cNvPr id="6" name="Text 3"/>
-          <p:cNvSpPr txBox="1"/>
-          <p:nvPr/>
-        </p:nvSpPr>
-        <p:spPr>
-          <a:xfrm>
-            <a:off x="11430000" y="6419088"/>
-            <a:ext cx="320040" cy="228600"/>
-          </a:xfrm>
-          <a:prstGeom prst="rect">
-            <a:avLst/>
-          </a:prstGeom>
-          <a:noFill/>
-          <a:ln/>
-        </p:spPr>
-        <p:txBody>
-          <a:bodyPr wrap="square" lIns="0" tIns="0" rIns="0" bIns="0" rtlCol="0" anchor="ctr"/>
-          <a:lstStyle/>
-          <a:p>
-            <a:pPr marL="0" indent="0" algn="r">
-              <a:buNone/>
-            </a:pPr>
-            <a:r>
-              <a:rPr lang="en-US" sz="1000" dirty="0">
-                <a:solidFill>
-                  <a:srgbClr val="B5B5B5"/>
-                </a:solidFill>
-                <a:latin typeface="Calibri" pitchFamily="34" charset="0"/>
-                <a:ea typeface="Calibri" pitchFamily="34" charset="-122"/>
-                <a:cs typeface="Calibri" pitchFamily="34" charset="-120"/>
-              </a:rPr>
-              <a:t>20</a:t>
-            </a:r>
-            <a:endParaRPr lang="en-US" sz="1000" dirty="0"/>
-          </a:p>
-        </p:txBody>
-      </p:sp>
-      <p:sp>
-        <p:nvSpPr>
-          <p:cNvPr id="7" name="Shape 4"/>
-          <p:cNvSpPr/>
-          <p:nvPr/>
-        </p:nvSpPr>
-        <p:spPr>
-          <a:xfrm>
-            <a:off x="566928" y="1572768"/>
-            <a:ext cx="5532120" cy="2834640"/>
-          </a:xfrm>
-          <a:prstGeom prst="roundRect">
-            <a:avLst>
-              <a:gd name="adj" fmla="val 2903"/>
-            </a:avLst>
-          </a:prstGeom>
-          <a:solidFill>
-            <a:srgbClr val="FBF7EF"/>
-          </a:solidFill>
-          <a:ln w="12700">
-            <a:solidFill>
-              <a:srgbClr val="E6E6E6"/>
-            </a:solidFill>
-            <a:prstDash val="solid"/>
-          </a:ln>
-        </p:spPr>
-        <p:txBody>
-          <a:bodyPr/>
-          <a:lstStyle/>
-          <a:p>
-            <a:endParaRPr lang="en-US"/>
-          </a:p>
-        </p:txBody>
-      </p:sp>
-      <p:sp>
-        <p:nvSpPr>
-          <p:cNvPr id="8" name="Text 5"/>
-          <p:cNvSpPr txBox="1"/>
-          <p:nvPr/>
-        </p:nvSpPr>
-        <p:spPr>
-          <a:xfrm>
-            <a:off x="822960" y="1773936"/>
-            <a:ext cx="4937760" cy="237744"/>
-          </a:xfrm>
-          <a:prstGeom prst="rect">
-            <a:avLst/>
-          </a:prstGeom>
-          <a:noFill/>
-          <a:ln/>
-        </p:spPr>
-        <p:txBody>
-          <a:bodyPr wrap="square" lIns="0" tIns="0" rIns="0" bIns="0" rtlCol="0" anchor="ctr"/>
-          <a:lstStyle/>
-          <a:p>
-            <a:pPr marL="0" indent="0">
-              <a:buNone/>
-            </a:pPr>
-            <a:r>
-              <a:rPr lang="en-US" sz="1000" b="1" kern="0" spc="150" dirty="0">
-                <a:solidFill>
-                  <a:srgbClr val="8A6D3B"/>
-                </a:solidFill>
-                <a:latin typeface="Arial" pitchFamily="34" charset="0"/>
-                <a:ea typeface="Arial" pitchFamily="34" charset="-122"/>
-                <a:cs typeface="Arial" pitchFamily="34" charset="-120"/>
-              </a:rPr>
-              <a:t>REQUIRED</a:t>
-            </a:r>
-            <a:endParaRPr lang="en-US" sz="1000" dirty="0"/>
-          </a:p>
-        </p:txBody>
-      </p:sp>
-      <p:sp>
-        <p:nvSpPr>
-          <p:cNvPr id="9" name="Text 6"/>
-          <p:cNvSpPr txBox="1"/>
-          <p:nvPr/>
-        </p:nvSpPr>
-        <p:spPr>
-          <a:xfrm>
-            <a:off x="841248" y="2103120"/>
-            <a:ext cx="5029200" cy="2377440"/>
-          </a:xfrm>
-          <a:prstGeom prst="rect">
-            <a:avLst/>
-          </a:prstGeom>
-          <a:noFill/>
-          <a:ln/>
-        </p:spPr>
-        <p:txBody>
-          <a:bodyPr wrap="square" lIns="0" tIns="0" rIns="0" bIns="0" rtlCol="0" anchor="t"/>
-          <a:lstStyle/>
-          <a:p>
-            <a:pPr marL="203200" indent="-203200">
-              <a:lnSpc>
-                <a:spcPts val="1800"/>
-              </a:lnSpc>
-              <a:spcAft>
-                <a:spcPts val="1300"/>
-              </a:spcAft>
-              <a:buSzPct val="100000"/>
-              <a:buChar char="•"/>
-            </a:pPr>
-            <a:r>
-              <a:rPr lang="en-US" sz="1400" dirty="0">
-                <a:solidFill>
-                  <a:srgbClr val="3A3A3A"/>
-                </a:solidFill>
-                <a:latin typeface="Calibri" pitchFamily="34" charset="0"/>
-                <a:ea typeface="Calibri" pitchFamily="34" charset="-122"/>
-                <a:cs typeface="Calibri" pitchFamily="34" charset="-120"/>
-              </a:rPr>
-              <a:t>Finish your installs. The written guide and the check script are both on Brightspace.</a:t>
-            </a:r>
-            <a:endParaRPr lang="en-US" sz="1400" dirty="0"/>
-          </a:p>
-          <a:p>
-            <a:pPr marL="203200" indent="-203200">
-              <a:lnSpc>
-                <a:spcPts val="1800"/>
-              </a:lnSpc>
-              <a:spcAft>
-                <a:spcPts val="1300"/>
-              </a:spcAft>
-              <a:buSzPct val="100000"/>
-              <a:buChar char="•"/>
-            </a:pPr>
-            <a:r>
-              <a:rPr lang="en-US" sz="1400" dirty="0">
-                <a:solidFill>
-                  <a:srgbClr val="3A3A3A"/>
-                </a:solidFill>
-                <a:latin typeface="Calibri" pitchFamily="34" charset="0"/>
-                <a:ea typeface="Calibri" pitchFamily="34" charset="-122"/>
-                <a:cs typeface="Calibri" pitchFamily="34" charset="-120"/>
-              </a:rPr>
-              <a:t>Run the check script and fix whatever it names.</a:t>
-            </a:r>
-            <a:endParaRPr lang="en-US" sz="1400" dirty="0"/>
-          </a:p>
-          <a:p>
-            <a:pPr marL="203200" indent="-203200">
-              <a:lnSpc>
-                <a:spcPts val="1800"/>
-              </a:lnSpc>
-              <a:spcAft>
-                <a:spcPts val="1300"/>
-              </a:spcAft>
-              <a:buSzPct val="100000"/>
-              <a:buChar char="•"/>
-            </a:pPr>
-            <a:r>
-              <a:rPr lang="en-US" sz="1400" dirty="0">
-                <a:solidFill>
-                  <a:srgbClr val="3A3A3A"/>
-                </a:solidFill>
-                <a:latin typeface="Calibri" pitchFamily="34" charset="0"/>
-                <a:ea typeface="Calibri" pitchFamily="34" charset="-122"/>
-                <a:cs typeface="Calibri" pitchFamily="34" charset="-120"/>
-              </a:rPr>
-              <a:t>Do the Session 1 tutor activity and post the transcript — this is your participation grade.</a:t>
-            </a:r>
-            <a:endParaRPr lang="en-US" sz="1400" dirty="0"/>
-          </a:p>
-        </p:txBody>
-      </p:sp>
-      <p:sp>
-        <p:nvSpPr>
-          <p:cNvPr id="10" name="Shape 7"/>
-          <p:cNvSpPr/>
-          <p:nvPr/>
-        </p:nvSpPr>
-        <p:spPr>
-          <a:xfrm>
-            <a:off x="6382512" y="1572768"/>
-            <a:ext cx="5230368" cy="2834640"/>
-          </a:xfrm>
-          <a:prstGeom prst="roundRect">
-            <a:avLst>
-              <a:gd name="adj" fmla="val 2903"/>
-            </a:avLst>
-          </a:prstGeom>
-          <a:solidFill>
-            <a:srgbClr val="FFFFFF"/>
-          </a:solidFill>
-          <a:ln w="12700">
-            <a:solidFill>
-              <a:srgbClr val="E6E6E6"/>
-            </a:solidFill>
-            <a:prstDash val="solid"/>
-          </a:ln>
-        </p:spPr>
-        <p:txBody>
-          <a:bodyPr/>
-          <a:lstStyle/>
-          <a:p>
-            <a:endParaRPr lang="en-US"/>
-          </a:p>
-        </p:txBody>
-      </p:sp>
-      <p:sp>
-        <p:nvSpPr>
-          <p:cNvPr id="11" name="Text 8"/>
-          <p:cNvSpPr txBox="1"/>
-          <p:nvPr/>
-        </p:nvSpPr>
-        <p:spPr>
-          <a:xfrm>
-            <a:off x="6638544" y="1773936"/>
-            <a:ext cx="4754880" cy="237744"/>
-          </a:xfrm>
-          <a:prstGeom prst="rect">
-            <a:avLst/>
-          </a:prstGeom>
-          <a:noFill/>
-          <a:ln/>
-        </p:spPr>
-        <p:txBody>
-          <a:bodyPr wrap="square" lIns="0" tIns="0" rIns="0" bIns="0" rtlCol="0" anchor="ctr"/>
-          <a:lstStyle/>
-          <a:p>
-            <a:pPr marL="0" indent="0">
-              <a:buNone/>
-            </a:pPr>
-            <a:r>
-              <a:rPr lang="en-US" sz="1000" b="1" kern="0" spc="150" dirty="0">
-                <a:solidFill>
-                  <a:srgbClr val="6B7A88"/>
-                </a:solidFill>
-                <a:latin typeface="Arial" pitchFamily="34" charset="0"/>
-                <a:ea typeface="Arial" pitchFamily="34" charset="-122"/>
-                <a:cs typeface="Arial" pitchFamily="34" charset="-120"/>
-              </a:rPr>
-              <a:t>START THINKING ABOUT</a:t>
-            </a:r>
-            <a:endParaRPr lang="en-US" sz="1000" dirty="0"/>
-          </a:p>
-        </p:txBody>
-      </p:sp>
-      <p:sp>
-        <p:nvSpPr>
-          <p:cNvPr id="12" name="Text 9"/>
-          <p:cNvSpPr txBox="1"/>
-          <p:nvPr/>
-        </p:nvSpPr>
-        <p:spPr>
-          <a:xfrm>
-            <a:off x="6656832" y="2103120"/>
-            <a:ext cx="4754880" cy="2377440"/>
-          </a:xfrm>
-          <a:prstGeom prst="rect">
-            <a:avLst/>
-          </a:prstGeom>
-          <a:noFill/>
-          <a:ln/>
-        </p:spPr>
-        <p:txBody>
-          <a:bodyPr wrap="square" lIns="0" tIns="0" rIns="0" bIns="0" rtlCol="0" anchor="t"/>
-          <a:lstStyle/>
-          <a:p>
-            <a:pPr marL="203200" indent="-203200">
-              <a:lnSpc>
-                <a:spcPts val="1800"/>
-              </a:lnSpc>
-              <a:spcAft>
-                <a:spcPts val="1300"/>
-              </a:spcAft>
-              <a:buSzPct val="100000"/>
-              <a:buChar char="•"/>
-            </a:pPr>
-            <a:r>
-              <a:rPr lang="en-US" sz="1400" dirty="0">
-                <a:solidFill>
-                  <a:srgbClr val="3A3A3A"/>
-                </a:solidFill>
-                <a:latin typeface="Calibri" pitchFamily="34" charset="0"/>
-                <a:ea typeface="Calibri" pitchFamily="34" charset="-122"/>
-                <a:cs typeface="Calibri" pitchFamily="34" charset="-120"/>
-              </a:rPr>
-              <a:t>Your project dataset. Choose by Session 4, register by Session 6.</a:t>
-            </a:r>
-            <a:endParaRPr lang="en-US" sz="1400" dirty="0"/>
-          </a:p>
-          <a:p>
-            <a:pPr marL="203200" indent="-203200">
-              <a:lnSpc>
-                <a:spcPts val="1800"/>
-              </a:lnSpc>
-              <a:spcAft>
-                <a:spcPts val="1300"/>
-              </a:spcAft>
-              <a:buSzPct val="100000"/>
-              <a:buChar char="•"/>
-            </a:pPr>
-            <a:r>
-              <a:rPr lang="en-US" sz="1400" dirty="0">
-                <a:solidFill>
-                  <a:srgbClr val="3A3A3A"/>
-                </a:solidFill>
-                <a:latin typeface="Calibri" pitchFamily="34" charset="0"/>
-                <a:ea typeface="Calibri" pitchFamily="34" charset="-122"/>
-                <a:cs typeface="Calibri" pitchFamily="34" charset="-120"/>
-              </a:rPr>
-              <a:t>Browse the dataset list on the course research guide.</a:t>
-            </a:r>
-            <a:endParaRPr lang="en-US" sz="1400" dirty="0"/>
-          </a:p>
-          <a:p>
-            <a:pPr marL="203200" indent="-203200">
-              <a:lnSpc>
-                <a:spcPts val="1800"/>
-              </a:lnSpc>
-              <a:spcAft>
-                <a:spcPts val="1300"/>
-              </a:spcAft>
-              <a:buSzPct val="100000"/>
-              <a:buChar char="•"/>
-            </a:pPr>
-            <a:r>
-              <a:rPr lang="en-US" sz="1400" dirty="0">
-                <a:solidFill>
-                  <a:srgbClr val="3A3A3A"/>
-                </a:solidFill>
-                <a:latin typeface="Calibri" pitchFamily="34" charset="0"/>
-                <a:ea typeface="Calibri" pitchFamily="34" charset="-122"/>
-                <a:cs typeface="Calibri" pitchFamily="34" charset="-120"/>
-              </a:rPr>
-              <a:t>Best option by far: data you already have, or already want.</a:t>
-            </a:r>
-            <a:endParaRPr lang="en-US" sz="1400" dirty="0"/>
-          </a:p>
-        </p:txBody>
-      </p:sp>
-      <p:sp>
-        <p:nvSpPr>
-          <p:cNvPr id="13" name="Shape 10"/>
-          <p:cNvSpPr/>
-          <p:nvPr/>
-        </p:nvSpPr>
-        <p:spPr>
-          <a:xfrm>
-            <a:off x="566928" y="4754880"/>
-            <a:ext cx="11057839" cy="1207008"/>
-          </a:xfrm>
-          <a:prstGeom prst="roundRect">
-            <a:avLst>
-              <a:gd name="adj" fmla="val 6818"/>
-            </a:avLst>
-          </a:prstGeom>
-          <a:solidFill>
-            <a:srgbClr val="1C1C1C"/>
-          </a:solidFill>
-          <a:ln w="12700">
-            <a:solidFill>
-              <a:srgbClr val="1C1C1C"/>
-            </a:solidFill>
-            <a:prstDash val="solid"/>
-          </a:ln>
-        </p:spPr>
-        <p:txBody>
-          <a:bodyPr/>
-          <a:lstStyle/>
-          <a:p>
-            <a:endParaRPr lang="en-US"/>
-          </a:p>
-        </p:txBody>
-      </p:sp>
-      <p:sp>
-        <p:nvSpPr>
-          <p:cNvPr id="14" name="Text 11"/>
-          <p:cNvSpPr txBox="1"/>
-          <p:nvPr/>
-        </p:nvSpPr>
-        <p:spPr>
-          <a:xfrm>
-            <a:off x="886968" y="4956048"/>
-            <a:ext cx="5486400" cy="237744"/>
-          </a:xfrm>
-          <a:prstGeom prst="rect">
-            <a:avLst/>
-          </a:prstGeom>
-          <a:noFill/>
-          <a:ln/>
-        </p:spPr>
-        <p:txBody>
-          <a:bodyPr wrap="square" lIns="0" tIns="0" rIns="0" bIns="0" rtlCol="0" anchor="ctr"/>
-          <a:lstStyle/>
-          <a:p>
-            <a:pPr marL="0" indent="0">
-              <a:buNone/>
-            </a:pPr>
-            <a:r>
-              <a:rPr lang="en-US" sz="950" b="1" kern="0" spc="160" dirty="0">
-                <a:solidFill>
-                  <a:srgbClr val="D9A441"/>
-                </a:solidFill>
-                <a:latin typeface="Arial" pitchFamily="34" charset="0"/>
-                <a:ea typeface="Arial" pitchFamily="34" charset="-122"/>
-                <a:cs typeface="Arial" pitchFamily="34" charset="-120"/>
-              </a:rPr>
-              <a:t>NEXT WEEK  ·  SESSION 2</a:t>
-            </a:r>
-            <a:endParaRPr lang="en-US" sz="950" dirty="0"/>
-          </a:p>
-        </p:txBody>
-      </p:sp>
-      <p:sp>
-        <p:nvSpPr>
-          <p:cNvPr id="15" name="Text 12"/>
-          <p:cNvSpPr txBox="1"/>
-          <p:nvPr/>
-        </p:nvSpPr>
-        <p:spPr>
-          <a:xfrm>
-            <a:off x="886968" y="5230368"/>
-            <a:ext cx="10424160" cy="713232"/>
-          </a:xfrm>
-          <a:prstGeom prst="rect">
-            <a:avLst/>
-          </a:prstGeom>
-          <a:noFill/>
-          <a:ln/>
-        </p:spPr>
-        <p:txBody>
-          <a:bodyPr wrap="square" lIns="0" tIns="0" rIns="0" bIns="0" rtlCol="0" anchor="t"/>
-          <a:lstStyle/>
-          <a:p>
-            <a:pPr marL="0" indent="0">
-              <a:lnSpc>
-                <a:spcPts val="2400"/>
-              </a:lnSpc>
-              <a:buNone/>
-            </a:pPr>
-            <a:r>
-              <a:rPr lang="en-US" sz="1800" b="1" dirty="0">
-                <a:solidFill>
-                  <a:srgbClr val="FFFFFF"/>
-                </a:solidFill>
-                <a:latin typeface="Arial" pitchFamily="34" charset="0"/>
-                <a:ea typeface="Arial" pitchFamily="34" charset="-122"/>
-                <a:cs typeface="Arial" pitchFamily="34" charset="-120"/>
-              </a:rPr>
-              <a:t>Variables and types — where most of your bugs will come from.
-</a:t>
-            </a:r>
-            <a:r>
-              <a:rPr lang="en-US" sz="1350" dirty="0">
-                <a:solidFill>
-                  <a:srgbClr val="C6C6C6"/>
-                </a:solidFill>
-                <a:latin typeface="Arial" pitchFamily="34" charset="0"/>
-                <a:ea typeface="Arial" pitchFamily="34" charset="-122"/>
-                <a:cs typeface="Arial" pitchFamily="34" charset="-120"/>
-              </a:rPr>
-              <a:t>Including how to read a TypeError traceback without panicking.</a:t>
-            </a:r>
-            <a:endParaRPr lang="en-US" sz="1800" dirty="0"/>
-          </a:p>
-        </p:txBody>
-      </p:sp>
-    </p:spTree>
-  </p:cSld>
-  <p:clrMapOvr>
-    <a:masterClrMapping/>
-  </p:clrMapOvr>
-</p:sld>
-</file>
-
-<file path=ppt/slides/slide3.xml><?xml version="1.0" encoding="utf-8"?>
+<file path=ppt/slides/slide4.xml><?xml version="1.0" encoding="utf-8"?>
 <p:sld xmlns:a="http://schemas.openxmlformats.org/drawingml/2006/main" xmlns:r="http://schemas.openxmlformats.org/officeDocument/2006/relationships" xmlns:p="http://schemas.openxmlformats.org/presentationml/2006/main">
   <p:cSld name="Slide 3">
     <p:bg>
@@ -14138,7 +15978,7 @@
         <p:spPr>
           <a:xfrm>
             <a:off x="566928" y="329184"/>
-            <a:ext cx="2583180" cy="310896"/>
+            <a:ext cx="2583177" cy="310896"/>
           </a:xfrm>
           <a:prstGeom prst="roundRect">
             <a:avLst>
@@ -14172,7 +16012,7 @@
         <p:spPr>
           <a:xfrm>
             <a:off x="566928" y="329184"/>
-            <a:ext cx="2583180" cy="310896"/>
+            <a:ext cx="2583177" cy="310896"/>
           </a:xfrm>
           <a:prstGeom prst="rect">
             <a:avLst/>
@@ -14196,7 +16036,7 @@
                 <a:ea typeface="Arial" pitchFamily="34" charset="-122"/>
                 <a:cs typeface="Arial" pitchFamily="34" charset="-120"/>
               </a:rPr>
-              <a:t>3–6 MIN  ·  DEMONSTRATION</a:t>
+              <a:t>5–8 MIN  ·  DEMONSTRATION</a:t>
             </a:r>
             <a:endParaRPr lang="en-US" sz="1050" dirty="0"/>
           </a:p>
@@ -14274,7 +16114,7 @@
                 <a:ea typeface="Calibri" pitchFamily="34" charset="-122"/>
                 <a:cs typeface="Calibri" pitchFamily="34" charset="-120"/>
               </a:rPr>
-              <a:t>3</a:t>
+              <a:t>4</a:t>
             </a:r>
             <a:endParaRPr lang="en-US" sz="1000" dirty="0"/>
           </a:p>
@@ -14992,7 +16832,7 @@
 </p:sld>
 </file>
 
-<file path=ppt/slides/slide4.xml><?xml version="1.0" encoding="utf-8"?>
+<file path=ppt/slides/slide5.xml><?xml version="1.0" encoding="utf-8"?>
 <p:sld xmlns:a="http://schemas.openxmlformats.org/drawingml/2006/main" xmlns:r="http://schemas.openxmlformats.org/officeDocument/2006/relationships" xmlns:p="http://schemas.openxmlformats.org/presentationml/2006/main">
   <p:cSld name="Slide 4">
     <p:bg>
@@ -15050,7 +16890,7 @@
         <p:spPr>
           <a:xfrm>
             <a:off x="566928" y="329184"/>
-            <a:ext cx="2328062" cy="310896"/>
+            <a:ext cx="2413099" cy="310896"/>
           </a:xfrm>
           <a:prstGeom prst="roundRect">
             <a:avLst>
@@ -15084,7 +16924,7 @@
         <p:spPr>
           <a:xfrm>
             <a:off x="566928" y="329184"/>
-            <a:ext cx="2328062" cy="310896"/>
+            <a:ext cx="2413099" cy="310896"/>
           </a:xfrm>
           <a:prstGeom prst="rect">
             <a:avLst/>
@@ -15108,7 +16948,7 @@
                 <a:ea typeface="Arial" pitchFamily="34" charset="-122"/>
                 <a:cs typeface="Arial" pitchFamily="34" charset="-120"/>
               </a:rPr>
-              <a:t>6–9 MIN  ·  THE REVEAL</a:t>
+              <a:t>8–11 MIN  ·  THE REVEAL</a:t>
             </a:r>
             <a:endParaRPr lang="en-US" sz="1050" dirty="0"/>
           </a:p>
@@ -15186,7 +17026,7 @@
                 <a:ea typeface="Calibri" pitchFamily="34" charset="-122"/>
                 <a:cs typeface="Calibri" pitchFamily="34" charset="-120"/>
               </a:rPr>
-              <a:t>4</a:t>
+              <a:t>5</a:t>
             </a:r>
             <a:endParaRPr lang="en-US" sz="1000" dirty="0"/>
           </a:p>
@@ -16054,7 +17894,7 @@
 </p:sld>
 </file>
 
-<file path=ppt/slides/slide5.xml><?xml version="1.0" encoding="utf-8"?>
+<file path=ppt/slides/slide6.xml><?xml version="1.0" encoding="utf-8"?>
 <p:sld xmlns:a="http://schemas.openxmlformats.org/drawingml/2006/main" xmlns:r="http://schemas.openxmlformats.org/officeDocument/2006/relationships" xmlns:p="http://schemas.openxmlformats.org/presentationml/2006/main">
   <p:cSld name="Slide 5">
     <p:bg>
@@ -16112,7 +17952,7 @@
         <p:spPr>
           <a:xfrm>
             <a:off x="566928" y="329184"/>
-            <a:ext cx="2583180" cy="310896"/>
+            <a:ext cx="2668216" cy="310896"/>
           </a:xfrm>
           <a:prstGeom prst="roundRect">
             <a:avLst>
@@ -16146,7 +17986,7 @@
         <p:spPr>
           <a:xfrm>
             <a:off x="566928" y="329184"/>
-            <a:ext cx="2583180" cy="310896"/>
+            <a:ext cx="2668216" cy="310896"/>
           </a:xfrm>
           <a:prstGeom prst="rect">
             <a:avLst/>
@@ -16170,7 +18010,7 @@
                 <a:ea typeface="Arial" pitchFamily="34" charset="-122"/>
                 <a:cs typeface="Arial" pitchFamily="34" charset="-120"/>
               </a:rPr>
-              <a:t>9–12 MIN  ·  THE CONTRACT</a:t>
+              <a:t>11–14 MIN  ·  THE CONTRACT</a:t>
             </a:r>
             <a:endParaRPr lang="en-US" sz="1050" dirty="0"/>
           </a:p>
@@ -16248,7 +18088,7 @@
                 <a:ea typeface="Calibri" pitchFamily="34" charset="-122"/>
                 <a:cs typeface="Calibri" pitchFamily="34" charset="-120"/>
               </a:rPr>
-              <a:t>5</a:t>
+              <a:t>6</a:t>
             </a:r>
             <a:endParaRPr lang="en-US" sz="1000" dirty="0"/>
           </a:p>
@@ -16961,7 +18801,7 @@
 </p:sld>
 </file>
 
-<file path=ppt/slides/slide6.xml><?xml version="1.0" encoding="utf-8"?>
+<file path=ppt/slides/slide7.xml><?xml version="1.0" encoding="utf-8"?>
 <p:sld xmlns:a="http://schemas.openxmlformats.org/drawingml/2006/main" xmlns:r="http://schemas.openxmlformats.org/officeDocument/2006/relationships" xmlns:p="http://schemas.openxmlformats.org/presentationml/2006/main">
   <p:cSld name="Slide 6">
     <p:bg>
@@ -17155,7 +18995,7 @@
                 <a:ea typeface="Calibri" pitchFamily="34" charset="-122"/>
                 <a:cs typeface="Calibri" pitchFamily="34" charset="-120"/>
               </a:rPr>
-              <a:t>6</a:t>
+              <a:t>7</a:t>
             </a:r>
             <a:endParaRPr lang="en-US" sz="1000" dirty="0"/>
           </a:p>
@@ -17830,7 +19670,7 @@
                 <a:ea typeface="Calibri" pitchFamily="34" charset="-122"/>
                 <a:cs typeface="Calibri" pitchFamily="34" charset="-120"/>
               </a:rPr>
-              <a:t>Why this course exists</a:t>
+              <a:t>Pre-test</a:t>
             </a:r>
             <a:endParaRPr lang="en-US" sz="1250" dirty="0"/>
           </a:p>
@@ -17901,7 +19741,7 @@
                 <a:ea typeface="Courier New" pitchFamily="34" charset="-122"/>
                 <a:cs typeface="Courier New" pitchFamily="34" charset="-120"/>
               </a:rPr>
-              <a:t>3–9</a:t>
+              <a:t>3–11</a:t>
             </a:r>
             <a:endParaRPr lang="en-US" sz="1200" dirty="0"/>
           </a:p>
@@ -17940,7 +19780,7 @@
                 <a:ea typeface="Calibri" pitchFamily="34" charset="-122"/>
                 <a:cs typeface="Calibri" pitchFamily="34" charset="-120"/>
               </a:rPr>
-              <a:t>Code that ran and was wrong</a:t>
+              <a:t>Why we’re here, and code that was wrong</a:t>
             </a:r>
             <a:endParaRPr lang="en-US" sz="1250" dirty="0"/>
           </a:p>
@@ -18011,7 +19851,7 @@
                 <a:ea typeface="Courier New" pitchFamily="34" charset="-122"/>
                 <a:cs typeface="Courier New" pitchFamily="34" charset="-120"/>
               </a:rPr>
-              <a:t>9–12</a:t>
+              <a:t>11–14</a:t>
             </a:r>
             <a:endParaRPr lang="en-US" sz="1200" dirty="0"/>
           </a:p>
@@ -18121,7 +19961,7 @@
                 <a:ea typeface="Courier New" pitchFamily="34" charset="-122"/>
                 <a:cs typeface="Courier New" pitchFamily="34" charset="-120"/>
               </a:rPr>
-              <a:t>12–18</a:t>
+              <a:t>14–19</a:t>
             </a:r>
             <a:endParaRPr lang="en-US" sz="1200" dirty="0"/>
           </a:p>
@@ -18231,7 +20071,7 @@
                 <a:ea typeface="Courier New" pitchFamily="34" charset="-122"/>
                 <a:cs typeface="Courier New" pitchFamily="34" charset="-120"/>
               </a:rPr>
-              <a:t>18–34</a:t>
+              <a:t>19–34</a:t>
             </a:r>
             <a:endParaRPr lang="en-US" sz="1200" dirty="0"/>
           </a:p>
@@ -18504,7 +20344,7 @@
 </p:sld>
 </file>
 
-<file path=ppt/slides/slide7.xml><?xml version="1.0" encoding="utf-8"?>
+<file path=ppt/slides/slide8.xml><?xml version="1.0" encoding="utf-8"?>
 <p:sld xmlns:a="http://schemas.openxmlformats.org/drawingml/2006/main" xmlns:r="http://schemas.openxmlformats.org/officeDocument/2006/relationships" xmlns:p="http://schemas.openxmlformats.org/presentationml/2006/main">
   <p:cSld>
     <p:spTree>
@@ -18612,7 +20452,7 @@
                 <a:ea typeface="Arial" pitchFamily="34" charset="-122"/>
                 <a:cs typeface="Arial" pitchFamily="34" charset="-120"/>
               </a:rPr>
-              <a:t>12–14 MIN  ·  DO THIS NOW</a:t>
+              <a:t>14–16 MIN  ·  DO THIS NOW</a:t>
             </a:r>
             <a:endParaRPr lang="en-US" sz="1050" dirty="0"/>
           </a:p>
@@ -18690,7 +20530,7 @@
                 <a:ea typeface="Calibri" pitchFamily="34" charset="-122"/>
                 <a:cs typeface="Calibri" pitchFamily="34" charset="-120"/>
               </a:rPr>
-              <a:t>7</a:t>
+              <a:t>8</a:t>
             </a:r>
             <a:endParaRPr lang="en-US" sz="1000" dirty="0"/>
           </a:p>
@@ -19719,7 +21559,7 @@
 </p:sld>
 </file>
 
-<file path=ppt/slides/slide8.xml><?xml version="1.0" encoding="utf-8"?>
+<file path=ppt/slides/slide9.xml><?xml version="1.0" encoding="utf-8"?>
 <p:sld xmlns:a="http://schemas.openxmlformats.org/drawingml/2006/main" xmlns:r="http://schemas.openxmlformats.org/officeDocument/2006/relationships" xmlns:p="http://schemas.openxmlformats.org/presentationml/2006/main">
   <p:cSld name="Slide 7">
     <p:bg>
@@ -19835,7 +21675,7 @@
                 <a:ea typeface="Arial" pitchFamily="34" charset="-122"/>
                 <a:cs typeface="Arial" pitchFamily="34" charset="-120"/>
               </a:rPr>
-              <a:t>14–18 MIN  ·  WHILE YOU DOWNLOAD</a:t>
+              <a:t>16–19 MIN  ·  WHILE YOU DOWNLOAD</a:t>
             </a:r>
             <a:endParaRPr lang="en-US" sz="1050" dirty="0"/>
           </a:p>
@@ -19913,7 +21753,7 @@
                 <a:ea typeface="Calibri" pitchFamily="34" charset="-122"/>
                 <a:cs typeface="Calibri" pitchFamily="34" charset="-120"/>
               </a:rPr>
-              <a:t>8</a:t>
+              <a:t>9</a:t>
             </a:r>
             <a:endParaRPr lang="en-US" sz="1000" dirty="0"/>
           </a:p>
@@ -21740,1026 +23580,6 @@
 </p:sld>
 </file>
 
-<file path=ppt/slides/slide9.xml><?xml version="1.0" encoding="utf-8"?>
-<p:sld xmlns:a="http://schemas.openxmlformats.org/drawingml/2006/main" xmlns:r="http://schemas.openxmlformats.org/officeDocument/2006/relationships" xmlns:p="http://schemas.openxmlformats.org/presentationml/2006/main">
-  <p:cSld>
-    <p:spTree>
-      <p:nvGrpSpPr>
-        <p:cNvPr id="1" name=""/>
-        <p:cNvGrpSpPr/>
-        <p:nvPr/>
-      </p:nvGrpSpPr>
-      <p:grpSpPr>
-        <a:xfrm>
-          <a:off x="0" y="0"/>
-          <a:ext cx="0" cy="0"/>
-          <a:chOff x="0" y="0"/>
-          <a:chExt cx="0" cy="0"/>
-        </a:xfrm>
-      </p:grpSpPr>
-      <p:pic>
-        <p:nvPicPr>
-          <p:cNvPr id="2" name="Image 0" descr="vu_mark_gold.png"/>
-          <p:cNvPicPr>
-            <a:picLocks noChangeAspect="1"/>
-          </p:cNvPicPr>
-          <p:nvPr/>
-        </p:nvPicPr>
-        <p:blipFill>
-          <a:blip r:embed="rId3"/>
-          <a:stretch>
-            <a:fillRect/>
-          </a:stretch>
-        </p:blipFill>
-        <p:spPr>
-          <a:xfrm>
-            <a:off x="11356848" y="310896"/>
-            <a:ext cx="384048" cy="274320"/>
-          </a:xfrm>
-          <a:prstGeom prst="rect">
-            <a:avLst/>
-          </a:prstGeom>
-        </p:spPr>
-      </p:pic>
-      <p:sp>
-        <p:nvSpPr>
-          <p:cNvPr id="3" name="Shape 0"/>
-          <p:cNvSpPr/>
-          <p:nvPr/>
-        </p:nvSpPr>
-        <p:spPr>
-          <a:xfrm>
-            <a:off x="566928" y="329184"/>
-            <a:ext cx="2838294" cy="310896"/>
-          </a:xfrm>
-          <a:prstGeom prst="roundRect">
-            <a:avLst>
-              <a:gd name="adj" fmla="val 50000"/>
-            </a:avLst>
-          </a:prstGeom>
-          <a:solidFill>
-            <a:srgbClr val="F2C879"/>
-          </a:solidFill>
-          <a:ln w="12700">
-            <a:solidFill>
-              <a:srgbClr val="F2C879"/>
-            </a:solidFill>
-            <a:prstDash val="solid"/>
-          </a:ln>
-        </p:spPr>
-        <p:txBody>
-          <a:bodyPr/>
-          <a:lstStyle/>
-          <a:p>
-            <a:endParaRPr lang="en-US"/>
-          </a:p>
-        </p:txBody>
-      </p:sp>
-      <p:sp>
-        <p:nvSpPr>
-          <p:cNvPr id="4" name="Text 1"/>
-          <p:cNvSpPr txBox="1"/>
-          <p:nvPr/>
-        </p:nvSpPr>
-        <p:spPr>
-          <a:xfrm>
-            <a:off x="566928" y="329184"/>
-            <a:ext cx="2838294" cy="310896"/>
-          </a:xfrm>
-          <a:prstGeom prst="rect">
-            <a:avLst/>
-          </a:prstGeom>
-          <a:noFill/>
-          <a:ln/>
-        </p:spPr>
-        <p:txBody>
-          <a:bodyPr wrap="square" lIns="0" tIns="0" rIns="0" bIns="0" rtlCol="0" anchor="ctr"/>
-          <a:lstStyle/>
-          <a:p>
-            <a:pPr marL="0" indent="0" algn="ctr">
-              <a:buNone/>
-            </a:pPr>
-            <a:r>
-              <a:rPr lang="en-US" sz="1050" b="1" kern="0" spc="110" dirty="0">
-                <a:solidFill>
-                  <a:srgbClr val="5A4415"/>
-                </a:solidFill>
-                <a:latin typeface="Arial" pitchFamily="34" charset="0"/>
-                <a:ea typeface="Arial" pitchFamily="34" charset="-122"/>
-                <a:cs typeface="Arial" pitchFamily="34" charset="-120"/>
-              </a:rPr>
-              <a:t>18–23 MIN  ·  INSTALL 1 OF 4</a:t>
-            </a:r>
-            <a:endParaRPr lang="en-US" sz="1050" dirty="0"/>
-          </a:p>
-        </p:txBody>
-      </p:sp>
-      <p:sp>
-        <p:nvSpPr>
-          <p:cNvPr id="5" name="Text 2"/>
-          <p:cNvSpPr txBox="1"/>
-          <p:nvPr/>
-        </p:nvSpPr>
-        <p:spPr>
-          <a:xfrm>
-            <a:off x="566928" y="749808"/>
-            <a:ext cx="10692079" cy="658368"/>
-          </a:xfrm>
-          <a:prstGeom prst="rect">
-            <a:avLst/>
-          </a:prstGeom>
-          <a:noFill/>
-          <a:ln/>
-        </p:spPr>
-        <p:txBody>
-          <a:bodyPr wrap="square" lIns="0" tIns="0" rIns="0" bIns="0" rtlCol="0" anchor="ctr"/>
-          <a:lstStyle/>
-          <a:p>
-            <a:pPr marL="0" indent="0">
-              <a:buNone/>
-            </a:pPr>
-            <a:r>
-              <a:rPr lang="en-US" sz="3300" b="1" dirty="0">
-                <a:solidFill>
-                  <a:srgbClr val="1C1C1C"/>
-                </a:solidFill>
-                <a:latin typeface="Arial" pitchFamily="34" charset="0"/>
-                <a:ea typeface="Arial" pitchFamily="34" charset="-122"/>
-                <a:cs typeface="Arial" pitchFamily="34" charset="-120"/>
-              </a:rPr>
-              <a:t>Python — the engine</a:t>
-            </a:r>
-            <a:endParaRPr lang="en-US" sz="3300" dirty="0"/>
-          </a:p>
-        </p:txBody>
-      </p:sp>
-      <p:sp>
-        <p:nvSpPr>
-          <p:cNvPr id="6" name="Text 3"/>
-          <p:cNvSpPr txBox="1"/>
-          <p:nvPr/>
-        </p:nvSpPr>
-        <p:spPr>
-          <a:xfrm>
-            <a:off x="11430000" y="6419088"/>
-            <a:ext cx="320040" cy="228600"/>
-          </a:xfrm>
-          <a:prstGeom prst="rect">
-            <a:avLst/>
-          </a:prstGeom>
-          <a:noFill/>
-          <a:ln/>
-        </p:spPr>
-        <p:txBody>
-          <a:bodyPr wrap="square" lIns="0" tIns="0" rIns="0" bIns="0" rtlCol="0" anchor="ctr"/>
-          <a:lstStyle/>
-          <a:p>
-            <a:pPr marL="0" indent="0" algn="r">
-              <a:buNone/>
-            </a:pPr>
-            <a:r>
-              <a:rPr lang="en-US" sz="1000" dirty="0">
-                <a:solidFill>
-                  <a:srgbClr val="B5B5B5"/>
-                </a:solidFill>
-                <a:latin typeface="Calibri" pitchFamily="34" charset="0"/>
-                <a:ea typeface="Calibri" pitchFamily="34" charset="-122"/>
-                <a:cs typeface="Calibri" pitchFamily="34" charset="-120"/>
-              </a:rPr>
-              <a:t>9</a:t>
-            </a:r>
-            <a:endParaRPr lang="en-US" sz="1000" dirty="0"/>
-          </a:p>
-        </p:txBody>
-      </p:sp>
-      <p:sp>
-        <p:nvSpPr>
-          <p:cNvPr id="7" name="Shape 4"/>
-          <p:cNvSpPr/>
-          <p:nvPr/>
-        </p:nvSpPr>
-        <p:spPr>
-          <a:xfrm>
-            <a:off x="566928" y="1517904"/>
-            <a:ext cx="5760720" cy="2633472"/>
-          </a:xfrm>
-          <a:prstGeom prst="roundRect">
-            <a:avLst>
-              <a:gd name="adj" fmla="val 3125"/>
-            </a:avLst>
-          </a:prstGeom>
-          <a:solidFill>
-            <a:srgbClr val="FBF7EF"/>
-          </a:solidFill>
-          <a:ln w="12700">
-            <a:solidFill>
-              <a:srgbClr val="E6E6E6"/>
-            </a:solidFill>
-            <a:prstDash val="solid"/>
-          </a:ln>
-        </p:spPr>
-        <p:txBody>
-          <a:bodyPr/>
-          <a:lstStyle/>
-          <a:p>
-            <a:endParaRPr lang="en-US"/>
-          </a:p>
-        </p:txBody>
-      </p:sp>
-      <p:sp>
-        <p:nvSpPr>
-          <p:cNvPr id="8" name="Text 5"/>
-          <p:cNvSpPr txBox="1"/>
-          <p:nvPr/>
-        </p:nvSpPr>
-        <p:spPr>
-          <a:xfrm>
-            <a:off x="822960" y="1719072"/>
-            <a:ext cx="5120640" cy="237744"/>
-          </a:xfrm>
-          <a:prstGeom prst="rect">
-            <a:avLst/>
-          </a:prstGeom>
-          <a:noFill/>
-          <a:ln/>
-        </p:spPr>
-        <p:txBody>
-          <a:bodyPr wrap="square" lIns="0" tIns="0" rIns="0" bIns="0" rtlCol="0" anchor="ctr"/>
-          <a:lstStyle/>
-          <a:p>
-            <a:pPr marL="0" indent="0">
-              <a:buNone/>
-            </a:pPr>
-            <a:r>
-              <a:rPr lang="en-US" sz="1000" b="1" kern="0" spc="150" dirty="0">
-                <a:solidFill>
-                  <a:srgbClr val="8A6D3B"/>
-                </a:solidFill>
-                <a:latin typeface="Arial" pitchFamily="34" charset="0"/>
-                <a:ea typeface="Arial" pitchFamily="34" charset="-122"/>
-                <a:cs typeface="Arial" pitchFamily="34" charset="-120"/>
-              </a:rPr>
-              <a:t>WINDOWS</a:t>
-            </a:r>
-            <a:endParaRPr lang="en-US" sz="1000" dirty="0"/>
-          </a:p>
-        </p:txBody>
-      </p:sp>
-      <p:sp>
-        <p:nvSpPr>
-          <p:cNvPr id="9" name="Text 6"/>
-          <p:cNvSpPr txBox="1"/>
-          <p:nvPr/>
-        </p:nvSpPr>
-        <p:spPr>
-          <a:xfrm>
-            <a:off x="841248" y="2029968"/>
-            <a:ext cx="5257800" cy="2103120"/>
-          </a:xfrm>
-          <a:prstGeom prst="rect">
-            <a:avLst/>
-          </a:prstGeom>
-          <a:noFill/>
-          <a:ln/>
-        </p:spPr>
-        <p:txBody>
-          <a:bodyPr wrap="square" lIns="0" tIns="0" rIns="0" bIns="0" rtlCol="0" anchor="t"/>
-          <a:lstStyle/>
-          <a:p>
-            <a:pPr marL="203200" indent="-203200">
-              <a:lnSpc>
-                <a:spcPts val="1800"/>
-              </a:lnSpc>
-              <a:spcAft>
-                <a:spcPts val="900"/>
-              </a:spcAft>
-              <a:buSzPct val="100000"/>
-              <a:buChar char="•"/>
-            </a:pPr>
-            <a:r>
-              <a:rPr lang="en-US" sz="1250" dirty="0">
-                <a:solidFill>
-                  <a:srgbClr val="3A3A3A"/>
-                </a:solidFill>
-                <a:latin typeface="Calibri" pitchFamily="34" charset="0"/>
-                <a:ea typeface="Calibri" pitchFamily="34" charset="-122"/>
-                <a:cs typeface="Calibri" pitchFamily="34" charset="-120"/>
-              </a:rPr>
-              <a:t>Run the installer you downloaded.</a:t>
-            </a:r>
-            <a:endParaRPr lang="en-US" sz="1250" dirty="0"/>
-          </a:p>
-          <a:p>
-            <a:pPr marL="203200" indent="-203200">
-              <a:lnSpc>
-                <a:spcPts val="1800"/>
-              </a:lnSpc>
-              <a:spcAft>
-                <a:spcPts val="900"/>
-              </a:spcAft>
-              <a:buSzPct val="100000"/>
-              <a:buChar char="•"/>
-            </a:pPr>
-            <a:r>
-              <a:rPr lang="en-US" sz="1250" dirty="0">
-                <a:solidFill>
-                  <a:srgbClr val="3A3A3A"/>
-                </a:solidFill>
-                <a:latin typeface="Calibri" pitchFamily="34" charset="0"/>
-                <a:ea typeface="Calibri" pitchFamily="34" charset="-122"/>
-                <a:cs typeface="Calibri" pitchFamily="34" charset="-120"/>
-              </a:rPr>
-              <a:t>STOP on the first screen. Tick “Add python.exe to PATH” at the bottom.</a:t>
-            </a:r>
-            <a:endParaRPr lang="en-US" sz="1250" dirty="0"/>
-          </a:p>
-          <a:p>
-            <a:pPr marL="203200" indent="-203200">
-              <a:lnSpc>
-                <a:spcPts val="1800"/>
-              </a:lnSpc>
-              <a:spcAft>
-                <a:spcPts val="900"/>
-              </a:spcAft>
-              <a:buSzPct val="100000"/>
-              <a:buChar char="•"/>
-            </a:pPr>
-            <a:r>
-              <a:rPr lang="en-US" sz="1250" dirty="0">
-                <a:solidFill>
-                  <a:srgbClr val="3A3A3A"/>
-                </a:solidFill>
-                <a:latin typeface="Calibri" pitchFamily="34" charset="0"/>
-                <a:ea typeface="Calibri" pitchFamily="34" charset="-122"/>
-                <a:cs typeface="Calibri" pitchFamily="34" charset="-120"/>
-              </a:rPr>
-              <a:t>That one checkbox is the most common reason Session 2 does not work.</a:t>
-            </a:r>
-            <a:endParaRPr lang="en-US" sz="1250" dirty="0"/>
-          </a:p>
-          <a:p>
-            <a:pPr marL="203200" indent="-203200">
-              <a:lnSpc>
-                <a:spcPts val="1800"/>
-              </a:lnSpc>
-              <a:spcAft>
-                <a:spcPts val="900"/>
-              </a:spcAft>
-              <a:buSzPct val="100000"/>
-              <a:buChar char="•"/>
-            </a:pPr>
-            <a:r>
-              <a:rPr lang="en-US" sz="1250" dirty="0">
-                <a:solidFill>
-                  <a:srgbClr val="3A3A3A"/>
-                </a:solidFill>
-                <a:latin typeface="Calibri" pitchFamily="34" charset="0"/>
-                <a:ea typeface="Calibri" pitchFamily="34" charset="-122"/>
-                <a:cs typeface="Calibri" pitchFamily="34" charset="-120"/>
-              </a:rPr>
-              <a:t>Then “Install Now.” Accept everything else.</a:t>
-            </a:r>
-            <a:endParaRPr lang="en-US" sz="1250" dirty="0"/>
-          </a:p>
-          <a:p>
-            <a:pPr marL="203200" indent="-203200">
-              <a:lnSpc>
-                <a:spcPts val="1800"/>
-              </a:lnSpc>
-              <a:spcAft>
-                <a:spcPts val="900"/>
-              </a:spcAft>
-              <a:buSzPct val="100000"/>
-              <a:buChar char="•"/>
-            </a:pPr>
-            <a:r>
-              <a:rPr lang="en-US" sz="1250" dirty="0">
-                <a:solidFill>
-                  <a:srgbClr val="3A3A3A"/>
-                </a:solidFill>
-                <a:latin typeface="Calibri" pitchFamily="34" charset="0"/>
-                <a:ea typeface="Calibri" pitchFamily="34" charset="-122"/>
-                <a:cs typeface="Calibri" pitchFamily="34" charset="-120"/>
-              </a:rPr>
-              <a:t>Check it: Command Prompt, type  python --version  — any 3.11 or newer is fine.</a:t>
-            </a:r>
-            <a:endParaRPr lang="en-US" sz="1250" dirty="0"/>
-          </a:p>
-        </p:txBody>
-      </p:sp>
-      <p:sp>
-        <p:nvSpPr>
-          <p:cNvPr id="10" name="Shape 7"/>
-          <p:cNvSpPr/>
-          <p:nvPr/>
-        </p:nvSpPr>
-        <p:spPr>
-          <a:xfrm>
-            <a:off x="6583680" y="1517904"/>
-            <a:ext cx="5029200" cy="2633472"/>
-          </a:xfrm>
-          <a:prstGeom prst="roundRect">
-            <a:avLst>
-              <a:gd name="adj" fmla="val 3125"/>
-            </a:avLst>
-          </a:prstGeom>
-          <a:solidFill>
-            <a:srgbClr val="FFFFFF"/>
-          </a:solidFill>
-          <a:ln w="12700">
-            <a:solidFill>
-              <a:srgbClr val="E6E6E6"/>
-            </a:solidFill>
-            <a:prstDash val="solid"/>
-          </a:ln>
-        </p:spPr>
-        <p:txBody>
-          <a:bodyPr/>
-          <a:lstStyle/>
-          <a:p>
-            <a:endParaRPr lang="en-US"/>
-          </a:p>
-        </p:txBody>
-      </p:sp>
-      <p:sp>
-        <p:nvSpPr>
-          <p:cNvPr id="11" name="Text 8"/>
-          <p:cNvSpPr txBox="1"/>
-          <p:nvPr/>
-        </p:nvSpPr>
-        <p:spPr>
-          <a:xfrm>
-            <a:off x="6839712" y="1719072"/>
-            <a:ext cx="4480560" cy="237744"/>
-          </a:xfrm>
-          <a:prstGeom prst="rect">
-            <a:avLst/>
-          </a:prstGeom>
-          <a:noFill/>
-          <a:ln/>
-        </p:spPr>
-        <p:txBody>
-          <a:bodyPr wrap="square" lIns="0" tIns="0" rIns="0" bIns="0" rtlCol="0" anchor="ctr"/>
-          <a:lstStyle/>
-          <a:p>
-            <a:pPr marL="0" indent="0">
-              <a:buNone/>
-            </a:pPr>
-            <a:r>
-              <a:rPr lang="en-US" sz="1000" b="1" kern="0" spc="150" dirty="0">
-                <a:solidFill>
-                  <a:srgbClr val="8A6D3B"/>
-                </a:solidFill>
-                <a:latin typeface="Arial" pitchFamily="34" charset="0"/>
-                <a:ea typeface="Arial" pitchFamily="34" charset="-122"/>
-                <a:cs typeface="Arial" pitchFamily="34" charset="-120"/>
-              </a:rPr>
-              <a:t>MACOS</a:t>
-            </a:r>
-            <a:endParaRPr lang="en-US" sz="1000" dirty="0"/>
-          </a:p>
-        </p:txBody>
-      </p:sp>
-      <p:sp>
-        <p:nvSpPr>
-          <p:cNvPr id="12" name="Text 9"/>
-          <p:cNvSpPr txBox="1"/>
-          <p:nvPr/>
-        </p:nvSpPr>
-        <p:spPr>
-          <a:xfrm>
-            <a:off x="6858000" y="2029968"/>
-            <a:ext cx="4526280" cy="2103120"/>
-          </a:xfrm>
-          <a:prstGeom prst="rect">
-            <a:avLst/>
-          </a:prstGeom>
-          <a:noFill/>
-          <a:ln/>
-        </p:spPr>
-        <p:txBody>
-          <a:bodyPr wrap="square" lIns="0" tIns="0" rIns="0" bIns="0" rtlCol="0" anchor="t"/>
-          <a:lstStyle/>
-          <a:p>
-            <a:pPr marL="203200" indent="-203200">
-              <a:lnSpc>
-                <a:spcPts val="1800"/>
-              </a:lnSpc>
-              <a:spcAft>
-                <a:spcPts val="900"/>
-              </a:spcAft>
-              <a:buSzPct val="100000"/>
-              <a:buChar char="•"/>
-            </a:pPr>
-            <a:r>
-              <a:rPr lang="en-US" sz="1250" dirty="0">
-                <a:solidFill>
-                  <a:srgbClr val="3A3A3A"/>
-                </a:solidFill>
-                <a:latin typeface="Calibri" pitchFamily="34" charset="0"/>
-                <a:ea typeface="Calibri" pitchFamily="34" charset="-122"/>
-                <a:cs typeface="Calibri" pitchFamily="34" charset="-120"/>
-              </a:rPr>
-              <a:t>Open the .pkg you downloaded.</a:t>
-            </a:r>
-            <a:endParaRPr lang="en-US" sz="1250" dirty="0"/>
-          </a:p>
-          <a:p>
-            <a:pPr marL="203200" indent="-203200">
-              <a:lnSpc>
-                <a:spcPts val="1800"/>
-              </a:lnSpc>
-              <a:spcAft>
-                <a:spcPts val="900"/>
-              </a:spcAft>
-              <a:buSzPct val="100000"/>
-              <a:buChar char="•"/>
-            </a:pPr>
-            <a:r>
-              <a:rPr lang="en-US" sz="1250" dirty="0">
-                <a:solidFill>
-                  <a:srgbClr val="3A3A3A"/>
-                </a:solidFill>
-                <a:latin typeface="Calibri" pitchFamily="34" charset="0"/>
-                <a:ea typeface="Calibri" pitchFamily="34" charset="-122"/>
-                <a:cs typeface="Calibri" pitchFamily="34" charset="-120"/>
-              </a:rPr>
-              <a:t>Continue, Agree, Install. There are no choices to make.</a:t>
-            </a:r>
-            <a:endParaRPr lang="en-US" sz="1250" dirty="0"/>
-          </a:p>
-          <a:p>
-            <a:pPr marL="203200" indent="-203200">
-              <a:lnSpc>
-                <a:spcPts val="1800"/>
-              </a:lnSpc>
-              <a:spcAft>
-                <a:spcPts val="900"/>
-              </a:spcAft>
-              <a:buSzPct val="100000"/>
-              <a:buChar char="•"/>
-            </a:pPr>
-            <a:r>
-              <a:rPr lang="en-US" sz="1250" dirty="0">
-                <a:solidFill>
-                  <a:srgbClr val="3A3A3A"/>
-                </a:solidFill>
-                <a:latin typeface="Calibri" pitchFamily="34" charset="0"/>
-                <a:ea typeface="Calibri" pitchFamily="34" charset="-122"/>
-                <a:cs typeface="Calibri" pitchFamily="34" charset="-120"/>
-              </a:rPr>
-              <a:t>Enter your Mac password when it asks.</a:t>
-            </a:r>
-            <a:endParaRPr lang="en-US" sz="1250" dirty="0"/>
-          </a:p>
-          <a:p>
-            <a:pPr marL="203200" indent="-203200">
-              <a:lnSpc>
-                <a:spcPts val="1800"/>
-              </a:lnSpc>
-              <a:spcAft>
-                <a:spcPts val="900"/>
-              </a:spcAft>
-              <a:buSzPct val="100000"/>
-              <a:buChar char="•"/>
-            </a:pPr>
-            <a:r>
-              <a:rPr lang="en-US" sz="1250" dirty="0">
-                <a:solidFill>
-                  <a:srgbClr val="3A3A3A"/>
-                </a:solidFill>
-                <a:latin typeface="Calibri" pitchFamily="34" charset="0"/>
-                <a:ea typeface="Calibri" pitchFamily="34" charset="-122"/>
-                <a:cs typeface="Calibri" pitchFamily="34" charset="-120"/>
-              </a:rPr>
-              <a:t>Check it: open Terminal and type  python3 --version</a:t>
-            </a:r>
-            <a:endParaRPr lang="en-US" sz="1250" dirty="0"/>
-          </a:p>
-          <a:p>
-            <a:pPr marL="203200" indent="-203200">
-              <a:lnSpc>
-                <a:spcPts val="1800"/>
-              </a:lnSpc>
-              <a:spcAft>
-                <a:spcPts val="900"/>
-              </a:spcAft>
-              <a:buSzPct val="100000"/>
-              <a:buChar char="•"/>
-            </a:pPr>
-            <a:r>
-              <a:rPr lang="en-US" sz="1250" dirty="0">
-                <a:solidFill>
-                  <a:srgbClr val="3A3A3A"/>
-                </a:solidFill>
-                <a:latin typeface="Calibri" pitchFamily="34" charset="0"/>
-                <a:ea typeface="Calibri" pitchFamily="34" charset="-122"/>
-                <a:cs typeface="Calibri" pitchFamily="34" charset="-120"/>
-              </a:rPr>
-              <a:t>On a Mac it is python3, not python. Both are normal.</a:t>
-            </a:r>
-            <a:endParaRPr lang="en-US" sz="1250" dirty="0"/>
-          </a:p>
-        </p:txBody>
-      </p:sp>
-      <p:sp>
-        <p:nvSpPr>
-          <p:cNvPr id="13" name="Text 10"/>
-          <p:cNvSpPr txBox="1"/>
-          <p:nvPr/>
-        </p:nvSpPr>
-        <p:spPr>
-          <a:xfrm>
-            <a:off x="566928" y="4443984"/>
-            <a:ext cx="7315200" cy="256032"/>
-          </a:xfrm>
-          <a:prstGeom prst="rect">
-            <a:avLst/>
-          </a:prstGeom>
-          <a:noFill/>
-          <a:ln/>
-        </p:spPr>
-        <p:txBody>
-          <a:bodyPr wrap="square" lIns="0" tIns="0" rIns="0" bIns="0" rtlCol="0" anchor="ctr"/>
-          <a:lstStyle/>
-          <a:p>
-            <a:pPr marL="0" indent="0">
-              <a:buNone/>
-            </a:pPr>
-            <a:r>
-              <a:rPr lang="en-US" sz="1000" b="1" kern="0" spc="150" dirty="0">
-                <a:solidFill>
-                  <a:srgbClr val="A83A2C"/>
-                </a:solidFill>
-                <a:latin typeface="Arial" pitchFamily="34" charset="0"/>
-                <a:ea typeface="Arial" pitchFamily="34" charset="-122"/>
-                <a:cs typeface="Arial" pitchFamily="34" charset="-120"/>
-              </a:rPr>
-              <a:t>WHEN IT GOES WRONG — AND WHAT IT MEANS</a:t>
-            </a:r>
-            <a:endParaRPr lang="en-US" sz="1000" dirty="0"/>
-          </a:p>
-        </p:txBody>
-      </p:sp>
-      <p:sp>
-        <p:nvSpPr>
-          <p:cNvPr id="14" name="Text 11"/>
-          <p:cNvSpPr txBox="1"/>
-          <p:nvPr/>
-        </p:nvSpPr>
-        <p:spPr>
-          <a:xfrm>
-            <a:off x="566928" y="4754880"/>
-            <a:ext cx="219456" cy="310896"/>
-          </a:xfrm>
-          <a:prstGeom prst="rect">
-            <a:avLst/>
-          </a:prstGeom>
-          <a:noFill/>
-          <a:ln/>
-        </p:spPr>
-        <p:txBody>
-          <a:bodyPr wrap="square" lIns="0" tIns="0" rIns="0" bIns="0" rtlCol="0" anchor="ctr"/>
-          <a:lstStyle/>
-          <a:p>
-            <a:pPr marL="0" indent="0">
-              <a:buNone/>
-            </a:pPr>
-            <a:r>
-              <a:rPr lang="en-US" sz="1100" b="1" dirty="0">
-                <a:solidFill>
-                  <a:srgbClr val="A83A2C"/>
-                </a:solidFill>
-                <a:latin typeface="Arial" pitchFamily="34" charset="0"/>
-                <a:ea typeface="Arial" pitchFamily="34" charset="-122"/>
-                <a:cs typeface="Arial" pitchFamily="34" charset="-120"/>
-              </a:rPr>
-              <a:t>✕</a:t>
-            </a:r>
-            <a:endParaRPr lang="en-US" sz="1100" dirty="0"/>
-          </a:p>
-        </p:txBody>
-      </p:sp>
-      <p:sp>
-        <p:nvSpPr>
-          <p:cNvPr id="15" name="Text 12"/>
-          <p:cNvSpPr txBox="1"/>
-          <p:nvPr/>
-        </p:nvSpPr>
-        <p:spPr>
-          <a:xfrm>
-            <a:off x="804672" y="4754880"/>
-            <a:ext cx="5120640" cy="310896"/>
-          </a:xfrm>
-          <a:prstGeom prst="rect">
-            <a:avLst/>
-          </a:prstGeom>
-          <a:noFill/>
-          <a:ln/>
-        </p:spPr>
-        <p:txBody>
-          <a:bodyPr wrap="square" lIns="0" tIns="0" rIns="0" bIns="0" rtlCol="0" anchor="ctr"/>
-          <a:lstStyle/>
-          <a:p>
-            <a:pPr marL="0" indent="0">
-              <a:buNone/>
-            </a:pPr>
-            <a:r>
-              <a:rPr lang="en-US" sz="1250" dirty="0">
-                <a:solidFill>
-                  <a:srgbClr val="3A3A3A"/>
-                </a:solidFill>
-                <a:latin typeface="Calibri" pitchFamily="34" charset="0"/>
-                <a:ea typeface="Calibri" pitchFamily="34" charset="-122"/>
-                <a:cs typeface="Calibri" pitchFamily="34" charset="-120"/>
-              </a:rPr>
-              <a:t>“python is not recognized” — the PATH box was missed. Re-run the installer and tick it.</a:t>
-            </a:r>
-            <a:endParaRPr lang="en-US" sz="1250" dirty="0"/>
-          </a:p>
-        </p:txBody>
-      </p:sp>
-      <p:sp>
-        <p:nvSpPr>
-          <p:cNvPr id="16" name="Text 13"/>
-          <p:cNvSpPr txBox="1"/>
-          <p:nvPr/>
-        </p:nvSpPr>
-        <p:spPr>
-          <a:xfrm>
-            <a:off x="6108192" y="4754880"/>
-            <a:ext cx="219456" cy="310896"/>
-          </a:xfrm>
-          <a:prstGeom prst="rect">
-            <a:avLst/>
-          </a:prstGeom>
-          <a:noFill/>
-          <a:ln/>
-        </p:spPr>
-        <p:txBody>
-          <a:bodyPr wrap="square" lIns="0" tIns="0" rIns="0" bIns="0" rtlCol="0" anchor="ctr"/>
-          <a:lstStyle/>
-          <a:p>
-            <a:pPr marL="0" indent="0">
-              <a:buNone/>
-            </a:pPr>
-            <a:r>
-              <a:rPr lang="en-US" sz="1100" b="1" dirty="0">
-                <a:solidFill>
-                  <a:srgbClr val="A83A2C"/>
-                </a:solidFill>
-                <a:latin typeface="Arial" pitchFamily="34" charset="0"/>
-                <a:ea typeface="Arial" pitchFamily="34" charset="-122"/>
-                <a:cs typeface="Arial" pitchFamily="34" charset="-120"/>
-              </a:rPr>
-              <a:t>✕</a:t>
-            </a:r>
-            <a:endParaRPr lang="en-US" sz="1100" dirty="0"/>
-          </a:p>
-        </p:txBody>
-      </p:sp>
-      <p:sp>
-        <p:nvSpPr>
-          <p:cNvPr id="17" name="Text 14"/>
-          <p:cNvSpPr txBox="1"/>
-          <p:nvPr/>
-        </p:nvSpPr>
-        <p:spPr>
-          <a:xfrm>
-            <a:off x="6345936" y="4754880"/>
-            <a:ext cx="5120640" cy="310896"/>
-          </a:xfrm>
-          <a:prstGeom prst="rect">
-            <a:avLst/>
-          </a:prstGeom>
-          <a:noFill/>
-          <a:ln/>
-        </p:spPr>
-        <p:txBody>
-          <a:bodyPr wrap="square" lIns="0" tIns="0" rIns="0" bIns="0" rtlCol="0" anchor="ctr"/>
-          <a:lstStyle/>
-          <a:p>
-            <a:pPr marL="0" indent="0">
-              <a:buNone/>
-            </a:pPr>
-            <a:r>
-              <a:rPr lang="en-US" sz="1250" dirty="0">
-                <a:solidFill>
-                  <a:srgbClr val="3A3A3A"/>
-                </a:solidFill>
-                <a:latin typeface="Calibri" pitchFamily="34" charset="0"/>
-                <a:ea typeface="Calibri" pitchFamily="34" charset="-122"/>
-                <a:cs typeface="Calibri" pitchFamily="34" charset="-120"/>
-              </a:rPr>
-              <a:t>The Microsoft Store opens instead — same cause, same fix.</a:t>
-            </a:r>
-            <a:endParaRPr lang="en-US" sz="1250" dirty="0"/>
-          </a:p>
-        </p:txBody>
-      </p:sp>
-      <p:sp>
-        <p:nvSpPr>
-          <p:cNvPr id="18" name="Text 15"/>
-          <p:cNvSpPr txBox="1"/>
-          <p:nvPr/>
-        </p:nvSpPr>
-        <p:spPr>
-          <a:xfrm>
-            <a:off x="566928" y="5175504"/>
-            <a:ext cx="219456" cy="310896"/>
-          </a:xfrm>
-          <a:prstGeom prst="rect">
-            <a:avLst/>
-          </a:prstGeom>
-          <a:noFill/>
-          <a:ln/>
-        </p:spPr>
-        <p:txBody>
-          <a:bodyPr wrap="square" lIns="0" tIns="0" rIns="0" bIns="0" rtlCol="0" anchor="ctr"/>
-          <a:lstStyle/>
-          <a:p>
-            <a:pPr marL="0" indent="0">
-              <a:buNone/>
-            </a:pPr>
-            <a:r>
-              <a:rPr lang="en-US" sz="1100" b="1" dirty="0">
-                <a:solidFill>
-                  <a:srgbClr val="A83A2C"/>
-                </a:solidFill>
-                <a:latin typeface="Arial" pitchFamily="34" charset="0"/>
-                <a:ea typeface="Arial" pitchFamily="34" charset="-122"/>
-                <a:cs typeface="Arial" pitchFamily="34" charset="-120"/>
-              </a:rPr>
-              <a:t>✕</a:t>
-            </a:r>
-            <a:endParaRPr lang="en-US" sz="1100" dirty="0"/>
-          </a:p>
-        </p:txBody>
-      </p:sp>
-      <p:sp>
-        <p:nvSpPr>
-          <p:cNvPr id="19" name="Text 16"/>
-          <p:cNvSpPr txBox="1"/>
-          <p:nvPr/>
-        </p:nvSpPr>
-        <p:spPr>
-          <a:xfrm>
-            <a:off x="804672" y="5175504"/>
-            <a:ext cx="5120640" cy="310896"/>
-          </a:xfrm>
-          <a:prstGeom prst="rect">
-            <a:avLst/>
-          </a:prstGeom>
-          <a:noFill/>
-          <a:ln/>
-        </p:spPr>
-        <p:txBody>
-          <a:bodyPr wrap="square" lIns="0" tIns="0" rIns="0" bIns="0" rtlCol="0" anchor="ctr"/>
-          <a:lstStyle/>
-          <a:p>
-            <a:pPr marL="0" indent="0">
-              <a:buNone/>
-            </a:pPr>
-            <a:r>
-              <a:rPr lang="en-US" sz="1250" dirty="0">
-                <a:solidFill>
-                  <a:srgbClr val="3A3A3A"/>
-                </a:solidFill>
-                <a:latin typeface="Calibri" pitchFamily="34" charset="0"/>
-                <a:ea typeface="Calibri" pitchFamily="34" charset="-122"/>
-                <a:cs typeface="Calibri" pitchFamily="34" charset="-120"/>
-              </a:rPr>
-              <a:t>“command not found” on a Mac — you typed python. Try python3.</a:t>
-            </a:r>
-            <a:endParaRPr lang="en-US" sz="1250" dirty="0"/>
-          </a:p>
-        </p:txBody>
-      </p:sp>
-      <p:sp>
-        <p:nvSpPr>
-          <p:cNvPr id="20" name="Text 17"/>
-          <p:cNvSpPr txBox="1"/>
-          <p:nvPr/>
-        </p:nvSpPr>
-        <p:spPr>
-          <a:xfrm>
-            <a:off x="6108192" y="5175504"/>
-            <a:ext cx="219456" cy="310896"/>
-          </a:xfrm>
-          <a:prstGeom prst="rect">
-            <a:avLst/>
-          </a:prstGeom>
-          <a:noFill/>
-          <a:ln/>
-        </p:spPr>
-        <p:txBody>
-          <a:bodyPr wrap="square" lIns="0" tIns="0" rIns="0" bIns="0" rtlCol="0" anchor="ctr"/>
-          <a:lstStyle/>
-          <a:p>
-            <a:pPr marL="0" indent="0">
-              <a:buNone/>
-            </a:pPr>
-            <a:r>
-              <a:rPr lang="en-US" sz="1100" b="1" dirty="0">
-                <a:solidFill>
-                  <a:srgbClr val="A83A2C"/>
-                </a:solidFill>
-                <a:latin typeface="Arial" pitchFamily="34" charset="0"/>
-                <a:ea typeface="Arial" pitchFamily="34" charset="-122"/>
-                <a:cs typeface="Arial" pitchFamily="34" charset="-120"/>
-              </a:rPr>
-              <a:t>✕</a:t>
-            </a:r>
-            <a:endParaRPr lang="en-US" sz="1100" dirty="0"/>
-          </a:p>
-        </p:txBody>
-      </p:sp>
-      <p:sp>
-        <p:nvSpPr>
-          <p:cNvPr id="21" name="Text 18"/>
-          <p:cNvSpPr txBox="1"/>
-          <p:nvPr/>
-        </p:nvSpPr>
-        <p:spPr>
-          <a:xfrm>
-            <a:off x="6345936" y="5175504"/>
-            <a:ext cx="5120640" cy="310896"/>
-          </a:xfrm>
-          <a:prstGeom prst="rect">
-            <a:avLst/>
-          </a:prstGeom>
-          <a:noFill/>
-          <a:ln/>
-        </p:spPr>
-        <p:txBody>
-          <a:bodyPr wrap="square" lIns="0" tIns="0" rIns="0" bIns="0" rtlCol="0" anchor="ctr"/>
-          <a:lstStyle/>
-          <a:p>
-            <a:pPr marL="0" indent="0">
-              <a:buNone/>
-            </a:pPr>
-            <a:r>
-              <a:rPr lang="en-US" sz="1250" dirty="0">
-                <a:solidFill>
-                  <a:srgbClr val="3A3A3A"/>
-                </a:solidFill>
-                <a:latin typeface="Calibri" pitchFamily="34" charset="0"/>
-                <a:ea typeface="Calibri" pitchFamily="34" charset="-122"/>
-                <a:cs typeface="Calibri" pitchFamily="34" charset="-120"/>
-              </a:rPr>
-              <a:t>Python 2.7 prints on an older Mac — that is the built-in one, not yours. Use python3.</a:t>
-            </a:r>
-            <a:endParaRPr lang="en-US" sz="1250" dirty="0"/>
-          </a:p>
-        </p:txBody>
-      </p:sp>
-      <p:sp>
-        <p:nvSpPr>
-          <p:cNvPr id="22" name="Text 19"/>
-          <p:cNvSpPr txBox="1"/>
-          <p:nvPr/>
-        </p:nvSpPr>
-        <p:spPr>
-          <a:xfrm>
-            <a:off x="566928" y="5815584"/>
-            <a:ext cx="11057839" cy="329184"/>
-          </a:xfrm>
-          <a:prstGeom prst="rect">
-            <a:avLst/>
-          </a:prstGeom>
-          <a:noFill/>
-          <a:ln/>
-        </p:spPr>
-        <p:txBody>
-          <a:bodyPr wrap="square" lIns="0" tIns="0" rIns="0" bIns="0" rtlCol="0" anchor="ctr"/>
-          <a:lstStyle/>
-          <a:p>
-            <a:pPr marL="0" indent="0">
-              <a:buNone/>
-            </a:pPr>
-            <a:r>
-              <a:rPr lang="en-US" sz="1250" i="1" dirty="0">
-                <a:solidFill>
-                  <a:srgbClr val="7A7A7A"/>
-                </a:solidFill>
-                <a:latin typeface="Calibri" pitchFamily="34" charset="0"/>
-                <a:ea typeface="Calibri" pitchFamily="34" charset="-122"/>
-                <a:cs typeface="Calibri" pitchFamily="34" charset="-120"/>
-              </a:rPr>
-              <a:t>Hand up the moment your screen differs from this. Do not go quiet and fall behind — that is how people leave today without a working laptop.</a:t>
-            </a:r>
-            <a:endParaRPr lang="en-US" sz="1250" dirty="0"/>
-          </a:p>
-        </p:txBody>
-      </p:sp>
-    </p:spTree>
-  </p:cSld>
-  <p:clrMapOvr>
-    <a:masterClrMapping/>
-  </p:clrMapOvr>
-</p:sld>
-</file>
-
 <file path=ppt/theme/theme1.xml><?xml version="1.0" encoding="utf-8"?>
 <a:theme xmlns:a="http://schemas.openxmlformats.org/drawingml/2006/main" name="Office Theme">
   <a:themeElements>

</xml_diff>